<commit_message>
fig_mmacos: widen the canvas so every entry sits inside its column
Co-Authored-By: Claude Fable 5 <noreply@anthropic.com>
</commit_message>
<xml_diff>
--- a/demo_session/deck_keysight.pptx
+++ b/demo_session/deck_keysight.pptx
@@ -14304,8 +14304,8 @@
         </p:blipFill>
         <p:spPr>
           <a:xfrm>
-            <a:off x="1283341" y="1298448"/>
-            <a:ext cx="9625012" cy="4297680"/>
+            <a:off x="463282" y="1298448"/>
+            <a:ext cx="11265130" cy="4297680"/>
           </a:xfrm>
           <a:prstGeom prst="rect">
             <a:avLst/>

</xml_diff>

<commit_message>
slide 5 table: ladder-steps row + natural width for narrow label columns
The steps row names what each reported number is (on-axis -> offset,
frozen -> re-solved -> tilt/decenter; challenge 3 adds + clearance
constraints -> + Zernike freedom), aligned 1:1 with the reported
ladder.  Builder: a naturally-narrow column beside paragraph cells now
gets its full unwrapped width when there is room (proportional shares
had squeezed 'reproduction' into wrapping); long-text columns absorb
the difference, proportional remains the fallback.  Sandbox master
copy synced.

Co-Authored-By: Claude Fable 5 <noreply@anthropic.com>
</commit_message>
<xml_diff>
--- a/demo_session/deck_keysight.pptx
+++ b/demo_session/deck_keysight.pptx
@@ -4403,7 +4403,7 @@
         </p:nvGraphicFramePr>
         <p:xfrm>
           <a:off x="411480" y="3200399"/>
-          <a:ext cx="5806438" cy="1400175"/>
+          <a:ext cx="5806439" cy="1400175"/>
         </p:xfrm>
         <a:graphic>
           <a:graphicData uri="http://schemas.openxmlformats.org/drawingml/2006/table">
@@ -4412,9 +4412,9 @@
                 <a:tableStyleId>{5C22544A-7EE6-4342-B048-85BDC9FD1C3A}</a:tableStyleId>
               </a:tblPr>
               <a:tblGrid>
-                <a:gridCol w="2835703"/>
-                <a:gridCol w="1080267"/>
-                <a:gridCol w="1890468"/>
+                <a:gridCol w="3915663"/>
+                <a:gridCol w="727456"/>
+                <a:gridCol w="1163320"/>
               </a:tblGrid>
               <a:tr h="280035">
                 <a:tc>
@@ -4989,7 +4989,7 @@
         </p:nvGraphicFramePr>
         <p:xfrm>
           <a:off x="411480" y="1298448"/>
-          <a:ext cx="5806438" cy="1400175"/>
+          <a:ext cx="5806439" cy="1400175"/>
         </p:xfrm>
         <a:graphic>
           <a:graphicData uri="http://schemas.openxmlformats.org/drawingml/2006/table">
@@ -4998,9 +4998,9 @@
                 <a:tableStyleId>{5C22544A-7EE6-4342-B048-85BDC9FD1C3A}</a:tableStyleId>
               </a:tblPr>
               <a:tblGrid>
-                <a:gridCol w="3548380"/>
-                <a:gridCol w="967739"/>
-                <a:gridCol w="1290319"/>
+                <a:gridCol w="3988307"/>
+                <a:gridCol w="800100"/>
+                <a:gridCol w="1018032"/>
               </a:tblGrid>
               <a:tr h="280035">
                 <a:tc>
@@ -6133,7 +6133,7 @@
         </p:nvGraphicFramePr>
         <p:xfrm>
           <a:off x="411480" y="4133087"/>
-          <a:ext cx="5806438" cy="1680210"/>
+          <a:ext cx="5806439" cy="1680210"/>
         </p:xfrm>
         <a:graphic>
           <a:graphicData uri="http://schemas.openxmlformats.org/drawingml/2006/table">
@@ -6142,9 +6142,9 @@
                 <a:tableStyleId>{5C22544A-7EE6-4342-B048-85BDC9FD1C3A}</a:tableStyleId>
               </a:tblPr>
               <a:tblGrid>
-                <a:gridCol w="2852286"/>
-                <a:gridCol w="1018673"/>
-                <a:gridCol w="1935479"/>
+                <a:gridCol w="2939223"/>
+                <a:gridCol w="872744"/>
+                <a:gridCol w="1994472"/>
               </a:tblGrid>
               <a:tr h="280035">
                 <a:tc>
@@ -7248,7 +7248,7 @@
         </p:nvGraphicFramePr>
         <p:xfrm>
           <a:off x="411480" y="2804160"/>
-          <a:ext cx="5806438" cy="1680210"/>
+          <a:ext cx="5806439" cy="1680210"/>
         </p:xfrm>
         <a:graphic>
           <a:graphicData uri="http://schemas.openxmlformats.org/drawingml/2006/table">
@@ -7257,9 +7257,9 @@
                 <a:tableStyleId>{5C22544A-7EE6-4342-B048-85BDC9FD1C3A}</a:tableStyleId>
               </a:tblPr>
               <a:tblGrid>
-                <a:gridCol w="3177108"/>
-                <a:gridCol w="1533776"/>
-                <a:gridCol w="1095554"/>
+                <a:gridCol w="3770375"/>
+                <a:gridCol w="1163320"/>
+                <a:gridCol w="872744"/>
               </a:tblGrid>
               <a:tr h="280035">
                 <a:tc>
@@ -11227,9 +11227,9 @@
                 <a:tableStyleId>{5C22544A-7EE6-4342-B048-85BDC9FD1C3A}</a:tableStyleId>
               </a:tblPr>
               <a:tblGrid>
-                <a:gridCol w="1815176"/>
-                <a:gridCol w="3343745"/>
-                <a:gridCol w="6209813"/>
+                <a:gridCol w="1526540"/>
+                <a:gridCol w="3444768"/>
+                <a:gridCol w="6397426"/>
               </a:tblGrid>
               <a:tr h="280035">
                 <a:tc>
@@ -14478,7 +14478,7 @@
         </p:nvGraphicFramePr>
         <p:xfrm>
           <a:off x="411480" y="1298448"/>
-          <a:ext cx="11368733" cy="2063115"/>
+          <a:ext cx="11368733" cy="1965960"/>
         </p:xfrm>
         <a:graphic>
           <a:graphicData uri="http://schemas.openxmlformats.org/drawingml/2006/table">
@@ -14487,10 +14487,10 @@
                 <a:tableStyleId>{5C22544A-7EE6-4342-B048-85BDC9FD1C3A}</a:tableStyleId>
               </a:tblPr>
               <a:tblGrid>
-                <a:gridCol w="854127"/>
-                <a:gridCol w="2591836"/>
-                <a:gridCol w="3917206"/>
-                <a:gridCol w="4005564"/>
+                <a:gridCol w="2252980"/>
+                <a:gridCol w="2247020"/>
+                <a:gridCol w="3396065"/>
+                <a:gridCol w="3472668"/>
               </a:tblGrid>
               <a:tr h="280035">
                 <a:tc>
@@ -14662,7 +14662,7 @@
                   </a:tcPr>
                 </a:tc>
               </a:tr>
-              <a:tr h="657225">
+              <a:tr h="468630">
                 <a:tc>
                   <a:txBody>
                     <a:bodyPr wrap="square"/>
@@ -14675,7 +14675,7 @@
                           </a:solidFill>
                           <a:latin typeface="Arial"/>
                         </a:rPr>
-                        <a:t>reported ladder (max RMS WFE)</a:t>
+                        <a:t>the ladder, in steps</a:t>
                       </a:r>
                     </a:p>
                   </a:txBody>
@@ -14697,7 +14697,7 @@
                           </a:solidFill>
                           <a:latin typeface="Arial"/>
                         </a:rPr>
-                        <a:t>2 → 375 → 92 → 40 nm</a:t>
+                        <a:t>on-axis → offset, frozen → re-solved → tilt/decenter</a:t>
                       </a:r>
                     </a:p>
                   </a:txBody>
@@ -14719,7 +14719,7 @@
                           </a:solidFill>
                           <a:latin typeface="Arial"/>
                         </a:rPr>
-                        <a:t>15 → 430 → 160 → 119 nm</a:t>
+                        <a:t>on-axis → offset, frozen → re-solved → tilt/decenter</a:t>
                       </a:r>
                     </a:p>
                   </a:txBody>
@@ -14741,7 +14741,7 @@
                           </a:solidFill>
                           <a:latin typeface="Arial"/>
                         </a:rPr>
-                        <a:t>159 → 8810 → 168 → 117 → 53 nm</a:t>
+                        <a:t>on-axis → offset, frozen → re-solved → + clearance constraints → + Zernike freedom</a:t>
                       </a:r>
                     </a:p>
                   </a:txBody>
@@ -14752,7 +14752,7 @@
                   </a:tcPr>
                 </a:tc>
               </a:tr>
-              <a:tr h="468630">
+              <a:tr h="280035">
                 <a:tc>
                   <a:txBody>
                     <a:bodyPr wrap="square"/>
@@ -14765,7 +14765,7 @@
                           </a:solidFill>
                           <a:latin typeface="Arial"/>
                         </a:rPr>
-                        <a:t>reproduction</a:t>
+                        <a:t>reported ladder (max RMS WFE)</a:t>
                       </a:r>
                     </a:p>
                   </a:txBody>
@@ -14787,7 +14787,7 @@
                           </a:solidFill>
                           <a:latin typeface="Arial"/>
                         </a:rPr>
-                        <a:t>0.83–1.11×</a:t>
+                        <a:t>2 → 375 → 92 → 40 nm</a:t>
                       </a:r>
                     </a:p>
                   </a:txBody>
@@ -14809,7 +14809,7 @@
                           </a:solidFill>
                           <a:latin typeface="Arial"/>
                         </a:rPr>
-                        <a:t>0.95–1.02×</a:t>
+                        <a:t>15 → 430 → 160 → 119 nm</a:t>
                       </a:r>
                     </a:p>
                   </a:txBody>
@@ -14831,7 +14831,7 @@
                           </a:solidFill>
                           <a:latin typeface="Arial"/>
                         </a:rPr>
-                        <a:t>0.99–1.10× (all five steps)</a:t>
+                        <a:t>159 → 8810 → 168 → 117 → 53 nm</a:t>
                       </a:r>
                     </a:p>
                   </a:txBody>
@@ -14842,6 +14842,96 @@
                   </a:tcPr>
                 </a:tc>
               </a:tr>
+              <a:tr h="280035">
+                <a:tc>
+                  <a:txBody>
+                    <a:bodyPr wrap="square"/>
+                    <a:lstStyle/>
+                    <a:p>
+                      <a:r>
+                        <a:rPr sz="1100" b="0">
+                          <a:solidFill>
+                            <a:srgbClr val="282828"/>
+                          </a:solidFill>
+                          <a:latin typeface="Arial"/>
+                        </a:rPr>
+                        <a:t>reproduction</a:t>
+                      </a:r>
+                    </a:p>
+                  </a:txBody>
+                  <a:tcPr marL="54864" marR="54864" marT="18288" marB="18288">
+                    <a:solidFill>
+                      <a:srgbClr val="ECF1F6"/>
+                    </a:solidFill>
+                  </a:tcPr>
+                </a:tc>
+                <a:tc>
+                  <a:txBody>
+                    <a:bodyPr wrap="square"/>
+                    <a:lstStyle/>
+                    <a:p>
+                      <a:r>
+                        <a:rPr sz="1100" b="0">
+                          <a:solidFill>
+                            <a:srgbClr val="282828"/>
+                          </a:solidFill>
+                          <a:latin typeface="Arial"/>
+                        </a:rPr>
+                        <a:t>0.83–1.11×</a:t>
+                      </a:r>
+                    </a:p>
+                  </a:txBody>
+                  <a:tcPr marL="54864" marR="54864" marT="18288" marB="18288">
+                    <a:solidFill>
+                      <a:srgbClr val="ECF1F6"/>
+                    </a:solidFill>
+                  </a:tcPr>
+                </a:tc>
+                <a:tc>
+                  <a:txBody>
+                    <a:bodyPr wrap="square"/>
+                    <a:lstStyle/>
+                    <a:p>
+                      <a:r>
+                        <a:rPr sz="1100" b="0">
+                          <a:solidFill>
+                            <a:srgbClr val="282828"/>
+                          </a:solidFill>
+                          <a:latin typeface="Arial"/>
+                        </a:rPr>
+                        <a:t>0.95–1.02×</a:t>
+                      </a:r>
+                    </a:p>
+                  </a:txBody>
+                  <a:tcPr marL="54864" marR="54864" marT="18288" marB="18288">
+                    <a:solidFill>
+                      <a:srgbClr val="ECF1F6"/>
+                    </a:solidFill>
+                  </a:tcPr>
+                </a:tc>
+                <a:tc>
+                  <a:txBody>
+                    <a:bodyPr wrap="square"/>
+                    <a:lstStyle/>
+                    <a:p>
+                      <a:r>
+                        <a:rPr sz="1100" b="0">
+                          <a:solidFill>
+                            <a:srgbClr val="282828"/>
+                          </a:solidFill>
+                          <a:latin typeface="Arial"/>
+                        </a:rPr>
+                        <a:t>0.99–1.10× (all five steps)</a:t>
+                      </a:r>
+                    </a:p>
+                  </a:txBody>
+                  <a:tcPr marL="54864" marR="54864" marT="18288" marB="18288">
+                    <a:solidFill>
+                      <a:srgbClr val="ECF1F6"/>
+                    </a:solidFill>
+                  </a:tcPr>
+                </a:tc>
+              </a:tr>
             </a:tbl>
           </a:graphicData>
         </a:graphic>
@@ -14854,7 +14944,7 @@
         </p:nvSpPr>
         <p:spPr>
           <a:xfrm>
-            <a:off x="411480" y="3507867"/>
+            <a:off x="411480" y="3410712"/>
             <a:ext cx="11368735" cy="274320"/>
           </a:xfrm>
           <a:prstGeom prst="rect">

</xml_diff>

<commit_message>
deck: recover Dave's pptx edit pass + features row + gate sequence
Recovered from deck_keysight_edit.pptx by shape-level diff against its
baseline build: three wording edits (Hubble 'correctly diagnosed',
'Physics lives in the engine', the challenge-3 'moving a field' title)
fold back verbatim; the font intent (full-width bullets 12->15 pt,
sub-bullets 10.5->13) becomes a builder rule -- columns keep 12 pt,
matching what the pass left alone.  Save-time auto-fit geometry noise
identified and ignored.  Plus this round's content: the 'feature it
proved' table row + reusable-template bullet (slide 5), and the
five-gate sequence with its negative control (slide 6).

Co-Authored-By: Claude Fable 5 <noreply@anthropic.com>
</commit_message>
<xml_diff>
--- a/demo_session/deck_keysight.pptx
+++ b/demo_session/deck_keysight.pptx
@@ -8642,7 +8642,7 @@
               </a:spcAft>
             </a:pPr>
             <a:r>
-              <a:rPr sz="1200" b="0">
+              <a:rPr sz="1500" b="0">
                 <a:solidFill>
                   <a:srgbClr val="282828"/>
                 </a:solidFill>
@@ -8669,7 +8669,7 @@
         </p:blipFill>
         <p:spPr>
           <a:xfrm>
-            <a:off x="1328979" y="2069591"/>
+            <a:off x="1328979" y="2218182"/>
             <a:ext cx="3971440" cy="1343152"/>
           </a:xfrm>
           <a:prstGeom prst="rect">
@@ -8685,7 +8685,7 @@
         </p:nvSpPr>
         <p:spPr>
           <a:xfrm>
-            <a:off x="411480" y="3431032"/>
+            <a:off x="411480" y="3579622"/>
             <a:ext cx="5806440" cy="394208"/>
           </a:xfrm>
           <a:prstGeom prst="rect">
@@ -8732,7 +8732,7 @@
         </p:blipFill>
         <p:spPr>
           <a:xfrm>
-            <a:off x="7536686" y="2069591"/>
+            <a:off x="7536686" y="2218182"/>
             <a:ext cx="3123186" cy="2257552"/>
           </a:xfrm>
           <a:prstGeom prst="rect">
@@ -8748,7 +8748,7 @@
         </p:nvSpPr>
         <p:spPr>
           <a:xfrm>
-            <a:off x="6400800" y="4345431"/>
+            <a:off x="6400800" y="4494022"/>
             <a:ext cx="5394960" cy="394208"/>
           </a:xfrm>
           <a:prstGeom prst="rect">
@@ -8787,7 +8787,7 @@
         </p:nvSpPr>
         <p:spPr>
           <a:xfrm>
-            <a:off x="6400800" y="4776216"/>
+            <a:off x="6400800" y="4924806"/>
             <a:ext cx="5394960" cy="274320"/>
           </a:xfrm>
           <a:prstGeom prst="rect">
@@ -8963,7 +8963,7 @@
               </a:spcAft>
             </a:pPr>
             <a:r>
-              <a:rPr sz="1200" b="0">
+              <a:rPr sz="1500" b="0">
                 <a:solidFill>
                   <a:srgbClr val="282828"/>
                 </a:solidFill>
@@ -8979,7 +8979,7 @@
               </a:spcAft>
             </a:pPr>
             <a:r>
-              <a:rPr sz="1050" b="0">
+              <a:rPr sz="1300" b="0">
                 <a:solidFill>
                   <a:srgbClr val="6E6E6E"/>
                 </a:solidFill>
@@ -8995,13 +8995,13 @@
               </a:spcAft>
             </a:pPr>
             <a:r>
-              <a:rPr sz="1200" b="0">
+              <a:rPr sz="1500" b="0">
                 <a:solidFill>
                   <a:srgbClr val="282828"/>
                 </a:solidFill>
                 <a:latin typeface="Arial"/>
               </a:rPr>
-              <a:t>•  1991: Hubble — the prescription recovery that diagnosed the aberration from flight imagery</a:t>
+              <a:t>•  1991: Hubble — prescription recovery correctly diagnosed the aberration from flight imagery</a:t>
             </a:r>
           </a:p>
           <a:p>
@@ -9011,7 +9011,7 @@
               </a:spcAft>
             </a:pPr>
             <a:r>
-              <a:rPr sz="1050" b="0">
+              <a:rPr sz="1300" b="0">
                 <a:solidFill>
                   <a:srgbClr val="6E6E6E"/>
                 </a:solidFill>
@@ -9027,7 +9027,7 @@
               </a:spcAft>
             </a:pPr>
             <a:r>
-              <a:rPr sz="1200" b="0">
+              <a:rPr sz="1500" b="0">
                 <a:solidFill>
                   <a:srgbClr val="282828"/>
                 </a:solidFill>
@@ -9043,7 +9043,7 @@
               </a:spcAft>
             </a:pPr>
             <a:r>
-              <a:rPr sz="1050" b="0">
+              <a:rPr sz="1300" b="0">
                 <a:solidFill>
                   <a:srgbClr val="6E6E6E"/>
                 </a:solidFill>
@@ -9059,7 +9059,7 @@
               </a:spcAft>
             </a:pPr>
             <a:r>
-              <a:rPr sz="1200" b="0">
+              <a:rPr sz="1500" b="0">
                 <a:solidFill>
                   <a:srgbClr val="282828"/>
                 </a:solidFill>
@@ -9075,7 +9075,7 @@
               </a:spcAft>
             </a:pPr>
             <a:r>
-              <a:rPr sz="1050" b="0">
+              <a:rPr sz="1300" b="0">
                 <a:solidFill>
                   <a:srgbClr val="6E6E6E"/>
                 </a:solidFill>
@@ -9091,7 +9091,7 @@
               </a:spcAft>
             </a:pPr>
             <a:r>
-              <a:rPr sz="1200" b="0">
+              <a:rPr sz="1500" b="0">
                 <a:solidFill>
                   <a:srgbClr val="282828"/>
                 </a:solidFill>
@@ -10188,7 +10188,7 @@
               </a:spcAft>
             </a:pPr>
             <a:r>
-              <a:rPr sz="1200" b="0">
+              <a:rPr sz="1500" b="0">
                 <a:solidFill>
                   <a:srgbClr val="282828"/>
                 </a:solidFill>
@@ -10204,7 +10204,7 @@
               </a:spcAft>
             </a:pPr>
             <a:r>
-              <a:rPr sz="1200" b="0">
+              <a:rPr sz="1500" b="0">
                 <a:solidFill>
                   <a:srgbClr val="282828"/>
                 </a:solidFill>
@@ -10220,7 +10220,7 @@
               </a:spcAft>
             </a:pPr>
             <a:r>
-              <a:rPr sz="1200" b="0">
+              <a:rPr sz="1500" b="0">
                 <a:solidFill>
                   <a:srgbClr val="282828"/>
                 </a:solidFill>
@@ -10239,7 +10239,7 @@
         </p:nvSpPr>
         <p:spPr>
           <a:xfrm>
-            <a:off x="411480" y="2944368"/>
+            <a:off x="411480" y="3241547"/>
             <a:ext cx="11368735" cy="274320"/>
           </a:xfrm>
           <a:prstGeom prst="rect">
@@ -10415,7 +10415,7 @@
               </a:spcAft>
             </a:pPr>
             <a:r>
-              <a:rPr sz="1200" b="0">
+              <a:rPr sz="1500" b="0">
                 <a:solidFill>
                   <a:srgbClr val="282828"/>
                 </a:solidFill>
@@ -10431,7 +10431,7 @@
               </a:spcAft>
             </a:pPr>
             <a:r>
-              <a:rPr sz="1200" b="0">
+              <a:rPr sz="1500" b="0">
                 <a:solidFill>
                   <a:srgbClr val="282828"/>
                 </a:solidFill>
@@ -10447,7 +10447,7 @@
               </a:spcAft>
             </a:pPr>
             <a:r>
-              <a:rPr sz="1200" b="0">
+              <a:rPr sz="1500" b="0">
                 <a:solidFill>
                   <a:srgbClr val="282828"/>
                 </a:solidFill>
@@ -10466,7 +10466,7 @@
         </p:nvSpPr>
         <p:spPr>
           <a:xfrm>
-            <a:off x="411480" y="2548128"/>
+            <a:off x="411480" y="2993898"/>
             <a:ext cx="11368735" cy="274320"/>
           </a:xfrm>
           <a:prstGeom prst="rect">
@@ -10743,7 +10743,7 @@
               </a:spcAft>
             </a:pPr>
             <a:r>
-              <a:rPr sz="1200" b="0">
+              <a:rPr sz="1500" b="0">
                 <a:solidFill>
                   <a:srgbClr val="282828"/>
                 </a:solidFill>
@@ -10759,7 +10759,7 @@
               </a:spcAft>
             </a:pPr>
             <a:r>
-              <a:rPr sz="1200" b="0">
+              <a:rPr sz="1500" b="0">
                 <a:solidFill>
                   <a:srgbClr val="282828"/>
                 </a:solidFill>
@@ -10775,7 +10775,7 @@
               </a:spcAft>
             </a:pPr>
             <a:r>
-              <a:rPr sz="1200" b="0">
+              <a:rPr sz="1500" b="0">
                 <a:solidFill>
                   <a:srgbClr val="282828"/>
                 </a:solidFill>
@@ -10794,7 +10794,7 @@
         </p:nvSpPr>
         <p:spPr>
           <a:xfrm>
-            <a:off x="411480" y="2944368"/>
+            <a:off x="411480" y="3241547"/>
             <a:ext cx="11368735" cy="274320"/>
           </a:xfrm>
           <a:prstGeom prst="rect">
@@ -11671,7 +11671,7 @@
               </a:spcAft>
             </a:pPr>
             <a:r>
-              <a:rPr sz="1200" b="0">
+              <a:rPr sz="1500" b="0">
                 <a:solidFill>
                   <a:srgbClr val="282828"/>
                 </a:solidFill>
@@ -11690,7 +11690,7 @@
         </p:nvSpPr>
         <p:spPr>
           <a:xfrm>
-            <a:off x="411480" y="3499866"/>
+            <a:off x="411480" y="3797046"/>
             <a:ext cx="11368735" cy="274320"/>
           </a:xfrm>
           <a:prstGeom prst="rect">
@@ -12521,7 +12521,7 @@
               </a:spcAft>
             </a:pPr>
             <a:r>
-              <a:rPr sz="1200" b="0">
+              <a:rPr sz="1500" b="0">
                 <a:solidFill>
                   <a:srgbClr val="282828"/>
                 </a:solidFill>
@@ -12537,7 +12537,7 @@
               </a:spcAft>
             </a:pPr>
             <a:r>
-              <a:rPr sz="1200" b="0">
+              <a:rPr sz="1500" b="0">
                 <a:solidFill>
                   <a:srgbClr val="282828"/>
                 </a:solidFill>
@@ -12556,7 +12556,7 @@
         </p:nvSpPr>
         <p:spPr>
           <a:xfrm>
-            <a:off x="411480" y="3476244"/>
+            <a:off x="411480" y="3624834"/>
             <a:ext cx="11368735" cy="274320"/>
           </a:xfrm>
           <a:prstGeom prst="rect">
@@ -12756,13 +12756,13 @@
               </a:spcAft>
             </a:pPr>
             <a:r>
-              <a:rPr sz="1200" b="0">
+              <a:rPr sz="1500" b="0">
                 <a:solidFill>
                   <a:srgbClr val="282828"/>
                 </a:solidFill>
                 <a:latin typeface="Arial"/>
               </a:rPr>
-              <a:t>•  A capability added to the engine is everywhere at once:</a:t>
+              <a:t>•  Physics lives in the engine: a capability added there is everywhere at once</a:t>
             </a:r>
           </a:p>
           <a:p>
@@ -12772,7 +12772,7 @@
               </a:spcAft>
             </a:pPr>
             <a:r>
-              <a:rPr sz="1200" b="0">
+              <a:rPr sz="1500" b="0">
                 <a:solidFill>
                   <a:srgbClr val="282828"/>
                 </a:solidFill>
@@ -12788,7 +12788,7 @@
               </a:spcAft>
             </a:pPr>
             <a:r>
-              <a:rPr sz="1200" b="0">
+              <a:rPr sz="1500" b="0">
                 <a:solidFill>
                   <a:srgbClr val="282828"/>
                 </a:solidFill>
@@ -12804,7 +12804,7 @@
               </a:spcAft>
             </a:pPr>
             <a:r>
-              <a:rPr sz="1200" b="0">
+              <a:rPr sz="1500" b="0">
                 <a:solidFill>
                   <a:srgbClr val="282828"/>
                 </a:solidFill>
@@ -12820,13 +12820,13 @@
               </a:spcAft>
             </a:pPr>
             <a:r>
-              <a:rPr sz="1200" b="0">
+              <a:rPr sz="1500" b="0">
                 <a:solidFill>
                   <a:srgbClr val="282828"/>
                 </a:solidFill>
                 <a:latin typeface="Arial"/>
               </a:rPr>
-              <a:t>•  One source tree: github nasa-jpl/macos and MACOS_resources contain it all.</a:t>
+              <a:t>•  One source tree: github nasa-jpl/macos and /MACOS_resources contain it all.</a:t>
             </a:r>
           </a:p>
         </p:txBody>
@@ -13995,7 +13995,7 @@
               </a:spcAft>
             </a:pPr>
             <a:r>
-              <a:rPr sz="1200" b="0">
+              <a:rPr sz="1500" b="0">
                 <a:solidFill>
                   <a:srgbClr val="282828"/>
                 </a:solidFill>
@@ -14022,7 +14022,7 @@
         </p:blipFill>
         <p:spPr>
           <a:xfrm>
-            <a:off x="1466756" y="1871472"/>
+            <a:off x="1466756" y="2218182"/>
             <a:ext cx="3695887" cy="2714752"/>
           </a:xfrm>
           <a:prstGeom prst="rect">
@@ -14038,7 +14038,7 @@
         </p:nvSpPr>
         <p:spPr>
           <a:xfrm>
-            <a:off x="411480" y="4604512"/>
+            <a:off x="411480" y="4951222"/>
             <a:ext cx="5806440" cy="394208"/>
           </a:xfrm>
           <a:prstGeom prst="rect">
@@ -14085,7 +14085,7 @@
         </p:blipFill>
         <p:spPr>
           <a:xfrm>
-            <a:off x="6784520" y="1871472"/>
+            <a:off x="6784520" y="2218182"/>
             <a:ext cx="4627519" cy="2714752"/>
           </a:xfrm>
           <a:prstGeom prst="rect">
@@ -14101,7 +14101,7 @@
         </p:nvSpPr>
         <p:spPr>
           <a:xfrm>
-            <a:off x="6400800" y="4604512"/>
+            <a:off x="6400800" y="4951222"/>
             <a:ext cx="5394960" cy="394208"/>
           </a:xfrm>
           <a:prstGeom prst="rect">
@@ -14140,7 +14140,7 @@
         </p:nvSpPr>
         <p:spPr>
           <a:xfrm>
-            <a:off x="6400800" y="5035296"/>
+            <a:off x="6400800" y="5382006"/>
             <a:ext cx="5394960" cy="274320"/>
           </a:xfrm>
           <a:prstGeom prst="rect">
@@ -14478,7 +14478,7 @@
         </p:nvGraphicFramePr>
         <p:xfrm>
           <a:off x="411480" y="1298448"/>
-          <a:ext cx="11368733" cy="1965960"/>
+          <a:ext cx="11368733" cy="2623185"/>
         </p:xfrm>
         <a:graphic>
           <a:graphicData uri="http://schemas.openxmlformats.org/drawingml/2006/table">
@@ -14932,6 +14932,96 @@
                   </a:tcPr>
                 </a:tc>
               </a:tr>
+              <a:tr h="657225">
+                <a:tc>
+                  <a:txBody>
+                    <a:bodyPr wrap="square"/>
+                    <a:lstStyle/>
+                    <a:p>
+                      <a:r>
+                        <a:rPr sz="1100" b="0">
+                          <a:solidFill>
+                            <a:srgbClr val="282828"/>
+                          </a:solidFill>
+                          <a:latin typeface="Arial"/>
+                        </a:rPr>
+                        <a:t>the feature it proved</a:t>
+                      </a:r>
+                    </a:p>
+                  </a:txBody>
+                  <a:tcPr marL="54864" marR="54864" marT="18288" marB="18288">
+                    <a:solidFill>
+                      <a:srgbClr val="FFFFFF"/>
+                    </a:solidFill>
+                  </a:tcPr>
+                </a:tc>
+                <a:tc>
+                  <a:txBody>
+                    <a:bodyPr wrap="square"/>
+                    <a:lstStyle/>
+                    <a:p>
+                      <a:r>
+                        <a:rPr sz="1100" b="0">
+                          <a:solidFill>
+                            <a:srgbClr val="282828"/>
+                          </a:solidFill>
+                          <a:latin typeface="Arial"/>
+                        </a:rPr>
+                        <a:t>the field widened without freeforms — joint optics + focal-plane solves</a:t>
+                      </a:r>
+                    </a:p>
+                  </a:txBody>
+                  <a:tcPr marL="54864" marR="54864" marT="18288" marB="18288">
+                    <a:solidFill>
+                      <a:srgbClr val="FFFFFF"/>
+                    </a:solidFill>
+                  </a:tcPr>
+                </a:tc>
+                <a:tc>
+                  <a:txBody>
+                    <a:bodyPr wrap="square"/>
+                    <a:lstStyle/>
+                    <a:p>
+                      <a:r>
+                        <a:rPr sz="1100" b="0">
+                          <a:solidFill>
+                            <a:srgbClr val="282828"/>
+                          </a:solidFill>
+                          <a:latin typeface="Arial"/>
+                        </a:rPr>
+                        <a:t>pupil image quality, measured: metrics + the fourth-mirror trade</a:t>
+                      </a:r>
+                    </a:p>
+                  </a:txBody>
+                  <a:tcPr marL="54864" marR="54864" marT="18288" marB="18288">
+                    <a:solidFill>
+                      <a:srgbClr val="FFFFFF"/>
+                    </a:solidFill>
+                  </a:tcPr>
+                </a:tc>
+                <a:tc>
+                  <a:txBody>
+                    <a:bodyPr wrap="square"/>
+                    <a:lstStyle/>
+                    <a:p>
+                      <a:r>
+                        <a:rPr sz="1100" b="0">
+                          <a:solidFill>
+                            <a:srgbClr val="282828"/>
+                          </a:solidFill>
+                          <a:latin typeface="Arial"/>
+                        </a:rPr>
+                        <a:t>a super-wide-field imager family: the continuation walk + its frontier</a:t>
+                      </a:r>
+                    </a:p>
+                  </a:txBody>
+                  <a:tcPr marL="54864" marR="54864" marT="18288" marB="18288">
+                    <a:solidFill>
+                      <a:srgbClr val="FFFFFF"/>
+                    </a:solidFill>
+                  </a:tcPr>
+                </a:tc>
+              </a:tr>
             </a:tbl>
           </a:graphicData>
         </a:graphic>
@@ -14944,7 +15034,7 @@
         </p:nvSpPr>
         <p:spPr>
           <a:xfrm>
-            <a:off x="411480" y="3410712"/>
+            <a:off x="411480" y="4067937"/>
             <a:ext cx="11368735" cy="274320"/>
           </a:xfrm>
           <a:prstGeom prst="rect">
@@ -14964,7 +15054,7 @@
               </a:spcAft>
             </a:pPr>
             <a:r>
-              <a:rPr sz="1200" b="0">
+              <a:rPr sz="1500" b="0">
                 <a:solidFill>
                   <a:srgbClr val="282828"/>
                 </a:solidFill>
@@ -14980,7 +15070,7 @@
               </a:spcAft>
             </a:pPr>
             <a:r>
-              <a:rPr sz="1050" b="0">
+              <a:rPr sz="1300" b="0">
                 <a:solidFill>
                   <a:srgbClr val="6E6E6E"/>
                 </a:solidFill>
@@ -14996,7 +15086,7 @@
               </a:spcAft>
             </a:pPr>
             <a:r>
-              <a:rPr sz="1050" b="0">
+              <a:rPr sz="1300" b="0">
                 <a:solidFill>
                   <a:srgbClr val="6E6E6E"/>
                 </a:solidFill>
@@ -15012,12 +15102,28 @@
               </a:spcAft>
             </a:pPr>
             <a:r>
-              <a:rPr sz="1200" b="0">
+              <a:rPr sz="1500" b="0">
                 <a:solidFill>
                   <a:srgbClr val="282828"/>
                 </a:solidFill>
                 <a:latin typeface="Arial"/>
               </a:rPr>
+              <a:t>•  Each challenge left a reusable template behind — the whole study re-runs at new parameters in one call.</a:t>
+            </a:r>
+          </a:p>
+          <a:p>
+            <a:pPr>
+              <a:spcAft>
+                <a:spcPts val="600"/>
+              </a:spcAft>
+            </a:pPr>
+            <a:r>
+              <a:rPr sz="1500" b="0">
+                <a:solidFill>
+                  <a:srgbClr val="282828"/>
+                </a:solidFill>
+                <a:latin typeface="Arial"/>
+              </a:rPr>
               <a:t>•  MACOS solves each problem with its own optimizer and the same degrees of freedom.</a:t>
             </a:r>
           </a:p>
@@ -15028,7 +15134,7 @@
               </a:spcAft>
             </a:pPr>
             <a:r>
-              <a:rPr sz="1200" b="0">
+              <a:rPr sz="1500" b="0">
                 <a:solidFill>
                   <a:srgbClr val="282828"/>
                 </a:solidFill>
@@ -15044,7 +15150,7 @@
               </a:spcAft>
             </a:pPr>
             <a:r>
-              <a:rPr sz="1200" b="0">
+              <a:rPr sz="1500" b="0">
                 <a:solidFill>
                   <a:srgbClr val="282828"/>
                 </a:solidFill>
@@ -15107,7 +15213,7 @@
                 </a:solidFill>
                 <a:latin typeface="Arial"/>
               </a:rPr>
-              <a:t>Challenge 3: a 20°×20° field, 22° off axis</a:t>
+              <a:t>Challenge 3: moving a 20°×20° field 22° off axis</a:t>
             </a:r>
           </a:p>
           <a:p>
@@ -15239,6 +15345,118 @@
                 <a:latin typeface="Arial"/>
               </a:rPr>
               <a:t>•  The study became a template: one parameterized five-stage flow (solve on axis, map the offset, re-solve at the used field, add buildability constraints, add surface freedom) — re-running the whole study at new parameters is one call.</a:t>
+            </a:r>
+          </a:p>
+          <a:p>
+            <a:pPr>
+              <a:spcAft>
+                <a:spcPts val="600"/>
+              </a:spcAft>
+            </a:pPr>
+            <a:r>
+              <a:rPr sz="1200" b="0">
+                <a:solidFill>
+                  <a:srgbClr val="282828"/>
+                </a:solidFill>
+                <a:latin typeface="Arial"/>
+              </a:rPr>
+              <a:t>•  Every design passes the same gate sequence:</a:t>
+            </a:r>
+          </a:p>
+          <a:p>
+            <a:pPr>
+              <a:spcAft>
+                <a:spcPts val="500"/>
+              </a:spcAft>
+            </a:pPr>
+            <a:r>
+              <a:rPr sz="1050" b="0">
+                <a:solidFill>
+                  <a:srgbClr val="6E6E6E"/>
+                </a:solidFill>
+                <a:latin typeface="Arial"/>
+              </a:rPr>
+              <a:t>        –  1 · traceability — every solve field reaches the detector (screened before solving)</a:t>
+            </a:r>
+          </a:p>
+          <a:p>
+            <a:pPr>
+              <a:spcAft>
+                <a:spcPts val="500"/>
+              </a:spcAft>
+            </a:pPr>
+            <a:r>
+              <a:rPr sz="1050" b="0">
+                <a:solidFill>
+                  <a:srgbClr val="6E6E6E"/>
+                </a:solidFill>
+                <a:latin typeface="Arial"/>
+              </a:rPr>
+              <a:t>        –  2 · map validity — all 121 dense-map fields present, none lost</a:t>
+            </a:r>
+          </a:p>
+          <a:p>
+            <a:pPr>
+              <a:spcAft>
+                <a:spcPts val="500"/>
+              </a:spcAft>
+            </a:pPr>
+            <a:r>
+              <a:rPr sz="1050" b="0">
+                <a:solidFill>
+                  <a:srgbClr val="6E6E6E"/>
+                </a:solidFill>
+                <a:latin typeface="Arial"/>
+              </a:rPr>
+              <a:t>        –  3 · exit-beam direction — the chief within tolerance of the horizontal pin</a:t>
+            </a:r>
+          </a:p>
+          <a:p>
+            <a:pPr>
+              <a:spcAft>
+                <a:spcPts val="500"/>
+              </a:spcAft>
+            </a:pPr>
+            <a:r>
+              <a:rPr sz="1050" b="0">
+                <a:solidFill>
+                  <a:srgbClr val="6E6E6E"/>
+                </a:solidFill>
+                <a:latin typeface="Arial"/>
+              </a:rPr>
+              <a:t>        –  4 · clearance — the signed beam–mirror floor at or above spec</a:t>
+            </a:r>
+          </a:p>
+          <a:p>
+            <a:pPr>
+              <a:spcAft>
+                <a:spcPts val="500"/>
+              </a:spcAft>
+            </a:pPr>
+            <a:r>
+              <a:rPr sz="1050" b="0">
+                <a:solidFill>
+                  <a:srgbClr val="6E6E6E"/>
+                </a:solidFill>
+                <a:latin typeface="Arial"/>
+              </a:rPr>
+              <a:t>        –  5 · score — strict RMS WFE against the reported ladder</a:t>
+            </a:r>
+          </a:p>
+          <a:p>
+            <a:pPr>
+              <a:spcAft>
+                <a:spcPts val="500"/>
+              </a:spcAft>
+            </a:pPr>
+            <a:r>
+              <a:rPr sz="1050" b="0">
+                <a:solidFill>
+                  <a:srgbClr val="6E6E6E"/>
+                </a:solidFill>
+                <a:latin typeface="Arial"/>
+              </a:rPr>
+              <a:t>        –  pinned by regression checks with negative controls (the control reads 2989× the gate)</a:t>
             </a:r>
           </a:p>
         </p:txBody>
@@ -15490,7 +15708,7 @@
               </a:spcAft>
             </a:pPr>
             <a:r>
-              <a:rPr sz="1200" b="0">
+              <a:rPr sz="1500" b="0">
                 <a:solidFill>
                   <a:srgbClr val="282828"/>
                 </a:solidFill>
@@ -15506,7 +15724,7 @@
               </a:spcAft>
             </a:pPr>
             <a:r>
-              <a:rPr sz="1200" b="0">
+              <a:rPr sz="1500" b="0">
                 <a:solidFill>
                   <a:srgbClr val="282828"/>
                 </a:solidFill>
@@ -15533,7 +15751,7 @@
         </p:blipFill>
         <p:spPr>
           <a:xfrm>
-            <a:off x="818773" y="2606040"/>
+            <a:off x="818773" y="2853690"/>
             <a:ext cx="4991853" cy="2422652"/>
           </a:xfrm>
           <a:prstGeom prst="rect">
@@ -15549,7 +15767,7 @@
         </p:nvSpPr>
         <p:spPr>
           <a:xfrm>
-            <a:off x="411480" y="5046979"/>
+            <a:off x="411480" y="5294629"/>
             <a:ext cx="5806440" cy="229107"/>
           </a:xfrm>
           <a:prstGeom prst="rect">
@@ -15596,7 +15814,7 @@
         </p:blipFill>
         <p:spPr>
           <a:xfrm>
-            <a:off x="7543375" y="2606040"/>
+            <a:off x="7543375" y="2853690"/>
             <a:ext cx="3109808" cy="2696972"/>
           </a:xfrm>
           <a:prstGeom prst="rect">
@@ -15612,7 +15830,7 @@
         </p:nvSpPr>
         <p:spPr>
           <a:xfrm>
-            <a:off x="6400800" y="5321300"/>
+            <a:off x="6400800" y="5568949"/>
             <a:ext cx="5394960" cy="229107"/>
           </a:xfrm>
           <a:prstGeom prst="rect">
@@ -15651,7 +15869,7 @@
         </p:nvSpPr>
         <p:spPr>
           <a:xfrm>
-            <a:off x="6400800" y="5586984"/>
+            <a:off x="6400800" y="5834633"/>
             <a:ext cx="5394960" cy="274320"/>
           </a:xfrm>
           <a:prstGeom prst="rect">
@@ -15827,7 +16045,7 @@
               </a:spcAft>
             </a:pPr>
             <a:r>
-              <a:rPr sz="1200" b="0">
+              <a:rPr sz="1500" b="0">
                 <a:solidFill>
                   <a:srgbClr val="282828"/>
                 </a:solidFill>
@@ -15843,7 +16061,7 @@
               </a:spcAft>
             </a:pPr>
             <a:r>
-              <a:rPr sz="1200" b="0">
+              <a:rPr sz="1500" b="0">
                 <a:solidFill>
                   <a:srgbClr val="282828"/>
                 </a:solidFill>
@@ -15870,7 +16088,7 @@
         </p:blipFill>
         <p:spPr>
           <a:xfrm>
-            <a:off x="923134" y="2407920"/>
+            <a:off x="923134" y="2853690"/>
             <a:ext cx="4783130" cy="2879852"/>
           </a:xfrm>
           <a:prstGeom prst="rect">
@@ -15886,7 +16104,7 @@
         </p:nvSpPr>
         <p:spPr>
           <a:xfrm>
-            <a:off x="411480" y="5306059"/>
+            <a:off x="411480" y="5751829"/>
             <a:ext cx="5806440" cy="229107"/>
           </a:xfrm>
           <a:prstGeom prst="rect">
@@ -15933,7 +16151,7 @@
         </p:blipFill>
         <p:spPr>
           <a:xfrm>
-            <a:off x="7514869" y="2407920"/>
+            <a:off x="7514869" y="2853690"/>
             <a:ext cx="3166820" cy="2788411"/>
           </a:xfrm>
           <a:prstGeom prst="rect">
@@ -15949,7 +16167,7 @@
         </p:nvSpPr>
         <p:spPr>
           <a:xfrm>
-            <a:off x="6400800" y="5214620"/>
+            <a:off x="6400800" y="5660389"/>
             <a:ext cx="5394960" cy="229107"/>
           </a:xfrm>
           <a:prstGeom prst="rect">
@@ -15988,7 +16206,7 @@
         </p:nvSpPr>
         <p:spPr>
           <a:xfrm>
-            <a:off x="6400800" y="5480304"/>
+            <a:off x="6400800" y="5926073"/>
             <a:ext cx="5394960" cy="274320"/>
           </a:xfrm>
           <a:prstGeom prst="rect">

</xml_diff>

<commit_message>
deck: recover the REST of Dave's pass 1 -- the truncated-diff lesson
The first recovery's diff DISPLAY truncated each text shape at 400
chars; edits deeper in a long block (slide 2: 'now', plus four
modernization sub-bullets) were flagged but never read, and the
edit-copy refresh then hid them.  Dave's edited file survived in the
prior commit; restored (deck_keysight_dave_pass1.pptx), re-diffed with
the full-text line diff (pptx_text_diff.py, now kept in the package),
all edits folded in.  Rule for next time: the recovery diff must show
FULL text, never a preview window.

Co-Authored-By: Claude Fable 5 <noreply@anthropic.com>
</commit_message>
<xml_diff>
--- a/demo_session/deck_keysight.pptx
+++ b/demo_session/deck_keysight.pptx
@@ -9097,7 +9097,71 @@
                 </a:solidFill>
                 <a:latin typeface="Arial"/>
               </a:rPr>
-              <a:t>•  We are modernizing and extending the capabilities of our modeling to meet new challenges.</a:t>
+              <a:t>•  We are now modernizing and extending the capabilities of our modeling to meet new challenges.</a:t>
+            </a:r>
+          </a:p>
+          <a:p>
+            <a:pPr>
+              <a:spcAft>
+                <a:spcPts val="500"/>
+              </a:spcAft>
+            </a:pPr>
+            <a:r>
+              <a:rPr sz="1300" b="0">
+                <a:solidFill>
+                  <a:srgbClr val="6E6E6E"/>
+                </a:solidFill>
+                <a:latin typeface="Arial"/>
+              </a:rPr>
+              <a:t>        –  New elements: Freeforms with aberrations, polarizers, complex masks and apodizers, completely general surfaces added through the API</a:t>
+            </a:r>
+          </a:p>
+          <a:p>
+            <a:pPr>
+              <a:spcAft>
+                <a:spcPts val="500"/>
+              </a:spcAft>
+            </a:pPr>
+            <a:r>
+              <a:rPr sz="1300" b="0">
+                <a:solidFill>
+                  <a:srgbClr val="6E6E6E"/>
+                </a:solidFill>
+                <a:latin typeface="Arial"/>
+              </a:rPr>
+              <a:t>        –  The same functionality, streamlined: linear model generation, simulation, multi-path, metrology and edge sensors</a:t>
+            </a:r>
+          </a:p>
+          <a:p>
+            <a:pPr>
+              <a:spcAft>
+                <a:spcPts val="500"/>
+              </a:spcAft>
+            </a:pPr>
+            <a:r>
+              <a:rPr sz="1300" b="0">
+                <a:solidFill>
+                  <a:srgbClr val="6E6E6E"/>
+                </a:solidFill>
+                <a:latin typeface="Arial"/>
+              </a:rPr>
+              <a:t>        –  New capabilities: design layer</a:t>
+            </a:r>
+          </a:p>
+          <a:p>
+            <a:pPr>
+              <a:spcAft>
+                <a:spcPts val="500"/>
+              </a:spcAft>
+            </a:pPr>
+            <a:r>
+              <a:rPr sz="1300" b="0">
+                <a:solidFill>
+                  <a:srgbClr val="6E6E6E"/>
+                </a:solidFill>
+                <a:latin typeface="Arial"/>
+              </a:rPr>
+              <a:t>        –  Code cleanup: improved robustness, automated testing, updating documentation</a:t>
             </a:r>
           </a:p>
         </p:txBody>

</xml_diff>

<commit_message>
slide 12 honesty + BRIEF_r2_packaging: the 343 mm layout is a screen, not a package
Dave's catch: the folded layout's back focal path exceeds the M1-M2
spacing -- the record's own footnote agrees ('a first screen, not a
layout'; memory: S4 trade NOT BUILDABLE).  Slide 12 now says so
plainly (trade = the result, not the layout; packaging queued).  The
brief tasks TO with fold-down packaging (Path A), bounded redesign
(B), or pricing the measured gap (C) -- strictly additive in
challenges/afocal4/packaging/, no committed artifact touched.

Co-Authored-By: Claude Fable 5 <noreply@anthropic.com>
</commit_message>
<xml_diff>
--- a/demo_session/deck_keysight.pptx
+++ b/demo_session/deck_keysight.pptx
@@ -5396,7 +5396,7 @@
                 </a:solidFill>
                 <a:latin typeface="Arial"/>
               </a:rPr>
-              <a:t>•  The trade, packaged: with the last mirror held behind the primary, the solutions split into two families; pupil distances under 220 mm leave no room for an instrument after the fold — 343 mm admits a 464 mm diameter.</a:t>
+              <a:t>•  The trade, constrained: with the last mirror held behind the primary, the solutions split into two families; pupil distances under 220 mm leave no room for an instrument after the fold — 343 mm admits a 464 mm diameter.</a:t>
             </a:r>
           </a:p>
         </p:txBody>
@@ -5480,8 +5480,8 @@
         </p:blipFill>
         <p:spPr>
           <a:xfrm>
-            <a:off x="7972854" y="1298448"/>
-            <a:ext cx="2250851" cy="1874011"/>
+            <a:off x="8072004" y="1298448"/>
+            <a:ext cx="2052551" cy="1708911"/>
           </a:xfrm>
           <a:prstGeom prst="rect">
             <a:avLst/>
@@ -5496,8 +5496,8 @@
         </p:nvSpPr>
         <p:spPr>
           <a:xfrm>
-            <a:off x="6400800" y="3190747"/>
-            <a:ext cx="5394960" cy="229107"/>
+            <a:off x="6400800" y="3025648"/>
+            <a:ext cx="5394960" cy="394208"/>
           </a:xfrm>
           <a:prstGeom prst="rect">
             <a:avLst/>
@@ -5522,7 +5522,7 @@
                 </a:solidFill>
                 <a:latin typeface="Arial"/>
               </a:rPr>
-              <a:t>The constrained design, folded: the instrument volume behind the primary.</a:t>
+              <a:t>The constrained design at the 343 mm point — a packaging screen, not a completed layout.</a:t>
             </a:r>
           </a:p>
         </p:txBody>
@@ -5624,7 +5624,7 @@
                 </a:solidFill>
                 <a:latin typeface="Arial"/>
               </a:rPr>
-              <a:t>"3 mirrors" = the best delivered variant.  Yardsticks: pupil imaging resolves 2.7 µm across the 33 mm pupil, depth of focus ~30 µm — the measured defects sit 50–350× above these floors.  Per-point trade table: the design/rodgers2 record.</a:t>
+              <a:t>"3 mirrors" = the best delivered variant.  Yardsticks: pupil imaging resolves 2.7 µm across the 33 mm pupil, depth of focus ~30 µm — the measured defects sit 50–350× above these floors.  Packaging was not driven to completion: the back focal path still exceeds the M1–M2 spacing, and folding it down is queued work — the TRADE is the result, not the layout.  Per-point trade table: the design/rodgers2 record.</a:t>
             </a:r>
           </a:p>
         </p:txBody>

</xml_diff>

<commit_message>
slide 12 upgrade from the r2-packaging delivery + slide 9 literal prompts
Slide 12: the old S4b folded figure (which TO's rebuild showed touches
no depth, costs the shroud, and clips the feed) is replaced by the
three-way packaging comparison -- committed 1.81x overhang vs Path A's
four folds at 0.86x -- with costs stated and the collimator
self-interference finding declared (redesign queued).  Slide 9's code
box is now the literal demo-day sequence incl. oi_demo_show at the
reveal.

Co-Authored-By: Claude Fable 5 <noreply@anthropic.com>
</commit_message>
<xml_diff>
--- a/demo_session/deck_keysight.pptx
+++ b/demo_session/deck_keysight.pptx
@@ -5466,7 +5466,7 @@
       </p:sp>
       <p:pic>
         <p:nvPicPr>
-          <p:cNvPr id="8" name="Picture 7" descr="rodgers2_final_folded.png"/>
+          <p:cNvPr id="8" name="Picture 7" descr="afocal4_pack_compare.png"/>
           <p:cNvPicPr>
             <a:picLocks noChangeAspect="1"/>
           </p:cNvPicPr>
@@ -5480,8 +5480,8 @@
         </p:blipFill>
         <p:spPr>
           <a:xfrm>
-            <a:off x="8072004" y="1298448"/>
-            <a:ext cx="2052551" cy="1708911"/>
+            <a:off x="7166877" y="1298448"/>
+            <a:ext cx="3862805" cy="1653032"/>
           </a:xfrm>
           <a:prstGeom prst="rect">
             <a:avLst/>
@@ -5496,8 +5496,8 @@
         </p:nvSpPr>
         <p:spPr>
           <a:xfrm>
-            <a:off x="6400800" y="3025648"/>
-            <a:ext cx="5394960" cy="394208"/>
+            <a:off x="6400800" y="2969768"/>
+            <a:ext cx="5394960" cy="724408"/>
           </a:xfrm>
           <a:prstGeom prst="rect">
             <a:avLst/>
@@ -5522,7 +5522,7 @@
                 </a:solidFill>
                 <a:latin typeface="Arial"/>
               </a:rPr>
-              <a:t>The constrained design at the 343 mm point — a packaging screen, not a completed layout.</a:t>
+              <a:t>Packaging, driven to a measured answer: as committed the deepest optic sits 1.887 m behind the primary — 1.81× the M1–M2 span (left); four folds in the feed leg bring it to 0.893 m, 0.86×, inside the telescope's own envelope, with the fold null asserted at 3×10⁻⁸ nm (right).</a:t>
             </a:r>
           </a:p>
         </p:txBody>
@@ -5543,8 +5543,8 @@
         </p:blipFill>
         <p:spPr>
           <a:xfrm>
-            <a:off x="7983866" y="3456432"/>
-            <a:ext cx="2228827" cy="1526032"/>
+            <a:off x="8117417" y="3730752"/>
+            <a:ext cx="1961724" cy="1343152"/>
           </a:xfrm>
           <a:prstGeom prst="rect">
             <a:avLst/>
@@ -5559,7 +5559,7 @@
         </p:nvSpPr>
         <p:spPr>
           <a:xfrm>
-            <a:off x="6400800" y="5000752"/>
+            <a:off x="6400800" y="5092192"/>
             <a:ext cx="5394960" cy="394208"/>
           </a:xfrm>
           <a:prstGeom prst="rect">
@@ -5598,7 +5598,7 @@
         </p:nvSpPr>
         <p:spPr>
           <a:xfrm>
-            <a:off x="6400800" y="5431536"/>
+            <a:off x="6400800" y="5522976"/>
             <a:ext cx="5394960" cy="274320"/>
           </a:xfrm>
           <a:prstGeom prst="rect">
@@ -5624,7 +5624,7 @@
                 </a:solidFill>
                 <a:latin typeface="Arial"/>
               </a:rPr>
-              <a:t>"3 mirrors" = the best delivered variant.  Yardsticks: pupil imaging resolves 2.7 µm across the 33 mm pupil, depth of focus ~30 µm — the measured defects sit 50–350× above these floors.  Packaging was not driven to completion: the back focal path still exceeds the M1–M2 spacing, and folding it down is queued work — the TRADE is the result, not the layout.  Per-point trade table: the design/rodgers2 record.</a:t>
+              <a:t>Yardsticks: pupil imaging resolves 2.7 µm across the 33 mm pupil, depth of focus ~30 µm — the measured defects sit 50–350× above the floors.  Packaging costs are stated, not smoothed (+5.8 mm flat clearance, ~300 mm decentred flats, four 45° folds = an unopened polarization budget) — and the same measurement found a REAL buildability item no fold can fix: the collimator stands in the union of its own feed beams (−55 mm against bare glass); redesign queued.  Records: design/rodgers2 + challenges/afocal4/packaging.</a:t>
             </a:r>
           </a:p>
         </p:txBody>
@@ -16533,13 +16533,13 @@
               </a:spcAft>
             </a:pPr>
             <a:r>
-              <a:rPr sz="1150" b="0">
+              <a:rPr sz="938" b="0">
                 <a:solidFill>
                   <a:srgbClr val="282828"/>
                 </a:solidFill>
                 <a:latin typeface="Consolas"/>
               </a:rPr>
-              <a:t>&gt;&gt; oi_demo_step(12)      % the room's width goes here</a:t>
+              <a:t>$ matlab &amp;                    % a fresh MATLAB, just for this solve</a:t>
             </a:r>
           </a:p>
           <a:p>
@@ -16549,7 +16549,7 @@
               </a:spcAft>
             </a:pPr>
             <a:r>
-              <a:rPr sz="1150" b="0">
+              <a:rPr sz="938" b="0">
                 <a:solidFill>
                   <a:srgbClr val="282828"/>
                 </a:solidFill>
@@ -16565,13 +16565,13 @@
               </a:spcAft>
             </a:pPr>
             <a:r>
-              <a:rPr sz="1150" b="0">
+              <a:rPr sz="938" b="0">
                 <a:solidFill>
                   <a:srgbClr val="282828"/>
                 </a:solidFill>
                 <a:latin typeface="Consolas"/>
               </a:rPr>
-              <a:t> warm start     : committed walk step 3 (11 x 11 deg)</a:t>
+              <a:t>&gt;&gt; cd ~/dev/MACOS_resources/mmacos/templates/10_telescopes/offset_imager</a:t>
             </a:r>
           </a:p>
           <a:p>
@@ -16581,13 +16581,13 @@
               </a:spcAft>
             </a:pPr>
             <a:r>
-              <a:rPr sz="1150" b="0">
+              <a:rPr sz="938" b="0">
                 <a:solidFill>
                   <a:srgbClr val="282828"/>
                 </a:solidFill>
                 <a:latin typeface="Consolas"/>
               </a:rPr>
-              <a:t> solve          : S5 full freedom (conics+Zernike</a:t>
+              <a:t>&gt;&gt; OUT = oi_demo_step(12)     % &lt;-- the room's width goes here (5-15 deg)</a:t>
             </a:r>
           </a:p>
           <a:p>
@@ -16597,13 +16597,13 @@
               </a:spcAft>
             </a:pPr>
             <a:r>
-              <a:rPr sz="1150" b="0">
+              <a:rPr sz="938" b="0">
                 <a:solidFill>
                   <a:srgbClr val="282828"/>
                 </a:solidFill>
                 <a:latin typeface="Consolas"/>
               </a:rPr>
-              <a:t>                  +tilt/dec+radii+stop_y)</a:t>
+              <a:t> </a:t>
             </a:r>
           </a:p>
           <a:p>
@@ -16613,13 +16613,13 @@
               </a:spcAft>
             </a:pPr>
             <a:r>
-              <a:rPr sz="1150" b="0">
+              <a:rPr sz="938" b="0">
                 <a:solidFill>
                   <a:srgbClr val="282828"/>
                 </a:solidFill>
                 <a:latin typeface="Consolas"/>
               </a:rPr>
-              <a:t> ...  ~15 min ...</a:t>
+              <a:t> warm start : committed walk step 3  (11 x 11 deg)</a:t>
             </a:r>
           </a:p>
           <a:p>
@@ -16629,12 +16629,44 @@
               </a:spcAft>
             </a:pPr>
             <a:r>
-              <a:rPr sz="1150" b="0">
+              <a:rPr sz="938" b="0">
                 <a:solidFill>
                   <a:srgbClr val="282828"/>
                 </a:solidFill>
                 <a:latin typeface="Consolas"/>
               </a:rPr>
+              <a:t> predicted  : ~33.7 nm, ~24.8 mm floor  (frontier rows 11/13 deg)</a:t>
+            </a:r>
+          </a:p>
+          <a:p>
+            <a:pPr>
+              <a:spcAft>
+                <a:spcPts val="100"/>
+              </a:spcAft>
+            </a:pPr>
+            <a:r>
+              <a:rPr sz="938" b="0">
+                <a:solidFill>
+                  <a:srgbClr val="282828"/>
+                </a:solidFill>
+                <a:latin typeface="Consolas"/>
+              </a:rPr>
+              <a:t> solving    : one full-freedom step ...  ~15 min</a:t>
+            </a:r>
+          </a:p>
+          <a:p>
+            <a:pPr>
+              <a:spcAft>
+                <a:spcPts val="100"/>
+              </a:spcAft>
+            </a:pPr>
+            <a:r>
+              <a:rPr sz="938" b="0">
+                <a:solidFill>
+                  <a:srgbClr val="282828"/>
+                </a:solidFill>
+                <a:latin typeface="Consolas"/>
+              </a:rPr>
               <a:t> </a:t>
             </a:r>
           </a:p>
@@ -16645,13 +16677,13 @@
               </a:spcAft>
             </a:pPr>
             <a:r>
-              <a:rPr sz="1150" b="0">
+              <a:rPr sz="938" b="0">
                 <a:solidFill>
                   <a:srgbClr val="282828"/>
                 </a:solidFill>
                 <a:latin typeface="Consolas"/>
               </a:rPr>
-              <a:t> DENSE MAP MAX  : 33.6 nm   predicted ~33.7  (1.00x)</a:t>
+              <a:t> ... at the reveal, the windows are already up; if needed:</a:t>
             </a:r>
           </a:p>
           <a:p>
@@ -16661,13 +16693,13 @@
               </a:spcAft>
             </a:pPr>
             <a:r>
-              <a:rPr sz="1150" b="0">
+              <a:rPr sz="938" b="0">
                 <a:solidFill>
                   <a:srgbClr val="282828"/>
                 </a:solidFill>
                 <a:latin typeface="Consolas"/>
               </a:rPr>
-              <a:t> clearance floor: 24.9 mm   exit err 0.012 deg</a:t>
+              <a:t>&gt;&gt; oi_demo_show(OUT)          % live layout + WF map + fields</a:t>
             </a:r>
           </a:p>
           <a:p>
@@ -16677,13 +16709,13 @@
               </a:spcAft>
             </a:pPr>
             <a:r>
-              <a:rPr sz="1150" b="0">
+              <a:rPr sz="938" b="0">
                 <a:solidFill>
                   <a:srgbClr val="282828"/>
                 </a:solidFill>
                 <a:latin typeface="Consolas"/>
               </a:rPr>
-              <a:t> gates          : exit PASS / clear PASS</a:t>
+              <a:t>&gt;&gt; type(OUT.files.verdict)    % the verdict block</a:t>
             </a:r>
           </a:p>
         </p:txBody>
@@ -16696,7 +16728,7 @@
         </p:nvSpPr>
         <p:spPr>
           <a:xfrm>
-            <a:off x="6400800" y="3354324"/>
+            <a:off x="6400800" y="3314580"/>
             <a:ext cx="5394960" cy="274320"/>
           </a:xfrm>
           <a:prstGeom prst="rect">
@@ -16722,7 +16754,7 @@
                 </a:solidFill>
                 <a:latin typeface="Arial"/>
               </a:rPr>
-              <a:t>The rehearsal run's verdict (12° ask), abbreviated verbatim; the live run prints the same block for the room's width.</a:t>
+              <a:t>The literal demo-day sequence ($ = shell, &gt;&gt; = MATLAB); the rehearsal at 12° solved 33.6 nm against the ~33.7 prediction, and the 14° rehearsal beat its predict too.</a:t>
             </a:r>
           </a:p>
         </p:txBody>

</xml_diff>

<commit_message>
packaging gets its own slide 13 (split-don't-shrink); slide 12 back to one idea
Co-Authored-By: Claude Fable 5 <noreply@anthropic.com>
</commit_message>
<xml_diff>
--- a/demo_session/deck_keysight.pptx
+++ b/demo_session/deck_keysight.pptx
@@ -38,6 +38,7 @@
     <p:sldId id="286" r:id="rId37"/>
     <p:sldId id="287" r:id="rId38"/>
     <p:sldId id="288" r:id="rId39"/>
+    <p:sldId id="289" r:id="rId40"/>
   </p:sldIdLst>
   <p:sldSz cx="12191695" cy="6858000" type="screen4x3"/>
   <p:notesSz cx="6858000" cy="9144000"/>
@@ -5466,7 +5467,7 @@
       </p:sp>
       <p:pic>
         <p:nvPicPr>
-          <p:cNvPr id="8" name="Picture 7" descr="afocal4_pack_compare.png"/>
+          <p:cNvPr id="8" name="Picture 7" descr="rodgers2_final_trade.png"/>
           <p:cNvPicPr>
             <a:picLocks noChangeAspect="1"/>
           </p:cNvPicPr>
@@ -5480,8 +5481,8 @@
         </p:blipFill>
         <p:spPr>
           <a:xfrm>
-            <a:off x="7166877" y="1298448"/>
-            <a:ext cx="3862805" cy="1653032"/>
+            <a:off x="7649987" y="1298448"/>
+            <a:ext cx="2896585" cy="1983232"/>
           </a:xfrm>
           <a:prstGeom prst="rect">
             <a:avLst/>
@@ -5496,8 +5497,8 @@
         </p:nvSpPr>
         <p:spPr>
           <a:xfrm>
-            <a:off x="6400800" y="2969768"/>
-            <a:ext cx="5394960" cy="724408"/>
+            <a:off x="6400800" y="3299968"/>
+            <a:ext cx="5394960" cy="394208"/>
           </a:xfrm>
           <a:prstGeom prst="rect">
             <a:avLst/>
@@ -5522,45 +5523,21 @@
                 </a:solidFill>
                 <a:latin typeface="Arial"/>
               </a:rPr>
-              <a:t>Packaging, driven to a measured answer: as committed the deepest optic sits 1.887 m behind the primary — 1.81× the M1–M2 span (left); four folds in the feed leg bring it to 0.893 m, 0.86×, inside the telescope's own envelope, with the fold null asserted at 3×10⁻⁸ nm (right).</a:t>
-            </a:r>
-          </a:p>
-        </p:txBody>
-      </p:sp>
-      <p:pic>
-        <p:nvPicPr>
-          <p:cNvPr id="10" name="Picture 9" descr="rodgers2_final_trade.png"/>
-          <p:cNvPicPr>
-            <a:picLocks noChangeAspect="1"/>
-          </p:cNvPicPr>
-          <p:nvPr/>
-        </p:nvPicPr>
-        <p:blipFill>
-          <a:blip r:embed="rId4"/>
-          <a:stretch>
-            <a:fillRect/>
-          </a:stretch>
-        </p:blipFill>
-        <p:spPr>
-          <a:xfrm>
-            <a:off x="8117417" y="3730752"/>
-            <a:ext cx="1961724" cy="1343152"/>
-          </a:xfrm>
-          <a:prstGeom prst="rect">
-            <a:avLst/>
-          </a:prstGeom>
-        </p:spPr>
-      </p:pic>
-      <p:sp>
-        <p:nvSpPr>
-          <p:cNvPr id="11" name="TextBox 10"/>
+              <a:t>Both solution families beside the retracted unconstrained curve; the instrument-diameter column selects the 343 mm point.</a:t>
+            </a:r>
+          </a:p>
+        </p:txBody>
+      </p:sp>
+      <p:sp>
+        <p:nvSpPr>
+          <p:cNvPr id="10" name="TextBox 9"/>
           <p:cNvSpPr txBox="1"/>
           <p:nvPr/>
         </p:nvSpPr>
         <p:spPr>
           <a:xfrm>
-            <a:off x="6400800" y="5092192"/>
-            <a:ext cx="5394960" cy="394208"/>
+            <a:off x="6400800" y="3730752"/>
+            <a:ext cx="5394960" cy="274320"/>
           </a:xfrm>
           <a:prstGeom prst="rect">
             <a:avLst/>
@@ -5573,58 +5550,19 @@
           </a:bodyPr>
           <a:lstStyle/>
           <a:p>
-            <a:pPr algn="ctr">
-              <a:spcAft>
-                <a:spcPts val="0"/>
-              </a:spcAft>
-            </a:pPr>
-            <a:r>
-              <a:rPr sz="1000" b="0">
+            <a:pPr>
+              <a:spcAft>
+                <a:spcPts val="600"/>
+              </a:spcAft>
+            </a:pPr>
+            <a:r>
+              <a:rPr sz="1050" b="0">
                 <a:solidFill>
                   <a:srgbClr val="6E6E6E"/>
                 </a:solidFill>
                 <a:latin typeface="Arial"/>
               </a:rPr>
-              <a:t>Both solution families beside the retracted unconstrained curve; the instrument-diameter column selects the 343 mm point.</a:t>
-            </a:r>
-          </a:p>
-        </p:txBody>
-      </p:sp>
-      <p:sp>
-        <p:nvSpPr>
-          <p:cNvPr id="12" name="TextBox 11"/>
-          <p:cNvSpPr txBox="1"/>
-          <p:nvPr/>
-        </p:nvSpPr>
-        <p:spPr>
-          <a:xfrm>
-            <a:off x="6400800" y="5522976"/>
-            <a:ext cx="5394960" cy="274320"/>
-          </a:xfrm>
-          <a:prstGeom prst="rect">
-            <a:avLst/>
-          </a:prstGeom>
-          <a:noFill/>
-        </p:spPr>
-        <p:txBody>
-          <a:bodyPr wrap="square">
-            <a:spAutoFit/>
-          </a:bodyPr>
-          <a:lstStyle/>
-          <a:p>
-            <a:pPr>
-              <a:spcAft>
-                <a:spcPts val="600"/>
-              </a:spcAft>
-            </a:pPr>
-            <a:r>
-              <a:rPr sz="1050" b="0">
-                <a:solidFill>
-                  <a:srgbClr val="6E6E6E"/>
-                </a:solidFill>
-                <a:latin typeface="Arial"/>
-              </a:rPr>
-              <a:t>Yardsticks: pupil imaging resolves 2.7 µm across the 33 mm pupil, depth of focus ~30 µm — the measured defects sit 50–350× above the floors.  Packaging costs are stated, not smoothed (+5.8 mm flat clearance, ~300 mm decentred flats, four 45° folds = an unopened polarization budget) — and the same measurement found a REAL buildability item no fold can fix: the collimator stands in the union of its own feed beams (−55 mm against bare glass); redesign queued.  Records: design/rodgers2 + challenges/afocal4/packaging.</a:t>
+              <a:t>Yardsticks: pupil imaging resolves 2.7 µm across the 33 mm pupil, depth of focus ~30 µm — the measured defects sit 50–350× above these floors.  Per-point trade table: the design/rodgers2 record.  Packaging the 343 mm point: next slide.</a:t>
             </a:r>
           </a:p>
         </p:txBody>
@@ -5681,7 +5619,7 @@
                 </a:solidFill>
                 <a:latin typeface="Arial"/>
               </a:rPr>
-              <a:t>A Twyman–Green interferometer for measuring DM surfaces</a:t>
+              <a:t>Challenge 2: packaging behind the primary</a:t>
             </a:r>
           </a:p>
           <a:p>
@@ -5697,7 +5635,7 @@
                 </a:solidFill>
                 <a:latin typeface="Arial"/>
               </a:rPr>
-              <a:t>Phase-shifting with no moving parts: the analyzer angle is the phase step</a:t>
+              <a:t>As committed, the deepest optic overhangs the M1–M2 span 1.81× — four folds bring it to 0.86×</a:t>
             </a:r>
           </a:p>
         </p:txBody>
@@ -5746,96 +5684,9 @@
           </a:p>
         </p:txBody>
       </p:sp>
-      <p:sp>
-        <p:nvSpPr>
-          <p:cNvPr id="4" name="TextBox 3"/>
-          <p:cNvSpPr txBox="1"/>
-          <p:nvPr/>
-        </p:nvSpPr>
-        <p:spPr>
-          <a:xfrm>
-            <a:off x="411480" y="1298448"/>
-            <a:ext cx="5806440" cy="274320"/>
-          </a:xfrm>
-          <a:prstGeom prst="rect">
-            <a:avLst/>
-          </a:prstGeom>
-          <a:noFill/>
-        </p:spPr>
-        <p:txBody>
-          <a:bodyPr wrap="square">
-            <a:spAutoFit/>
-          </a:bodyPr>
-          <a:lstStyle/>
-          <a:p>
-            <a:pPr>
-              <a:spcAft>
-                <a:spcPts val="600"/>
-              </a:spcAft>
-            </a:pPr>
-            <a:r>
-              <a:rPr sz="1200" b="0">
-                <a:solidFill>
-                  <a:srgbClr val="282828"/>
-                </a:solidFill>
-                <a:latin typeface="Arial"/>
-              </a:rPr>
-              <a:t>•  Why a Twyman–Green for a DM: normal incidence (double pass, 2× sensitivity), a natural null against the flat reference, the fewest reference surfaces of any two-beam layout.  A Mach–Zehnder buys arm isolation, two ports and transmission testing — dynamics, not figure.</a:t>
-            </a:r>
-          </a:p>
-          <a:p>
-            <a:pPr>
-              <a:spcAft>
-                <a:spcPts val="600"/>
-              </a:spcAft>
-            </a:pPr>
-            <a:r>
-              <a:rPr sz="1200" b="0">
-                <a:solidFill>
-                  <a:srgbClr val="282828"/>
-                </a:solidFill>
-                <a:latin typeface="Arial"/>
-              </a:rPr>
-              <a:t>•  The polarization trick: the two arms carry orthogonal polarizations, so they cannot interfere until projected; an output quarter-wave plate makes them opposite circular, and an analyzer at angle θ then writes fringe phase 2θ.</a:t>
-            </a:r>
-          </a:p>
-          <a:p>
-            <a:pPr>
-              <a:spcAft>
-                <a:spcPts val="600"/>
-              </a:spcAft>
-            </a:pPr>
-            <a:r>
-              <a:rPr sz="1200" b="0">
-                <a:solidFill>
-                  <a:srgbClr val="282828"/>
-                </a:solidFill>
-                <a:latin typeface="Arial"/>
-              </a:rPr>
-              <a:t>•  Four analyzer angles — 0 / 45 / 90 / 135° — are the four phase steps of standard PSI, with nothing in the interferometer moving: the vibration immunity of polarization phase shifting.</a:t>
-            </a:r>
-          </a:p>
-          <a:p>
-            <a:pPr>
-              <a:spcAft>
-                <a:spcPts val="600"/>
-              </a:spcAft>
-            </a:pPr>
-            <a:r>
-              <a:rPr sz="1200" b="0">
-                <a:solidFill>
-                  <a:srgbClr val="282828"/>
-                </a:solidFill>
-                <a:latin typeface="Arial"/>
-              </a:rPr>
-              <a:t>•  The factor of two: DM surface height h enters the optical path as 2h at normal incidence; the recovery closes against the injected map with exactly that factor.</a:t>
-            </a:r>
-          </a:p>
-        </p:txBody>
-      </p:sp>
       <p:pic>
         <p:nvPicPr>
-          <p:cNvPr id="5" name="Picture 4" descr="demo_beat6_sweep.png"/>
+          <p:cNvPr id="4" name="Picture 3" descr="afocal4_pack_compare.png"/>
           <p:cNvPicPr>
             <a:picLocks noChangeAspect="1"/>
           </p:cNvPicPr>
@@ -5849,8 +5700,8 @@
         </p:blipFill>
         <p:spPr>
           <a:xfrm>
-            <a:off x="6400800" y="1298448"/>
-            <a:ext cx="5394960" cy="2517954"/>
+            <a:off x="3223672" y="1298448"/>
+            <a:ext cx="5744349" cy="2458212"/>
           </a:xfrm>
           <a:prstGeom prst="rect">
             <a:avLst/>
@@ -5859,14 +5710,14 @@
       </p:pic>
       <p:sp>
         <p:nvSpPr>
-          <p:cNvPr id="6" name="TextBox 5"/>
+          <p:cNvPr id="5" name="TextBox 4"/>
           <p:cNvSpPr txBox="1"/>
           <p:nvPr/>
         </p:nvSpPr>
         <p:spPr>
           <a:xfrm>
-            <a:off x="6400800" y="3834690"/>
-            <a:ext cx="5394960" cy="394208"/>
+            <a:off x="411480" y="3774947"/>
+            <a:ext cx="11368735" cy="559307"/>
           </a:xfrm>
           <a:prstGeom prst="rect">
             <a:avLst/>
@@ -5891,21 +5742,21 @@
                 </a:solidFill>
                 <a:latin typeface="Arial"/>
               </a:rPr>
-              <a:t>The analyzer sweep on the poked DM: phase-stepped fringe frames — the phase walks, the rig stands still.</a:t>
-            </a:r>
-          </a:p>
-        </p:txBody>
-      </p:sp>
-      <p:sp>
-        <p:nvSpPr>
-          <p:cNvPr id="7" name="TextBox 6"/>
+              <a:t>Engine-truth packaging, three ways: as committed, the deepest optic sits 1.887 m behind the primary against a 1.042 m M1–M2 span (left); the recorded single-fold recipe touches no depth and throws the instrument radially (middle); four folds in the feed leg bring the deepest optic to 0.893 m — inside the telescope's own envelope — at Ø1.120 × 2.832 m (right).</a:t>
+            </a:r>
+          </a:p>
+        </p:txBody>
+      </p:sp>
+      <p:sp>
+        <p:nvSpPr>
+          <p:cNvPr id="6" name="TextBox 5"/>
           <p:cNvSpPr txBox="1"/>
           <p:nvPr/>
         </p:nvSpPr>
         <p:spPr>
           <a:xfrm>
-            <a:off x="6400800" y="4265474"/>
-            <a:ext cx="5394960" cy="274320"/>
+            <a:off x="411480" y="4370832"/>
+            <a:ext cx="11368735" cy="274320"/>
           </a:xfrm>
           <a:prstGeom prst="rect">
             <a:avLst/>
@@ -5924,13 +5775,68 @@
               </a:spcAft>
             </a:pPr>
             <a:r>
+              <a:rPr sz="1500" b="0">
+                <a:solidFill>
+                  <a:srgbClr val="282828"/>
+                </a:solidFill>
+                <a:latin typeface="Arial"/>
+              </a:rPr>
+              <a:t>•  The fix is real and priced: zero rays lost, fold null asserted at 3×10⁻⁸ nm; costs stated, not smoothed — the new flats clear by +5.8 mm, are ~300 mm across and decentred 100–146 mm, and four 45° folds are an unopened polarization budget.</a:t>
+            </a:r>
+          </a:p>
+          <a:p>
+            <a:pPr>
+              <a:spcAft>
+                <a:spcPts val="600"/>
+              </a:spcAft>
+            </a:pPr>
+            <a:r>
+              <a:rPr sz="1500" b="0">
+                <a:solidFill>
+                  <a:srgbClr val="282828"/>
+                </a:solidFill>
+                <a:latin typeface="Arial"/>
+              </a:rPr>
+              <a:t>•  The measurement found what no fold can fix: over the field box, the collimator stands in the union of its own feed beams — −55 mm against bare glass with no allowance at all.  A fold is an isometry and carries it across unchanged; the redesign is queued.</a:t>
+            </a:r>
+          </a:p>
+        </p:txBody>
+      </p:sp>
+      <p:sp>
+        <p:nvSpPr>
+          <p:cNvPr id="7" name="TextBox 6"/>
+          <p:cNvSpPr txBox="1"/>
+          <p:nvPr/>
+        </p:nvSpPr>
+        <p:spPr>
+          <a:xfrm>
+            <a:off x="411480" y="6173724"/>
+            <a:ext cx="11368735" cy="274320"/>
+          </a:xfrm>
+          <a:prstGeom prst="rect">
+            <a:avLst/>
+          </a:prstGeom>
+          <a:noFill/>
+        </p:spPr>
+        <p:txBody>
+          <a:bodyPr wrap="square">
+            <a:spAutoFit/>
+          </a:bodyPr>
+          <a:lstStyle/>
+          <a:p>
+            <a:pPr>
+              <a:spcAft>
+                <a:spcPts val="600"/>
+              </a:spcAft>
+            </a:pPr>
+            <a:r>
               <a:rPr sz="1050" b="0">
                 <a:solidFill>
                   <a:srgbClr val="6E6E6E"/>
                 </a:solidFill>
                 <a:latin typeface="Arial"/>
               </a:rPr>
-              <a:t>Topology ruling and full physics: the template README, templates/90_polarization/tg_psi_dm.</a:t>
+              <a:t>The recorded single-fold layout passed its gate on a 17.5-vs-15 mm margin while its flat clips the feed beam by −74 mm — a gate's margin is a number, not a body.  Record: challenges/afocal4/packaging.</a:t>
             </a:r>
           </a:p>
         </p:txBody>
@@ -5944,6 +5850,312 @@
 </file>
 
 <file path=ppt/slides/slide14.xml><?xml version="1.0" encoding="utf-8"?>
+<p:sld xmlns:a="http://schemas.openxmlformats.org/drawingml/2006/main" xmlns:p="http://schemas.openxmlformats.org/presentationml/2006/main" xmlns:r="http://schemas.openxmlformats.org/officeDocument/2006/relationships">
+  <p:cSld>
+    <p:spTree>
+      <p:nvGrpSpPr>
+        <p:cNvPr id="1" name=""/>
+        <p:cNvGrpSpPr/>
+        <p:nvPr/>
+      </p:nvGrpSpPr>
+      <p:grpSpPr/>
+      <p:sp>
+        <p:nvSpPr>
+          <p:cNvPr id="2" name="TextBox 1"/>
+          <p:cNvSpPr txBox="1"/>
+          <p:nvPr/>
+        </p:nvSpPr>
+        <p:spPr>
+          <a:xfrm>
+            <a:off x="411480" y="201168"/>
+            <a:ext cx="11368735" cy="914400"/>
+          </a:xfrm>
+          <a:prstGeom prst="rect">
+            <a:avLst/>
+          </a:prstGeom>
+          <a:noFill/>
+        </p:spPr>
+        <p:txBody>
+          <a:bodyPr wrap="square">
+            <a:spAutoFit/>
+          </a:bodyPr>
+          <a:lstStyle/>
+          <a:p>
+            <a:pPr>
+              <a:spcAft>
+                <a:spcPts val="400"/>
+              </a:spcAft>
+            </a:pPr>
+            <a:r>
+              <a:rPr sz="2400" b="1">
+                <a:solidFill>
+                  <a:srgbClr val="1F4E79"/>
+                </a:solidFill>
+                <a:latin typeface="Arial"/>
+              </a:rPr>
+              <a:t>A Twyman–Green interferometer for measuring DM surfaces</a:t>
+            </a:r>
+          </a:p>
+          <a:p>
+            <a:pPr>
+              <a:spcAft>
+                <a:spcPts val="0"/>
+              </a:spcAft>
+            </a:pPr>
+            <a:r>
+              <a:rPr sz="1250" b="0">
+                <a:solidFill>
+                  <a:srgbClr val="6E6E6E"/>
+                </a:solidFill>
+                <a:latin typeface="Arial"/>
+              </a:rPr>
+              <a:t>Phase-shifting with no moving parts: the analyzer angle is the phase step</a:t>
+            </a:r>
+          </a:p>
+        </p:txBody>
+      </p:sp>
+      <p:sp>
+        <p:nvSpPr>
+          <p:cNvPr id="3" name="Rectangle 2"/>
+          <p:cNvSpPr/>
+          <p:nvPr/>
+        </p:nvSpPr>
+        <p:spPr>
+          <a:xfrm>
+            <a:off x="411480" y="1133856"/>
+            <a:ext cx="11368735" cy="20320"/>
+          </a:xfrm>
+          <a:prstGeom prst="rect">
+            <a:avLst/>
+          </a:prstGeom>
+          <a:solidFill>
+            <a:srgbClr val="B8C6D4"/>
+          </a:solidFill>
+          <a:ln>
+            <a:noFill/>
+          </a:ln>
+          <a:effectLst/>
+        </p:spPr>
+        <p:style>
+          <a:lnRef idx="1">
+            <a:schemeClr val="accent1"/>
+          </a:lnRef>
+          <a:fillRef idx="3">
+            <a:schemeClr val="accent1"/>
+          </a:fillRef>
+          <a:effectRef idx="2">
+            <a:schemeClr val="accent1"/>
+          </a:effectRef>
+          <a:fontRef idx="minor">
+            <a:schemeClr val="lt1"/>
+          </a:fontRef>
+        </p:style>
+        <p:txBody>
+          <a:bodyPr rtlCol="0" anchor="ctr"/>
+          <a:lstStyle/>
+          <a:p>
+            <a:pPr algn="ctr"/>
+          </a:p>
+        </p:txBody>
+      </p:sp>
+      <p:sp>
+        <p:nvSpPr>
+          <p:cNvPr id="4" name="TextBox 3"/>
+          <p:cNvSpPr txBox="1"/>
+          <p:nvPr/>
+        </p:nvSpPr>
+        <p:spPr>
+          <a:xfrm>
+            <a:off x="411480" y="1298448"/>
+            <a:ext cx="5806440" cy="274320"/>
+          </a:xfrm>
+          <a:prstGeom prst="rect">
+            <a:avLst/>
+          </a:prstGeom>
+          <a:noFill/>
+        </p:spPr>
+        <p:txBody>
+          <a:bodyPr wrap="square">
+            <a:spAutoFit/>
+          </a:bodyPr>
+          <a:lstStyle/>
+          <a:p>
+            <a:pPr>
+              <a:spcAft>
+                <a:spcPts val="600"/>
+              </a:spcAft>
+            </a:pPr>
+            <a:r>
+              <a:rPr sz="1200" b="0">
+                <a:solidFill>
+                  <a:srgbClr val="282828"/>
+                </a:solidFill>
+                <a:latin typeface="Arial"/>
+              </a:rPr>
+              <a:t>•  Why a Twyman–Green for a DM: normal incidence (double pass, 2× sensitivity), a natural null against the flat reference, the fewest reference surfaces of any two-beam layout.  A Mach–Zehnder buys arm isolation, two ports and transmission testing — dynamics, not figure.</a:t>
+            </a:r>
+          </a:p>
+          <a:p>
+            <a:pPr>
+              <a:spcAft>
+                <a:spcPts val="600"/>
+              </a:spcAft>
+            </a:pPr>
+            <a:r>
+              <a:rPr sz="1200" b="0">
+                <a:solidFill>
+                  <a:srgbClr val="282828"/>
+                </a:solidFill>
+                <a:latin typeface="Arial"/>
+              </a:rPr>
+              <a:t>•  The polarization trick: the two arms carry orthogonal polarizations, so they cannot interfere until projected; an output quarter-wave plate makes them opposite circular, and an analyzer at angle θ then writes fringe phase 2θ.</a:t>
+            </a:r>
+          </a:p>
+          <a:p>
+            <a:pPr>
+              <a:spcAft>
+                <a:spcPts val="600"/>
+              </a:spcAft>
+            </a:pPr>
+            <a:r>
+              <a:rPr sz="1200" b="0">
+                <a:solidFill>
+                  <a:srgbClr val="282828"/>
+                </a:solidFill>
+                <a:latin typeface="Arial"/>
+              </a:rPr>
+              <a:t>•  Four analyzer angles — 0 / 45 / 90 / 135° — are the four phase steps of standard PSI, with nothing in the interferometer moving: the vibration immunity of polarization phase shifting.</a:t>
+            </a:r>
+          </a:p>
+          <a:p>
+            <a:pPr>
+              <a:spcAft>
+                <a:spcPts val="600"/>
+              </a:spcAft>
+            </a:pPr>
+            <a:r>
+              <a:rPr sz="1200" b="0">
+                <a:solidFill>
+                  <a:srgbClr val="282828"/>
+                </a:solidFill>
+                <a:latin typeface="Arial"/>
+              </a:rPr>
+              <a:t>•  The factor of two: DM surface height h enters the optical path as 2h at normal incidence; the recovery closes against the injected map with exactly that factor.</a:t>
+            </a:r>
+          </a:p>
+        </p:txBody>
+      </p:sp>
+      <p:pic>
+        <p:nvPicPr>
+          <p:cNvPr id="5" name="Picture 4" descr="demo_beat6_sweep.png"/>
+          <p:cNvPicPr>
+            <a:picLocks noChangeAspect="1"/>
+          </p:cNvPicPr>
+          <p:nvPr/>
+        </p:nvPicPr>
+        <p:blipFill>
+          <a:blip r:embed="rId2"/>
+          <a:stretch>
+            <a:fillRect/>
+          </a:stretch>
+        </p:blipFill>
+        <p:spPr>
+          <a:xfrm>
+            <a:off x="6400800" y="1298448"/>
+            <a:ext cx="5394960" cy="2517954"/>
+          </a:xfrm>
+          <a:prstGeom prst="rect">
+            <a:avLst/>
+          </a:prstGeom>
+        </p:spPr>
+      </p:pic>
+      <p:sp>
+        <p:nvSpPr>
+          <p:cNvPr id="6" name="TextBox 5"/>
+          <p:cNvSpPr txBox="1"/>
+          <p:nvPr/>
+        </p:nvSpPr>
+        <p:spPr>
+          <a:xfrm>
+            <a:off x="6400800" y="3834690"/>
+            <a:ext cx="5394960" cy="394208"/>
+          </a:xfrm>
+          <a:prstGeom prst="rect">
+            <a:avLst/>
+          </a:prstGeom>
+          <a:noFill/>
+        </p:spPr>
+        <p:txBody>
+          <a:bodyPr wrap="square">
+            <a:spAutoFit/>
+          </a:bodyPr>
+          <a:lstStyle/>
+          <a:p>
+            <a:pPr algn="ctr">
+              <a:spcAft>
+                <a:spcPts val="0"/>
+              </a:spcAft>
+            </a:pPr>
+            <a:r>
+              <a:rPr sz="1000" b="0">
+                <a:solidFill>
+                  <a:srgbClr val="6E6E6E"/>
+                </a:solidFill>
+                <a:latin typeface="Arial"/>
+              </a:rPr>
+              <a:t>The analyzer sweep on the poked DM: phase-stepped fringe frames — the phase walks, the rig stands still.</a:t>
+            </a:r>
+          </a:p>
+        </p:txBody>
+      </p:sp>
+      <p:sp>
+        <p:nvSpPr>
+          <p:cNvPr id="7" name="TextBox 6"/>
+          <p:cNvSpPr txBox="1"/>
+          <p:nvPr/>
+        </p:nvSpPr>
+        <p:spPr>
+          <a:xfrm>
+            <a:off x="6400800" y="4265474"/>
+            <a:ext cx="5394960" cy="274320"/>
+          </a:xfrm>
+          <a:prstGeom prst="rect">
+            <a:avLst/>
+          </a:prstGeom>
+          <a:noFill/>
+        </p:spPr>
+        <p:txBody>
+          <a:bodyPr wrap="square">
+            <a:spAutoFit/>
+          </a:bodyPr>
+          <a:lstStyle/>
+          <a:p>
+            <a:pPr>
+              <a:spcAft>
+                <a:spcPts val="600"/>
+              </a:spcAft>
+            </a:pPr>
+            <a:r>
+              <a:rPr sz="1050" b="0">
+                <a:solidFill>
+                  <a:srgbClr val="6E6E6E"/>
+                </a:solidFill>
+                <a:latin typeface="Arial"/>
+              </a:rPr>
+              <a:t>Topology ruling and full physics: the template README, templates/90_polarization/tg_psi_dm.</a:t>
+            </a:r>
+          </a:p>
+        </p:txBody>
+      </p:sp>
+    </p:spTree>
+  </p:cSld>
+  <p:clrMapOvr>
+    <a:masterClrMapping/>
+  </p:clrMapOvr>
+</p:sld>
+</file>
+
+<file path=ppt/slides/slide15.xml><?xml version="1.0" encoding="utf-8"?>
 <p:sld xmlns:a="http://schemas.openxmlformats.org/drawingml/2006/main" xmlns:p="http://schemas.openxmlformats.org/presentationml/2006/main" xmlns:r="http://schemas.openxmlformats.org/officeDocument/2006/relationships">
   <p:cSld>
     <p:spTree>
@@ -6721,7 +6933,7 @@
 </p:sld>
 </file>
 
-<file path=ppt/slides/slide15.xml><?xml version="1.0" encoding="utf-8"?>
+<file path=ppt/slides/slide16.xml><?xml version="1.0" encoding="utf-8"?>
 <p:sld xmlns:a="http://schemas.openxmlformats.org/drawingml/2006/main" xmlns:p="http://schemas.openxmlformats.org/presentationml/2006/main" xmlns:r="http://schemas.openxmlformats.org/officeDocument/2006/relationships">
   <p:cSld>
     <p:spTree>
@@ -7074,7 +7286,7 @@
 </p:sld>
 </file>
 
-<file path=ppt/slides/slide16.xml><?xml version="1.0" encoding="utf-8"?>
+<file path=ppt/slides/slide17.xml><?xml version="1.0" encoding="utf-8"?>
 <p:sld xmlns:a="http://schemas.openxmlformats.org/drawingml/2006/main" xmlns:p="http://schemas.openxmlformats.org/presentationml/2006/main" xmlns:r="http://schemas.openxmlformats.org/officeDocument/2006/relationships">
   <p:cSld>
     <p:spTree>
@@ -7846,7 +8058,7 @@
 </p:sld>
 </file>
 
-<file path=ppt/slides/slide17.xml><?xml version="1.0" encoding="utf-8"?>
+<file path=ppt/slides/slide18.xml><?xml version="1.0" encoding="utf-8"?>
 <p:sld xmlns:a="http://schemas.openxmlformats.org/drawingml/2006/main" xmlns:p="http://schemas.openxmlformats.org/presentationml/2006/main" xmlns:r="http://schemas.openxmlformats.org/officeDocument/2006/relationships">
   <p:cSld>
     <p:spTree>
@@ -8124,375 +8336,6 @@
                 <a:latin typeface="Arial"/>
               </a:rPr>
               <a:t>Same grid, annulus and normalization as the head-to-head; fixed-design markers read from the committed comparison, not re-scored.</a:t>
-            </a:r>
-          </a:p>
-        </p:txBody>
-      </p:sp>
-    </p:spTree>
-  </p:cSld>
-  <p:clrMapOvr>
-    <a:masterClrMapping/>
-  </p:clrMapOvr>
-</p:sld>
-</file>
-
-<file path=ppt/slides/slide18.xml><?xml version="1.0" encoding="utf-8"?>
-<p:sld xmlns:a="http://schemas.openxmlformats.org/drawingml/2006/main" xmlns:p="http://schemas.openxmlformats.org/presentationml/2006/main" xmlns:r="http://schemas.openxmlformats.org/officeDocument/2006/relationships">
-  <p:cSld>
-    <p:spTree>
-      <p:nvGrpSpPr>
-        <p:cNvPr id="1" name=""/>
-        <p:cNvGrpSpPr/>
-        <p:nvPr/>
-      </p:nvGrpSpPr>
-      <p:grpSpPr/>
-      <p:sp>
-        <p:nvSpPr>
-          <p:cNvPr id="2" name="TextBox 1"/>
-          <p:cNvSpPr txBox="1"/>
-          <p:nvPr/>
-        </p:nvSpPr>
-        <p:spPr>
-          <a:xfrm>
-            <a:off x="411480" y="201168"/>
-            <a:ext cx="11368735" cy="914400"/>
-          </a:xfrm>
-          <a:prstGeom prst="rect">
-            <a:avLst/>
-          </a:prstGeom>
-          <a:noFill/>
-        </p:spPr>
-        <p:txBody>
-          <a:bodyPr wrap="square">
-            <a:spAutoFit/>
-          </a:bodyPr>
-          <a:lstStyle/>
-          <a:p>
-            <a:pPr>
-              <a:spcAft>
-                <a:spcPts val="400"/>
-              </a:spcAft>
-            </a:pPr>
-            <a:r>
-              <a:rPr sz="2400" b="1">
-                <a:solidFill>
-                  <a:srgbClr val="1F4E79"/>
-                </a:solidFill>
-                <a:latin typeface="Arial"/>
-              </a:rPr>
-              <a:t>The mirrors close the loop</a:t>
-            </a:r>
-          </a:p>
-          <a:p>
-            <a:pPr>
-              <a:spcAft>
-                <a:spcPts val="0"/>
-              </a:spcAft>
-            </a:pPr>
-            <a:r>
-              <a:rPr sz="1250" b="0">
-                <a:solidFill>
-                  <a:srgbClr val="6E6E6E"/>
-                </a:solidFill>
-                <a:latin typeface="Arial"/>
-              </a:rPr>
-              <a:t>On the vortex chain: 1.7×10⁻⁸ → 6.8×10⁻¹⁵ — nothing left that the mirrors cannot remove</a:t>
-            </a:r>
-          </a:p>
-        </p:txBody>
-      </p:sp>
-      <p:sp>
-        <p:nvSpPr>
-          <p:cNvPr id="3" name="Rectangle 2"/>
-          <p:cNvSpPr/>
-          <p:nvPr/>
-        </p:nvSpPr>
-        <p:spPr>
-          <a:xfrm>
-            <a:off x="411480" y="1133856"/>
-            <a:ext cx="11368735" cy="20320"/>
-          </a:xfrm>
-          <a:prstGeom prst="rect">
-            <a:avLst/>
-          </a:prstGeom>
-          <a:solidFill>
-            <a:srgbClr val="B8C6D4"/>
-          </a:solidFill>
-          <a:ln>
-            <a:noFill/>
-          </a:ln>
-          <a:effectLst/>
-        </p:spPr>
-        <p:style>
-          <a:lnRef idx="1">
-            <a:schemeClr val="accent1"/>
-          </a:lnRef>
-          <a:fillRef idx="3">
-            <a:schemeClr val="accent1"/>
-          </a:fillRef>
-          <a:effectRef idx="2">
-            <a:schemeClr val="accent1"/>
-          </a:effectRef>
-          <a:fontRef idx="minor">
-            <a:schemeClr val="lt1"/>
-          </a:fontRef>
-        </p:style>
-        <p:txBody>
-          <a:bodyPr rtlCol="0" anchor="ctr"/>
-          <a:lstStyle/>
-          <a:p>
-            <a:pPr algn="ctr"/>
-          </a:p>
-        </p:txBody>
-      </p:sp>
-      <p:sp>
-        <p:nvSpPr>
-          <p:cNvPr id="4" name="TextBox 3"/>
-          <p:cNvSpPr txBox="1"/>
-          <p:nvPr/>
-        </p:nvSpPr>
-        <p:spPr>
-          <a:xfrm>
-            <a:off x="411480" y="1298448"/>
-            <a:ext cx="5806440" cy="274320"/>
-          </a:xfrm>
-          <a:prstGeom prst="rect">
-            <a:avLst/>
-          </a:prstGeom>
-          <a:noFill/>
-        </p:spPr>
-        <p:txBody>
-          <a:bodyPr wrap="square">
-            <a:spAutoFit/>
-          </a:bodyPr>
-          <a:lstStyle/>
-          <a:p>
-            <a:pPr>
-              <a:spcAft>
-                <a:spcPts val="600"/>
-              </a:spcAft>
-            </a:pPr>
-            <a:r>
-              <a:rPr sz="1200" b="0">
-                <a:solidFill>
-                  <a:srgbClr val="282828"/>
-                </a:solidFill>
-                <a:latin typeface="Arial"/>
-              </a:rPr>
-              <a:t>•  The control matrix is measured, not modeled: every actuator poked and propagated through the full masked chain, so the correction solve has no model error to exploit; each iteration re-propagates and scores the measured contrast.</a:t>
-            </a:r>
-          </a:p>
-          <a:p>
-            <a:pPr>
-              <a:spcAft>
-                <a:spcPts val="600"/>
-              </a:spcAft>
-            </a:pPr>
-            <a:r>
-              <a:rPr sz="1200" b="0">
-                <a:solidFill>
-                  <a:srgbClr val="282828"/>
-                </a:solidFill>
-                <a:latin typeface="Arial"/>
-              </a:rPr>
-              <a:t>•  Two chains, two kinds of floor: the hard occulter stops at 3.8×10⁻⁹ — physics, occulter-edge diffraction the mirrors cannot represent; the charge-4 vortex chain reaches 6.8×10⁻¹⁵ at half-nanometer strokes — the model's own double-precision floor.</a:t>
-            </a:r>
-          </a:p>
-          <a:p>
-            <a:pPr>
-              <a:spcAft>
-                <a:spcPts val="600"/>
-              </a:spcAft>
-            </a:pPr>
-            <a:r>
-              <a:rPr sz="1200" b="0">
-                <a:solidFill>
-                  <a:srgbClr val="282828"/>
-                </a:solidFill>
-                <a:latin typeface="Arial"/>
-              </a:rPr>
-              <a:t>•  The physics layers, measured: the coated train's polarization floor rides flat at 1.1×10⁻¹⁵ at every bandwidth (a state change, not an aberration); the chromatic floor grows gently when control sampling matches the band — 8×10⁻¹³ mono to 5.4×10⁻¹¹ at a 20% band.</a:t>
-            </a:r>
-          </a:p>
-          <a:p>
-            <a:pPr>
-              <a:spcAft>
-                <a:spcPts val="600"/>
-              </a:spcAft>
-            </a:pPr>
-            <a:r>
-              <a:rPr sz="1200" b="0">
-                <a:solidFill>
-                  <a:srgbClr val="282828"/>
-                </a:solidFill>
-                <a:latin typeface="Arial"/>
-              </a:rPr>
-              <a:t>•  The vector-vortex verdict: the zero-order plate's retardance leak is uncorrectable by any mirror but optically removable — a circular polarizer sandwich returns to the scalar floor under per-λ control; a crossed-linear sandwich goes decades deeper on the star, at the price of eight planet blind spots.</a:t>
-            </a:r>
-          </a:p>
-        </p:txBody>
-      </p:sp>
-      <p:pic>
-        <p:nvPicPr>
-          <p:cNvPr id="5" name="Picture 4" descr="ctb_efc_vortex.png"/>
-          <p:cNvPicPr>
-            <a:picLocks noChangeAspect="1"/>
-          </p:cNvPicPr>
-          <p:nvPr/>
-        </p:nvPicPr>
-        <p:blipFill>
-          <a:blip r:embed="rId2"/>
-          <a:stretch>
-            <a:fillRect/>
-          </a:stretch>
-        </p:blipFill>
-        <p:spPr>
-          <a:xfrm>
-            <a:off x="6400800" y="1298448"/>
-            <a:ext cx="5394960" cy="1205662"/>
-          </a:xfrm>
-          <a:prstGeom prst="rect">
-            <a:avLst/>
-          </a:prstGeom>
-        </p:spPr>
-      </p:pic>
-      <p:sp>
-        <p:nvSpPr>
-          <p:cNvPr id="6" name="TextBox 5"/>
-          <p:cNvSpPr txBox="1"/>
-          <p:nvPr/>
-        </p:nvSpPr>
-        <p:spPr>
-          <a:xfrm>
-            <a:off x="6400800" y="2522398"/>
-            <a:ext cx="5394960" cy="394208"/>
-          </a:xfrm>
-          <a:prstGeom prst="rect">
-            <a:avLst/>
-          </a:prstGeom>
-          <a:noFill/>
-        </p:spPr>
-        <p:txBody>
-          <a:bodyPr wrap="square">
-            <a:spAutoFit/>
-          </a:bodyPr>
-          <a:lstStyle/>
-          <a:p>
-            <a:pPr algn="ctr">
-              <a:spcAft>
-                <a:spcPts val="0"/>
-              </a:spcAft>
-            </a:pPr>
-            <a:r>
-              <a:rPr sz="1000" b="0">
-                <a:solidFill>
-                  <a:srgbClr val="6E6E6E"/>
-                </a:solidFill>
-                <a:latin typeface="Arial"/>
-              </a:rPr>
-              <a:t>The vortex-chain dark hole: before and after (color floor 10⁻¹⁴), convergence, and the sub-nanometer command maps.</a:t>
-            </a:r>
-          </a:p>
-        </p:txBody>
-      </p:sp>
-      <p:pic>
-        <p:nvPicPr>
-          <p:cNvPr id="7" name="Picture 6" descr="ctb_vortex_bandwidth.png"/>
-          <p:cNvPicPr>
-            <a:picLocks noChangeAspect="1"/>
-          </p:cNvPicPr>
-          <p:nvPr/>
-        </p:nvPicPr>
-        <p:blipFill>
-          <a:blip r:embed="rId3"/>
-          <a:stretch>
-            <a:fillRect/>
-          </a:stretch>
-        </p:blipFill>
-        <p:spPr>
-          <a:xfrm>
-            <a:off x="8011995" y="2953182"/>
-            <a:ext cx="2172568" cy="1617472"/>
-          </a:xfrm>
-          <a:prstGeom prst="rect">
-            <a:avLst/>
-          </a:prstGeom>
-        </p:spPr>
-      </p:pic>
-      <p:sp>
-        <p:nvSpPr>
-          <p:cNvPr id="8" name="TextBox 7"/>
-          <p:cNvSpPr txBox="1"/>
-          <p:nvPr/>
-        </p:nvSpPr>
-        <p:spPr>
-          <a:xfrm>
-            <a:off x="6400800" y="4588942"/>
-            <a:ext cx="5394960" cy="394208"/>
-          </a:xfrm>
-          <a:prstGeom prst="rect">
-            <a:avLst/>
-          </a:prstGeom>
-          <a:noFill/>
-        </p:spPr>
-        <p:txBody>
-          <a:bodyPr wrap="square">
-            <a:spAutoFit/>
-          </a:bodyPr>
-          <a:lstStyle/>
-          <a:p>
-            <a:pPr algn="ctr">
-              <a:spcAft>
-                <a:spcPts val="0"/>
-              </a:spcAft>
-            </a:pPr>
-            <a:r>
-              <a:rPr sz="1000" b="0">
-                <a:solidFill>
-                  <a:srgbClr val="6E6E6E"/>
-                </a:solidFill>
-                <a:latin typeface="Arial"/>
-              </a:rPr>
-              <a:t>The bandwidth map: static, closed-loop floor, and the flat polarization floor at each band.</a:t>
-            </a:r>
-          </a:p>
-        </p:txBody>
-      </p:sp>
-      <p:sp>
-        <p:nvSpPr>
-          <p:cNvPr id="9" name="TextBox 8"/>
-          <p:cNvSpPr txBox="1"/>
-          <p:nvPr/>
-        </p:nvSpPr>
-        <p:spPr>
-          <a:xfrm>
-            <a:off x="6400800" y="5019726"/>
-            <a:ext cx="5394960" cy="274320"/>
-          </a:xfrm>
-          <a:prstGeom prst="rect">
-            <a:avLst/>
-          </a:prstGeom>
-          <a:noFill/>
-        </p:spPr>
-        <p:txBody>
-          <a:bodyPr wrap="square">
-            <a:spAutoFit/>
-          </a:bodyPr>
-          <a:lstStyle/>
-          <a:p>
-            <a:pPr>
-              <a:spcAft>
-                <a:spcPts val="600"/>
-              </a:spcAft>
-            </a:pPr>
-            <a:r>
-              <a:rPr sz="1050" b="0">
-                <a:solidFill>
-                  <a:srgbClr val="6E6E6E"/>
-                </a:solidFill>
-                <a:latin typeface="Arial"/>
-              </a:rPr>
-              <a:t>6.8×10⁻¹⁵ = dark-zone mean 3–15 λ/D, Strehl-normalized, monochromatic, noiseless sensing — the numerical floor of the noiseless model, not a hardware prediction.  Next layer of realism: camera-based sensing (pairwise probing), then FALCO driving the same DMs.</a:t>
             </a:r>
           </a:p>
         </p:txBody>
@@ -8549,7 +8392,7 @@
                 </a:solidFill>
                 <a:latin typeface="Arial"/>
               </a:rPr>
-              <a:t>From the testbed to an observatory</a:t>
+              <a:t>The mirrors close the loop</a:t>
             </a:r>
           </a:p>
           <a:p>
@@ -8565,7 +8408,7 @@
                 </a:solidFill>
                 <a:latin typeface="Arial"/>
               </a:rPr>
-              <a:t>The proven coronagraph modeling, carried onto a telescope designed for it</a:t>
+              <a:t>On the vortex chain: 1.7×10⁻⁸ → 6.8×10⁻¹⁵ — nothing left that the mirrors cannot remove</a:t>
             </a:r>
           </a:p>
         </p:txBody>
@@ -8623,7 +8466,7 @@
         <p:spPr>
           <a:xfrm>
             <a:off x="411480" y="1298448"/>
-            <a:ext cx="11368735" cy="274320"/>
+            <a:ext cx="5806440" cy="274320"/>
           </a:xfrm>
           <a:prstGeom prst="rect">
             <a:avLst/>
@@ -8642,20 +8485,68 @@
               </a:spcAft>
             </a:pPr>
             <a:r>
-              <a:rPr sz="1500" b="0">
+              <a:rPr sz="1200" b="0">
                 <a:solidFill>
                   <a:srgbClr val="282828"/>
                 </a:solidFill>
                 <a:latin typeface="Arial"/>
               </a:rPr>
-              <a:t>•  The testbed is where the models are built and proven; the same modeling then builds the flight-like system: an unobscured 6 m telescope from the design-layer templates — imaging leg and coronagraph leg, with the same DMs, apodizer, focal-plane mask and Lyot machinery — packaged to an 8 m launch shroud, drawn and checked.</a:t>
+              <a:t>•  The control matrix is measured, not modeled: every actuator poked and propagated through the full masked chain, so the correction solve has no model error to exploit; each iteration re-propagates and scores the measured contrast.</a:t>
+            </a:r>
+          </a:p>
+          <a:p>
+            <a:pPr>
+              <a:spcAft>
+                <a:spcPts val="600"/>
+              </a:spcAft>
+            </a:pPr>
+            <a:r>
+              <a:rPr sz="1200" b="0">
+                <a:solidFill>
+                  <a:srgbClr val="282828"/>
+                </a:solidFill>
+                <a:latin typeface="Arial"/>
+              </a:rPr>
+              <a:t>•  Two chains, two kinds of floor: the hard occulter stops at 3.8×10⁻⁹ — physics, occulter-edge diffraction the mirrors cannot represent; the charge-4 vortex chain reaches 6.8×10⁻¹⁵ at half-nanometer strokes — the model's own double-precision floor.</a:t>
+            </a:r>
+          </a:p>
+          <a:p>
+            <a:pPr>
+              <a:spcAft>
+                <a:spcPts val="600"/>
+              </a:spcAft>
+            </a:pPr>
+            <a:r>
+              <a:rPr sz="1200" b="0">
+                <a:solidFill>
+                  <a:srgbClr val="282828"/>
+                </a:solidFill>
+                <a:latin typeface="Arial"/>
+              </a:rPr>
+              <a:t>•  The physics layers, measured: the coated train's polarization floor rides flat at 1.1×10⁻¹⁵ at every bandwidth (a state change, not an aberration); the chromatic floor grows gently when control sampling matches the band — 8×10⁻¹³ mono to 5.4×10⁻¹¹ at a 20% band.</a:t>
+            </a:r>
+          </a:p>
+          <a:p>
+            <a:pPr>
+              <a:spcAft>
+                <a:spcPts val="600"/>
+              </a:spcAft>
+            </a:pPr>
+            <a:r>
+              <a:rPr sz="1200" b="0">
+                <a:solidFill>
+                  <a:srgbClr val="282828"/>
+                </a:solidFill>
+                <a:latin typeface="Arial"/>
+              </a:rPr>
+              <a:t>•  The vector-vortex verdict: the zero-order plate's retardance leak is uncorrectable by any mirror but optically removable — a circular polarizer sandwich returns to the scalar floor under per-λ control; a crossed-linear sandwich goes decades deeper on the star, at the price of eight planet blind spots.</a:t>
             </a:r>
           </a:p>
         </p:txBody>
       </p:sp>
       <p:pic>
         <p:nvPicPr>
-          <p:cNvPr id="5" name="Picture 4" descr="r2_sequence.png"/>
+          <p:cNvPr id="5" name="Picture 4" descr="ctb_efc_vortex.png"/>
           <p:cNvPicPr>
             <a:picLocks noChangeAspect="1"/>
           </p:cNvPicPr>
@@ -8669,8 +8560,8 @@
         </p:blipFill>
         <p:spPr>
           <a:xfrm>
-            <a:off x="1328979" y="2218182"/>
-            <a:ext cx="3971440" cy="1343152"/>
+            <a:off x="6400800" y="1298448"/>
+            <a:ext cx="5394960" cy="1205662"/>
           </a:xfrm>
           <a:prstGeom prst="rect">
             <a:avLst/>
@@ -8685,8 +8576,8 @@
         </p:nvSpPr>
         <p:spPr>
           <a:xfrm>
-            <a:off x="411480" y="3579622"/>
-            <a:ext cx="5806440" cy="394208"/>
+            <a:off x="6400800" y="2522398"/>
+            <a:ext cx="5394960" cy="394208"/>
           </a:xfrm>
           <a:prstGeom prst="rect">
             <a:avLst/>
@@ -8711,14 +8602,14 @@
                 </a:solidFill>
                 <a:latin typeface="Arial"/>
               </a:rPr>
-              <a:t>The light order, both instruments: the shared trunk, the deployable-pick-off imager leg, and the DM-bearing coronagraph leg.</a:t>
+              <a:t>The vortex-chain dark hole: before and after (color floor 10⁻¹⁴), convergence, and the sub-nanometer command maps.</a:t>
             </a:r>
           </a:p>
         </p:txBody>
       </p:sp>
       <p:pic>
         <p:nvPicPr>
-          <p:cNvPr id="7" name="Picture 6" descr="r1_seg_d110_shroud.png"/>
+          <p:cNvPr id="7" name="Picture 6" descr="ctb_vortex_bandwidth.png"/>
           <p:cNvPicPr>
             <a:picLocks noChangeAspect="1"/>
           </p:cNvPicPr>
@@ -8732,8 +8623,8 @@
         </p:blipFill>
         <p:spPr>
           <a:xfrm>
-            <a:off x="7536686" y="2218182"/>
-            <a:ext cx="3123186" cy="2257552"/>
+            <a:off x="8011995" y="2953182"/>
+            <a:ext cx="2172568" cy="1617472"/>
           </a:xfrm>
           <a:prstGeom prst="rect">
             <a:avLst/>
@@ -8748,7 +8639,7 @@
         </p:nvSpPr>
         <p:spPr>
           <a:xfrm>
-            <a:off x="6400800" y="4494022"/>
+            <a:off x="6400800" y="4588942"/>
             <a:ext cx="5394960" cy="394208"/>
           </a:xfrm>
           <a:prstGeom prst="rect">
@@ -8774,7 +8665,7 @@
                 </a:solidFill>
                 <a:latin typeface="Arial"/>
               </a:rPr>
-              <a:t>End-on in the shroud: the hex-19 telescope and instrument legs — hardware union 7.451 m against the 8.0 m gate.</a:t>
+              <a:t>The bandwidth map: static, closed-loop floor, and the flat polarization floor at each band.</a:t>
             </a:r>
           </a:p>
         </p:txBody>
@@ -8787,7 +8678,7 @@
         </p:nvSpPr>
         <p:spPr>
           <a:xfrm>
-            <a:off x="6400800" y="4924806"/>
+            <a:off x="6400800" y="5019726"/>
             <a:ext cx="5394960" cy="274320"/>
           </a:xfrm>
           <a:prstGeom prst="rect">
@@ -8813,7 +8704,7 @@
                 </a:solidFill>
                 <a:latin typeface="Arial"/>
               </a:rPr>
-              <a:t>The telescope is one of the design-layer templates, diffraction-limited at 500 nm (imaging-leg Strehl 0.9993).  Record: templates/80_end_to_end/e2e6m_r2.</a:t>
+              <a:t>6.8×10⁻¹⁵ = dark-zone mean 3–15 λ/D, Strehl-normalized, monochromatic, noiseless sensing — the numerical floor of the noiseless model, not a hardware prediction.  Next layer of realism: camera-based sensing (pairwise probing), then FALCO driving the same DMs.</a:t>
             </a:r>
           </a:p>
         </p:txBody>
@@ -9218,7 +9109,7 @@
                 </a:solidFill>
                 <a:latin typeface="Arial"/>
               </a:rPr>
-              <a:t>Segmentation, metrology, controls — on the observatory</a:t>
+              <a:t>From the testbed to an observatory</a:t>
             </a:r>
           </a:p>
           <a:p>
@@ -9234,7 +9125,7 @@
                 </a:solidFill>
                 <a:latin typeface="Arial"/>
               </a:rPr>
-              <a:t>The same segmentation and metrology machinery the smaller studies proved, at 6 m scale</a:t>
+              <a:t>The proven coronagraph modeling, carried onto a telescope designed for it</a:t>
             </a:r>
           </a:p>
         </p:txBody>
@@ -9292,7 +9183,7 @@
         <p:spPr>
           <a:xfrm>
             <a:off x="411480" y="1298448"/>
-            <a:ext cx="5806440" cy="274320"/>
+            <a:ext cx="11368735" cy="274320"/>
           </a:xfrm>
           <a:prstGeom prst="rect">
             <a:avLst/>
@@ -9311,36 +9202,20 @@
               </a:spcAft>
             </a:pPr>
             <a:r>
-              <a:rPr sz="1200" b="0">
+              <a:rPr sz="1500" b="0">
                 <a:solidFill>
                   <a:srgbClr val="282828"/>
                 </a:solidFill>
                 <a:latin typeface="Arial"/>
               </a:rPr>
-              <a:t>•  The primary segments hex-19 with physical apertures through the same segmentation product; every segment gets rigid-body and surface-figure sensitivity channels, stacked into one Jacobian — the control basis.</a:t>
-            </a:r>
-          </a:p>
-          <a:p>
-            <a:pPr>
-              <a:spcAft>
-                <a:spcPts val="600"/>
-              </a:spcAft>
-            </a:pPr>
-            <a:r>
-              <a:rPr sz="1200" b="0">
-                <a:solidFill>
-                  <a:srgbClr val="282828"/>
-                </a:solidFill>
-                <a:latin typeface="Arial"/>
-              </a:rPr>
-              <a:t>•  Metrology and edge sensors are designed ON that Jacobian — 114 beams from the launcher stations shown — and the same matrices drive the estimator and the closed loop.</a:t>
+              <a:t>•  The testbed is where the models are built and proven; the same modeling then builds the flight-like system: an unobscured 6 m telescope from the design-layer templates — imaging leg and coronagraph leg, with the same DMs, apodizer, focal-plane mask and Lyot machinery — packaged to an 8 m launch shroud, drawn and checked.</a:t>
             </a:r>
           </a:p>
         </p:txBody>
       </p:sp>
       <p:pic>
         <p:nvPicPr>
-          <p:cNvPr id="5" name="Picture 4" descr="r3_met_view_rx.png"/>
+          <p:cNvPr id="5" name="Picture 4" descr="r2_sequence.png"/>
           <p:cNvPicPr>
             <a:picLocks noChangeAspect="1"/>
           </p:cNvPicPr>
@@ -9354,8 +9229,8 @@
         </p:blipFill>
         <p:spPr>
           <a:xfrm>
-            <a:off x="7579124" y="1298448"/>
-            <a:ext cx="3038311" cy="1983232"/>
+            <a:off x="1328979" y="2218182"/>
+            <a:ext cx="3971440" cy="1343152"/>
           </a:xfrm>
           <a:prstGeom prst="rect">
             <a:avLst/>
@@ -9370,8 +9245,8 @@
         </p:nvSpPr>
         <p:spPr>
           <a:xfrm>
-            <a:off x="6400800" y="3299968"/>
-            <a:ext cx="5394960" cy="394208"/>
+            <a:off x="411480" y="3579622"/>
+            <a:ext cx="5806440" cy="394208"/>
           </a:xfrm>
           <a:prstGeom prst="rect">
             <a:avLst/>
@@ -9396,14 +9271,14 @@
                 </a:solidFill>
                 <a:latin typeface="Arial"/>
               </a:rPr>
-              <a:t>The metrology on the observatory: 24 elements, 114 MET beams to the aft launcher station.</a:t>
+              <a:t>The light order, both instruments: the shared trunk, the deployable-pick-off imager leg, and the DM-bearing coronagraph leg.</a:t>
             </a:r>
           </a:p>
         </p:txBody>
       </p:sp>
       <p:pic>
         <p:nvPicPr>
-          <p:cNvPr id="7" name="Picture 6" descr="r3_dwdx_channels.png"/>
+          <p:cNvPr id="7" name="Picture 6" descr="r1_seg_d110_shroud.png"/>
           <p:cNvPicPr>
             <a:picLocks noChangeAspect="1"/>
           </p:cNvPicPr>
@@ -9417,8 +9292,8 @@
         </p:blipFill>
         <p:spPr>
           <a:xfrm>
-            <a:off x="8314811" y="3730752"/>
-            <a:ext cx="1566937" cy="1553972"/>
+            <a:off x="7536686" y="2218182"/>
+            <a:ext cx="3123186" cy="2257552"/>
           </a:xfrm>
           <a:prstGeom prst="rect">
             <a:avLst/>
@@ -9433,8 +9308,8 @@
         </p:nvSpPr>
         <p:spPr>
           <a:xfrm>
-            <a:off x="6400800" y="5303012"/>
-            <a:ext cx="5394960" cy="229107"/>
+            <a:off x="6400800" y="4494022"/>
+            <a:ext cx="5394960" cy="394208"/>
           </a:xfrm>
           <a:prstGeom prst="rect">
             <a:avLst/>
@@ -9459,7 +9334,7 @@
                 </a:solidFill>
                 <a:latin typeface="Arial"/>
               </a:rPr>
-              <a:t>Per-segment wavefront sensitivity channels — the control basis.</a:t>
+              <a:t>End-on in the shroud: the hex-19 telescope and instrument legs — hardware union 7.451 m against the 8.0 m gate.</a:t>
             </a:r>
           </a:p>
         </p:txBody>
@@ -9472,7 +9347,7 @@
         </p:nvSpPr>
         <p:spPr>
           <a:xfrm>
-            <a:off x="6400800" y="5568696"/>
+            <a:off x="6400800" y="4924806"/>
             <a:ext cx="5394960" cy="274320"/>
           </a:xfrm>
           <a:prstGeom prst="rect">
@@ -9498,7 +9373,7 @@
                 </a:solidFill>
                 <a:latin typeface="Arial"/>
               </a:rPr>
-              <a:t>Record: templates/80_end_to_end/e2e6m_r2, sensitivities + MET stages.</a:t>
+              <a:t>The telescope is one of the design-layer templates, diffraction-limited at 500 nm (imaging-leg Strehl 0.9993).  Record: templates/80_end_to_end/e2e6m_r2.</a:t>
             </a:r>
           </a:p>
         </p:txBody>
@@ -9555,7 +9430,7 @@
                 </a:solidFill>
                 <a:latin typeface="Arial"/>
               </a:rPr>
-              <a:t>A randomly disturbed observatory, simulated</a:t>
+              <a:t>Segmentation, metrology, controls — on the observatory</a:t>
             </a:r>
           </a:p>
           <a:p>
@@ -9571,7 +9446,7 @@
                 </a:solidFill>
                 <a:latin typeface="Arial"/>
               </a:rPr>
-              <a:t>The closed loop holds dark-zone contrast at 2.5×10⁻⁷ where the uncontrolled series drifts to 1.7×10⁻⁶</a:t>
+              <a:t>The same segmentation and metrology machinery the smaller studies proved, at 6 m scale</a:t>
             </a:r>
           </a:p>
         </p:txBody>
@@ -9654,7 +9529,7 @@
                 </a:solidFill>
                 <a:latin typeface="Arial"/>
               </a:rPr>
-              <a:t>•  Random segment drift is injected; the rigid-body loop senses through the designed metrology, estimates and corrects, while EFC re-solves the dark zone per scored frame — all on one model.</a:t>
+              <a:t>•  The primary segments hex-19 with physical apertures through the same segmentation product; every segment gets rigid-body and surface-figure sensitivity channels, stacked into one Jacobian — the control basis.</a:t>
             </a:r>
           </a:p>
           <a:p>
@@ -9670,30 +9545,14 @@
                 </a:solidFill>
                 <a:latin typeface="Arial"/>
               </a:rPr>
-              <a:t>•  The disturbance interface is the point: the same channels are built to ingest dynamical- and thermal-model time histories — simulating performance in the space environment.  Work in progress.</a:t>
-            </a:r>
-          </a:p>
-          <a:p>
-            <a:pPr>
-              <a:spcAft>
-                <a:spcPts val="600"/>
-              </a:spcAft>
-            </a:pPr>
-            <a:r>
-              <a:rPr sz="1200" b="0">
-                <a:solidFill>
-                  <a:srgbClr val="282828"/>
-                </a:solidFill>
-                <a:latin typeface="Arial"/>
-              </a:rPr>
-              <a:t>•  Honest gap, attributed: the segmented-pupil contrast floor sits above the clear-pupil testbed's — the gaps and edges carry it, not the control.</a:t>
+              <a:t>•  Metrology and edge sensors are designed ON that Jacobian — 114 beams from the launcher stations shown — and the same matrices drive the estimator and the closed loop.</a:t>
             </a:r>
           </a:p>
         </p:txBody>
       </p:sp>
       <p:pic>
         <p:nvPicPr>
-          <p:cNvPr id="5" name="Picture 4" descr="r4_series_3nm.png"/>
+          <p:cNvPr id="5" name="Picture 4" descr="r3_met_view_rx.png"/>
           <p:cNvPicPr>
             <a:picLocks noChangeAspect="1"/>
           </p:cNvPicPr>
@@ -9707,8 +9566,8 @@
         </p:blipFill>
         <p:spPr>
           <a:xfrm>
-            <a:off x="7589880" y="1298448"/>
-            <a:ext cx="3016798" cy="2897632"/>
+            <a:off x="7579124" y="1298448"/>
+            <a:ext cx="3038311" cy="1983232"/>
           </a:xfrm>
           <a:prstGeom prst="rect">
             <a:avLst/>
@@ -9723,7 +9582,7 @@
         </p:nvSpPr>
         <p:spPr>
           <a:xfrm>
-            <a:off x="6400800" y="4214367"/>
+            <a:off x="6400800" y="3299968"/>
             <a:ext cx="5394960" cy="394208"/>
           </a:xfrm>
           <a:prstGeom prst="rect">
@@ -9749,21 +9608,45 @@
                 </a:solidFill>
                 <a:latin typeface="Arial"/>
               </a:rPr>
-              <a:t>Four hundred seconds under drift: segment rigid-body state, wavefront at the coronagraph exit pupil, and science-plane contrast — open loop against closed.</a:t>
-            </a:r>
-          </a:p>
-        </p:txBody>
-      </p:sp>
-      <p:sp>
-        <p:nvSpPr>
-          <p:cNvPr id="7" name="TextBox 6"/>
+              <a:t>The metrology on the observatory: 24 elements, 114 MET beams to the aft launcher station.</a:t>
+            </a:r>
+          </a:p>
+        </p:txBody>
+      </p:sp>
+      <p:pic>
+        <p:nvPicPr>
+          <p:cNvPr id="7" name="Picture 6" descr="r3_dwdx_channels.png"/>
+          <p:cNvPicPr>
+            <a:picLocks noChangeAspect="1"/>
+          </p:cNvPicPr>
+          <p:nvPr/>
+        </p:nvPicPr>
+        <p:blipFill>
+          <a:blip r:embed="rId3"/>
+          <a:stretch>
+            <a:fillRect/>
+          </a:stretch>
+        </p:blipFill>
+        <p:spPr>
+          <a:xfrm>
+            <a:off x="8314811" y="3730752"/>
+            <a:ext cx="1566937" cy="1553972"/>
+          </a:xfrm>
+          <a:prstGeom prst="rect">
+            <a:avLst/>
+          </a:prstGeom>
+        </p:spPr>
+      </p:pic>
+      <p:sp>
+        <p:nvSpPr>
+          <p:cNvPr id="8" name="TextBox 7"/>
           <p:cNvSpPr txBox="1"/>
           <p:nvPr/>
         </p:nvSpPr>
         <p:spPr>
           <a:xfrm>
-            <a:off x="6400800" y="4645152"/>
-            <a:ext cx="5394960" cy="274320"/>
+            <a:off x="6400800" y="5303012"/>
+            <a:ext cx="5394960" cy="229107"/>
           </a:xfrm>
           <a:prstGeom prst="rect">
             <a:avLst/>
@@ -9776,6 +9659,45 @@
           </a:bodyPr>
           <a:lstStyle/>
           <a:p>
+            <a:pPr algn="ctr">
+              <a:spcAft>
+                <a:spcPts val="0"/>
+              </a:spcAft>
+            </a:pPr>
+            <a:r>
+              <a:rPr sz="1000" b="0">
+                <a:solidFill>
+                  <a:srgbClr val="6E6E6E"/>
+                </a:solidFill>
+                <a:latin typeface="Arial"/>
+              </a:rPr>
+              <a:t>Per-segment wavefront sensitivity channels — the control basis.</a:t>
+            </a:r>
+          </a:p>
+        </p:txBody>
+      </p:sp>
+      <p:sp>
+        <p:nvSpPr>
+          <p:cNvPr id="9" name="TextBox 8"/>
+          <p:cNvSpPr txBox="1"/>
+          <p:nvPr/>
+        </p:nvSpPr>
+        <p:spPr>
+          <a:xfrm>
+            <a:off x="6400800" y="5568696"/>
+            <a:ext cx="5394960" cy="274320"/>
+          </a:xfrm>
+          <a:prstGeom prst="rect">
+            <a:avLst/>
+          </a:prstGeom>
+          <a:noFill/>
+        </p:spPr>
+        <p:txBody>
+          <a:bodyPr wrap="square">
+            <a:spAutoFit/>
+          </a:bodyPr>
+          <a:lstStyle/>
+          <a:p>
             <a:pPr>
               <a:spcAft>
                 <a:spcPts val="600"/>
@@ -9788,7 +9710,7 @@
                 </a:solidFill>
                 <a:latin typeface="Arial"/>
               </a:rPr>
-              <a:t>Record: templates/80_end_to_end/e2e6m_r2, time-series stage.</a:t>
+              <a:t>Record: templates/80_end_to_end/e2e6m_r2, sensitivities + MET stages.</a:t>
             </a:r>
           </a:p>
         </p:txBody>
@@ -9845,7 +9767,7 @@
                 </a:solidFill>
                 <a:latin typeface="Arial"/>
               </a:rPr>
-              <a:t>The live design, revealed</a:t>
+              <a:t>A randomly disturbed observatory, simulated</a:t>
             </a:r>
           </a:p>
           <a:p>
@@ -9861,7 +9783,7 @@
                 </a:solidFill>
                 <a:latin typeface="Arial"/>
               </a:rPr>
-              <a:t>Predicted from the frontier before solving; solved in one warm-started step while we talked</a:t>
+              <a:t>The closed loop holds dark-zone contrast at 2.5×10⁻⁷ where the uncontrolled series drifts to 1.7×10⁻⁶</a:t>
             </a:r>
           </a:p>
         </p:txBody>
@@ -9944,7 +9866,7 @@
                 </a:solidFill>
                 <a:latin typeface="Arial"/>
               </a:rPr>
-              <a:t>•  The ask: a field-box width, anywhere in 5–15°.  The prediction, stated before the solve: interpolated from the committed frontier rows.</a:t>
+              <a:t>•  Random segment drift is injected; the rigid-body loop senses through the designed metrology, estimates and corrects, while EFC re-solves the dark zone per scored frame — all on one model.</a:t>
             </a:r>
           </a:p>
           <a:p>
@@ -9960,7 +9882,7 @@
                 </a:solidFill>
                 <a:latin typeface="Arial"/>
               </a:rPr>
-              <a:t>•  The pre-run rehearsal of the default ask (12°): predicted 33.7 nm; solved 33.6 nm — 1.00× — at a 24.9 mm clearance floor, both checks pass, in 15 minutes.</a:t>
+              <a:t>•  The disturbance interface is the point: the same channels are built to ingest dynamical- and thermal-model time histories — simulating performance in the space environment.  Work in progress.</a:t>
             </a:r>
           </a:p>
           <a:p>
@@ -9976,14 +9898,14 @@
                 </a:solidFill>
                 <a:latin typeface="Arial"/>
               </a:rPr>
-              <a:t>•  The run is deterministic to every printed digit, and every ask is a genuine continuation step — never a re-score of a stored design.</a:t>
+              <a:t>•  Honest gap, attributed: the segmented-pupil contrast floor sits above the clear-pupil testbed's — the gaps and edges carry it, not the control.</a:t>
             </a:r>
           </a:p>
         </p:txBody>
       </p:sp>
       <p:pic>
         <p:nvPicPr>
-          <p:cNvPr id="5" name="Picture 4" descr="oi_demo_12deg_layout.png"/>
+          <p:cNvPr id="5" name="Picture 4" descr="r4_series_3nm.png"/>
           <p:cNvPicPr>
             <a:picLocks noChangeAspect="1"/>
           </p:cNvPicPr>
@@ -9997,8 +9919,8 @@
         </p:blipFill>
         <p:spPr>
           <a:xfrm>
-            <a:off x="8000103" y="1298448"/>
-            <a:ext cx="2196352" cy="1891792"/>
+            <a:off x="7589880" y="1298448"/>
+            <a:ext cx="3016798" cy="2897632"/>
           </a:xfrm>
           <a:prstGeom prst="rect">
             <a:avLst/>
@@ -10013,7 +9935,7 @@
         </p:nvSpPr>
         <p:spPr>
           <a:xfrm>
-            <a:off x="6400800" y="3208528"/>
+            <a:off x="6400800" y="4214367"/>
             <a:ext cx="5394960" cy="394208"/>
           </a:xfrm>
           <a:prstGeom prst="rect">
@@ -10039,44 +9961,20 @@
                 </a:solidFill>
                 <a:latin typeface="Arial"/>
               </a:rPr>
-              <a:t>The 12° rehearsal design and its field map: 33.6 nm max against a 33.7 nm prediction.</a:t>
-            </a:r>
-          </a:p>
-        </p:txBody>
-      </p:sp>
-      <p:pic>
-        <p:nvPicPr>
-          <p:cNvPr id="7" name="Picture 6" descr="oi_demo_12deg_map.png"/>
-          <p:cNvPicPr>
-            <a:picLocks noChangeAspect="1"/>
-          </p:cNvPicPr>
-          <p:nvPr/>
-        </p:nvPicPr>
-        <p:blipFill>
-          <a:blip r:embed="rId3"/>
-          <a:stretch>
-            <a:fillRect/>
-          </a:stretch>
-        </p:blipFill>
-        <p:spPr>
-          <a:xfrm>
-            <a:off x="7951092" y="3639312"/>
-            <a:ext cx="2294375" cy="2011680"/>
-          </a:xfrm>
-          <a:prstGeom prst="rect">
-            <a:avLst/>
-          </a:prstGeom>
-        </p:spPr>
-      </p:pic>
-      <p:sp>
-        <p:nvSpPr>
-          <p:cNvPr id="8" name="TextBox 7"/>
+              <a:t>Four hundred seconds under drift: segment rigid-body state, wavefront at the coronagraph exit pupil, and science-plane contrast — open loop against closed.</a:t>
+            </a:r>
+          </a:p>
+        </p:txBody>
+      </p:sp>
+      <p:sp>
+        <p:nvSpPr>
+          <p:cNvPr id="7" name="TextBox 6"/>
           <p:cNvSpPr txBox="1"/>
           <p:nvPr/>
         </p:nvSpPr>
         <p:spPr>
           <a:xfrm>
-            <a:off x="6400800" y="5650992"/>
+            <a:off x="6400800" y="4645152"/>
             <a:ext cx="5394960" cy="274320"/>
           </a:xfrm>
           <a:prstGeom prst="rect">
@@ -10102,7 +10000,7 @@
                 </a:solidFill>
                 <a:latin typeface="Arial"/>
               </a:rPr>
-              <a:t>On demo day the live run's figures replace these panels; this pre-generated bundle is the fallback if the room's ask matches nothing better.</a:t>
+              <a:t>Record: templates/80_end_to_end/e2e6m_r2, time-series stage.</a:t>
             </a:r>
           </a:p>
         </p:txBody>
@@ -10159,7 +10057,7 @@
                 </a:solidFill>
                 <a:latin typeface="Arial"/>
               </a:rPr>
-              <a:t>AI in design and analysis — the working questions</a:t>
+              <a:t>The live design, revealed</a:t>
             </a:r>
           </a:p>
           <a:p>
@@ -10175,7 +10073,7 @@
                 </a:solidFill>
                 <a:latin typeface="Arial"/>
               </a:rPr>
-              <a:t>What we ask of an AI-driven study before believing it</a:t>
+              <a:t>Predicted from the frontier before solving; solved in one warm-started step while we talked</a:t>
             </a:r>
           </a:p>
         </p:txBody>
@@ -10233,7 +10131,7 @@
         <p:spPr>
           <a:xfrm>
             <a:off x="411480" y="1298448"/>
-            <a:ext cx="11368735" cy="274320"/>
+            <a:ext cx="5806440" cy="274320"/>
           </a:xfrm>
           <a:prstGeom prst="rect">
             <a:avLst/>
@@ -10252,13 +10150,13 @@
               </a:spcAft>
             </a:pPr>
             <a:r>
-              <a:rPr sz="1500" b="0">
+              <a:rPr sz="1200" b="0">
                 <a:solidFill>
                   <a:srgbClr val="282828"/>
                 </a:solidFill>
                 <a:latin typeface="Arial"/>
               </a:rPr>
-              <a:t>•  How is a result verified when the designer is a machine?  Here: regression checks with negative controls, layout figures read against every claim, and corrected signed measures — the checks caught the errors shown today.</a:t>
+              <a:t>•  The ask: a field-box width, anywhere in 5–15°.  The prediction, stated before the solve: interpolated from the committed frontier rows.</a:t>
             </a:r>
           </a:p>
           <a:p>
@@ -10268,13 +10166,13 @@
               </a:spcAft>
             </a:pPr>
             <a:r>
-              <a:rPr sz="1500" b="0">
+              <a:rPr sz="1200" b="0">
                 <a:solidFill>
                   <a:srgbClr val="282828"/>
                 </a:solidFill>
                 <a:latin typeface="Arial"/>
               </a:rPr>
-              <a:t>•  Where does the human rule?  Constraint choices, metric definitions, and every outward claim carry a human sign-off; the AI proposes, the record decides.</a:t>
+              <a:t>•  The pre-run rehearsal of the default ask (12°): predicted 33.7 nm; solved 33.6 nm — 1.00× — at a 24.9 mm clearance floor, both checks pass, in 15 minutes.</a:t>
             </a:r>
           </a:p>
           <a:p>
@@ -10284,27 +10182,51 @@
               </a:spcAft>
             </a:pPr>
             <a:r>
-              <a:rPr sz="1500" b="0">
+              <a:rPr sz="1200" b="0">
                 <a:solidFill>
                   <a:srgbClr val="282828"/>
                 </a:solidFill>
                 <a:latin typeface="Arial"/>
               </a:rPr>
-              <a:t>•  Is it reproducible?  Every number in this deck rebuilds from committed scripts and committed records — including the design solved during this talk.</a:t>
-            </a:r>
-          </a:p>
-        </p:txBody>
-      </p:sp>
-      <p:sp>
-        <p:nvSpPr>
-          <p:cNvPr id="5" name="TextBox 4"/>
+              <a:t>•  The run is deterministic to every printed digit, and every ask is a genuine continuation step — never a re-score of a stored design.</a:t>
+            </a:r>
+          </a:p>
+        </p:txBody>
+      </p:sp>
+      <p:pic>
+        <p:nvPicPr>
+          <p:cNvPr id="5" name="Picture 4" descr="oi_demo_12deg_layout.png"/>
+          <p:cNvPicPr>
+            <a:picLocks noChangeAspect="1"/>
+          </p:cNvPicPr>
+          <p:nvPr/>
+        </p:nvPicPr>
+        <p:blipFill>
+          <a:blip r:embed="rId2"/>
+          <a:stretch>
+            <a:fillRect/>
+          </a:stretch>
+        </p:blipFill>
+        <p:spPr>
+          <a:xfrm>
+            <a:off x="8000103" y="1298448"/>
+            <a:ext cx="2196352" cy="1891792"/>
+          </a:xfrm>
+          <a:prstGeom prst="rect">
+            <a:avLst/>
+          </a:prstGeom>
+        </p:spPr>
+      </p:pic>
+      <p:sp>
+        <p:nvSpPr>
+          <p:cNvPr id="6" name="TextBox 5"/>
           <p:cNvSpPr txBox="1"/>
           <p:nvPr/>
         </p:nvSpPr>
         <p:spPr>
           <a:xfrm>
-            <a:off x="411480" y="3241547"/>
-            <a:ext cx="11368735" cy="274320"/>
+            <a:off x="6400800" y="3208528"/>
+            <a:ext cx="5394960" cy="394208"/>
           </a:xfrm>
           <a:prstGeom prst="rect">
             <a:avLst/>
@@ -10317,6 +10239,69 @@
           </a:bodyPr>
           <a:lstStyle/>
           <a:p>
+            <a:pPr algn="ctr">
+              <a:spcAft>
+                <a:spcPts val="0"/>
+              </a:spcAft>
+            </a:pPr>
+            <a:r>
+              <a:rPr sz="1000" b="0">
+                <a:solidFill>
+                  <a:srgbClr val="6E6E6E"/>
+                </a:solidFill>
+                <a:latin typeface="Arial"/>
+              </a:rPr>
+              <a:t>The 12° rehearsal design and its field map: 33.6 nm max against a 33.7 nm prediction.</a:t>
+            </a:r>
+          </a:p>
+        </p:txBody>
+      </p:sp>
+      <p:pic>
+        <p:nvPicPr>
+          <p:cNvPr id="7" name="Picture 6" descr="oi_demo_12deg_map.png"/>
+          <p:cNvPicPr>
+            <a:picLocks noChangeAspect="1"/>
+          </p:cNvPicPr>
+          <p:nvPr/>
+        </p:nvPicPr>
+        <p:blipFill>
+          <a:blip r:embed="rId3"/>
+          <a:stretch>
+            <a:fillRect/>
+          </a:stretch>
+        </p:blipFill>
+        <p:spPr>
+          <a:xfrm>
+            <a:off x="7951092" y="3639312"/>
+            <a:ext cx="2294375" cy="2011680"/>
+          </a:xfrm>
+          <a:prstGeom prst="rect">
+            <a:avLst/>
+          </a:prstGeom>
+        </p:spPr>
+      </p:pic>
+      <p:sp>
+        <p:nvSpPr>
+          <p:cNvPr id="8" name="TextBox 7"/>
+          <p:cNvSpPr txBox="1"/>
+          <p:nvPr/>
+        </p:nvSpPr>
+        <p:spPr>
+          <a:xfrm>
+            <a:off x="6400800" y="5650992"/>
+            <a:ext cx="5394960" cy="274320"/>
+          </a:xfrm>
+          <a:prstGeom prst="rect">
+            <a:avLst/>
+          </a:prstGeom>
+          <a:noFill/>
+        </p:spPr>
+        <p:txBody>
+          <a:bodyPr wrap="square">
+            <a:spAutoFit/>
+          </a:bodyPr>
+          <a:lstStyle/>
+          <a:p>
             <a:pPr>
               <a:spcAft>
                 <a:spcPts val="600"/>
@@ -10329,7 +10314,7 @@
                 </a:solidFill>
                 <a:latin typeface="Arial"/>
               </a:rPr>
-              <a:t>These are offered as discussion questions, not settled doctrine.</a:t>
+              <a:t>On demo day the live run's figures replace these panels; this pre-generated bundle is the fallback if the room's ask matches nothing better.</a:t>
             </a:r>
           </a:p>
         </p:txBody>
@@ -10386,7 +10371,7 @@
                 </a:solidFill>
                 <a:latin typeface="Arial"/>
               </a:rPr>
-              <a:t>Summary</a:t>
+              <a:t>AI in design and analysis — the working questions</a:t>
             </a:r>
           </a:p>
           <a:p>
@@ -10402,7 +10387,7 @@
                 </a:solidFill>
                 <a:latin typeface="Arial"/>
               </a:rPr>
-              <a:t>One engine, validated; a toolbox that designs; an AI that drives it — all public</a:t>
+              <a:t>What we ask of an AI-driven study before believing it</a:t>
             </a:r>
           </a:p>
         </p:txBody>
@@ -10485,7 +10470,7 @@
                 </a:solidFill>
                 <a:latin typeface="Arial"/>
               </a:rPr>
-              <a:t>•  One validated engine behind four language surfaces; a MATLAB design layer that took three CODE V benchmark studies from reproduction to extension.</a:t>
+              <a:t>•  How is a result verified when the designer is a machine?  Here: regression checks with negative controls, layout figures read against every claim, and corrected signed measures — the checks caught the errors shown today.</a:t>
             </a:r>
           </a:p>
           <a:p>
@@ -10501,7 +10486,7 @@
                 </a:solidFill>
                 <a:latin typeface="Arial"/>
               </a:rPr>
-              <a:t>•  Two things happened live: a telescope designed to the audience's field specification in one warm-started step, and a polarization interferometer measuring a deformable mirror to 0.30 nm.</a:t>
+              <a:t>•  Where does the human rule?  Constraint choices, metric definitions, and every outward claim carry a human sign-off; the AI proposes, the record decides.</a:t>
             </a:r>
           </a:p>
           <a:p>
@@ -10517,7 +10502,7 @@
                 </a:solidFill>
                 <a:latin typeface="Arial"/>
               </a:rPr>
-              <a:t>•  The code is public: github.com/nasa-jpl/macos.</a:t>
+              <a:t>•  Is it reproducible?  Every number in this deck rebuilds from committed scripts and committed records — including the design solved during this talk.</a:t>
             </a:r>
           </a:p>
         </p:txBody>
@@ -10530,7 +10515,7 @@
         </p:nvSpPr>
         <p:spPr>
           <a:xfrm>
-            <a:off x="411480" y="2993898"/>
+            <a:off x="411480" y="3241547"/>
             <a:ext cx="11368735" cy="274320"/>
           </a:xfrm>
           <a:prstGeom prst="rect">
@@ -10556,7 +10541,7 @@
                 </a:solidFill>
                 <a:latin typeface="Arial"/>
               </a:rPr>
-              <a:t>Contact and records: all studies cited are committed with packets and regression checks.</a:t>
+              <a:t>These are offered as discussion questions, not settled doctrine.</a:t>
             </a:r>
           </a:p>
         </p:txBody>
@@ -10613,7 +10598,23 @@
                 </a:solidFill>
                 <a:latin typeface="Arial"/>
               </a:rPr>
-              <a:t>Backup Slides</a:t>
+              <a:t>Summary</a:t>
+            </a:r>
+          </a:p>
+          <a:p>
+            <a:pPr>
+              <a:spcAft>
+                <a:spcPts val="0"/>
+              </a:spcAft>
+            </a:pPr>
+            <a:r>
+              <a:rPr sz="1250" b="0">
+                <a:solidFill>
+                  <a:srgbClr val="6E6E6E"/>
+                </a:solidFill>
+                <a:latin typeface="Arial"/>
+              </a:rPr>
+              <a:t>One engine, validated; a toolbox that designs; an AI that drives it — all public</a:t>
             </a:r>
           </a:p>
         </p:txBody>
@@ -10626,7 +10627,7 @@
         </p:nvSpPr>
         <p:spPr>
           <a:xfrm>
-            <a:off x="411480" y="914400"/>
+            <a:off x="411480" y="1133856"/>
             <a:ext cx="11368735" cy="20320"/>
           </a:xfrm>
           <a:prstGeom prst="rect">
@@ -10659,6 +10660,116 @@
           <a:lstStyle/>
           <a:p>
             <a:pPr algn="ctr"/>
+          </a:p>
+        </p:txBody>
+      </p:sp>
+      <p:sp>
+        <p:nvSpPr>
+          <p:cNvPr id="4" name="TextBox 3"/>
+          <p:cNvSpPr txBox="1"/>
+          <p:nvPr/>
+        </p:nvSpPr>
+        <p:spPr>
+          <a:xfrm>
+            <a:off x="411480" y="1298448"/>
+            <a:ext cx="11368735" cy="274320"/>
+          </a:xfrm>
+          <a:prstGeom prst="rect">
+            <a:avLst/>
+          </a:prstGeom>
+          <a:noFill/>
+        </p:spPr>
+        <p:txBody>
+          <a:bodyPr wrap="square">
+            <a:spAutoFit/>
+          </a:bodyPr>
+          <a:lstStyle/>
+          <a:p>
+            <a:pPr>
+              <a:spcAft>
+                <a:spcPts val="600"/>
+              </a:spcAft>
+            </a:pPr>
+            <a:r>
+              <a:rPr sz="1500" b="0">
+                <a:solidFill>
+                  <a:srgbClr val="282828"/>
+                </a:solidFill>
+                <a:latin typeface="Arial"/>
+              </a:rPr>
+              <a:t>•  One validated engine behind four language surfaces; a MATLAB design layer that took three CODE V benchmark studies from reproduction to extension.</a:t>
+            </a:r>
+          </a:p>
+          <a:p>
+            <a:pPr>
+              <a:spcAft>
+                <a:spcPts val="600"/>
+              </a:spcAft>
+            </a:pPr>
+            <a:r>
+              <a:rPr sz="1500" b="0">
+                <a:solidFill>
+                  <a:srgbClr val="282828"/>
+                </a:solidFill>
+                <a:latin typeface="Arial"/>
+              </a:rPr>
+              <a:t>•  Two things happened live: a telescope designed to the audience's field specification in one warm-started step, and a polarization interferometer measuring a deformable mirror to 0.30 nm.</a:t>
+            </a:r>
+          </a:p>
+          <a:p>
+            <a:pPr>
+              <a:spcAft>
+                <a:spcPts val="600"/>
+              </a:spcAft>
+            </a:pPr>
+            <a:r>
+              <a:rPr sz="1500" b="0">
+                <a:solidFill>
+                  <a:srgbClr val="282828"/>
+                </a:solidFill>
+                <a:latin typeface="Arial"/>
+              </a:rPr>
+              <a:t>•  The code is public: github.com/nasa-jpl/macos.</a:t>
+            </a:r>
+          </a:p>
+        </p:txBody>
+      </p:sp>
+      <p:sp>
+        <p:nvSpPr>
+          <p:cNvPr id="5" name="TextBox 4"/>
+          <p:cNvSpPr txBox="1"/>
+          <p:nvPr/>
+        </p:nvSpPr>
+        <p:spPr>
+          <a:xfrm>
+            <a:off x="411480" y="2993898"/>
+            <a:ext cx="11368735" cy="274320"/>
+          </a:xfrm>
+          <a:prstGeom prst="rect">
+            <a:avLst/>
+          </a:prstGeom>
+          <a:noFill/>
+        </p:spPr>
+        <p:txBody>
+          <a:bodyPr wrap="square">
+            <a:spAutoFit/>
+          </a:bodyPr>
+          <a:lstStyle/>
+          <a:p>
+            <a:pPr>
+              <a:spcAft>
+                <a:spcPts val="600"/>
+              </a:spcAft>
+            </a:pPr>
+            <a:r>
+              <a:rPr sz="1050" b="0">
+                <a:solidFill>
+                  <a:srgbClr val="6E6E6E"/>
+                </a:solidFill>
+                <a:latin typeface="Arial"/>
+              </a:rPr>
+              <a:t>Contact and records: all studies cited are committed with packets and regression checks.</a:t>
+            </a:r>
           </a:p>
         </p:txBody>
       </p:sp>
@@ -10714,23 +10825,7 @@
                 </a:solidFill>
                 <a:latin typeface="Arial"/>
               </a:rPr>
-              <a:t>What MACOS does today</a:t>
-            </a:r>
-          </a:p>
-          <a:p>
-            <a:pPr>
-              <a:spcAft>
-                <a:spcPts val="0"/>
-              </a:spcAft>
-            </a:pPr>
-            <a:r>
-              <a:rPr sz="1250" b="0">
-                <a:solidFill>
-                  <a:srgbClr val="6E6E6E"/>
-                </a:solidFill>
-                <a:latin typeface="Arial"/>
-              </a:rPr>
-              <a:t>System-level modeling from design through control</a:t>
+              <a:t>Backup Slides</a:t>
             </a:r>
           </a:p>
         </p:txBody>
@@ -10743,7 +10838,7 @@
         </p:nvSpPr>
         <p:spPr>
           <a:xfrm>
-            <a:off x="411480" y="1133856"/>
+            <a:off x="411480" y="914400"/>
             <a:ext cx="11368735" cy="20320"/>
           </a:xfrm>
           <a:prstGeom prst="rect">
@@ -10776,116 +10871,6 @@
           <a:lstStyle/>
           <a:p>
             <a:pPr algn="ctr"/>
-          </a:p>
-        </p:txBody>
-      </p:sp>
-      <p:sp>
-        <p:nvSpPr>
-          <p:cNvPr id="4" name="TextBox 3"/>
-          <p:cNvSpPr txBox="1"/>
-          <p:nvPr/>
-        </p:nvSpPr>
-        <p:spPr>
-          <a:xfrm>
-            <a:off x="411480" y="1298448"/>
-            <a:ext cx="11368735" cy="274320"/>
-          </a:xfrm>
-          <a:prstGeom prst="rect">
-            <a:avLst/>
-          </a:prstGeom>
-          <a:noFill/>
-        </p:spPr>
-        <p:txBody>
-          <a:bodyPr wrap="square">
-            <a:spAutoFit/>
-          </a:bodyPr>
-          <a:lstStyle/>
-          <a:p>
-            <a:pPr>
-              <a:spcAft>
-                <a:spcPts val="600"/>
-              </a:spcAft>
-            </a:pPr>
-            <a:r>
-              <a:rPr sz="1500" b="0">
-                <a:solidFill>
-                  <a:srgbClr val="282828"/>
-                </a:solidFill>
-                <a:latin typeface="Arial"/>
-              </a:rPr>
-              <a:t>•  Applications: error budgeting, integrated observatory simulation, wavefront sensing and control for segmented telescopes, coronagraph testbeds and instruments.</a:t>
-            </a:r>
-          </a:p>
-          <a:p>
-            <a:pPr>
-              <a:spcAft>
-                <a:spcPts val="600"/>
-              </a:spcAft>
-            </a:pPr>
-            <a:r>
-              <a:rPr sz="1500" b="0">
-                <a:solidFill>
-                  <a:srgbClr val="282828"/>
-                </a:solidFill>
-                <a:latin typeface="Arial"/>
-              </a:rPr>
-              <a:t>•  The linear-model workflow: w = J·x + w₀ — wavefront sensitivity channels per element, per segment, per surface mode; stacked over fields and configurations; element groups move as one.</a:t>
-            </a:r>
-          </a:p>
-          <a:p>
-            <a:pPr>
-              <a:spcAft>
-                <a:spcPts val="600"/>
-              </a:spcAft>
-            </a:pPr>
-            <a:r>
-              <a:rPr sz="1500" b="0">
-                <a:solidFill>
-                  <a:srgbClr val="282828"/>
-                </a:solidFill>
-                <a:latin typeface="Arial"/>
-              </a:rPr>
-              <a:t>•  From model to control: the same sensitivity matrices drive metrology design, estimator synthesis, and closed-loop simulation — one model, one bookkeeping, design to control.</a:t>
-            </a:r>
-          </a:p>
-        </p:txBody>
-      </p:sp>
-      <p:sp>
-        <p:nvSpPr>
-          <p:cNvPr id="5" name="TextBox 4"/>
-          <p:cNvSpPr txBox="1"/>
-          <p:nvPr/>
-        </p:nvSpPr>
-        <p:spPr>
-          <a:xfrm>
-            <a:off x="411480" y="3241547"/>
-            <a:ext cx="11368735" cy="274320"/>
-          </a:xfrm>
-          <a:prstGeom prst="rect">
-            <a:avLst/>
-          </a:prstGeom>
-          <a:noFill/>
-        </p:spPr>
-        <p:txBody>
-          <a:bodyPr wrap="square">
-            <a:spAutoFit/>
-          </a:bodyPr>
-          <a:lstStyle/>
-          <a:p>
-            <a:pPr>
-              <a:spcAft>
-                <a:spcPts val="600"/>
-              </a:spcAft>
-            </a:pPr>
-            <a:r>
-              <a:rPr sz="1050" b="0">
-                <a:solidFill>
-                  <a:srgbClr val="6E6E6E"/>
-                </a:solidFill>
-                <a:latin typeface="Arial"/>
-              </a:rPr>
-              <a:t>Every capability shown today is in the committed test suites; validation anchors: next slide.</a:t>
-            </a:r>
           </a:p>
         </p:txBody>
       </p:sp>
@@ -10941,7 +10926,7 @@
                 </a:solidFill>
                 <a:latin typeface="Arial"/>
               </a:rPr>
-              <a:t>The MATLAB toolbox and the design layer</a:t>
+              <a:t>What MACOS does today</a:t>
             </a:r>
           </a:p>
           <a:p>
@@ -10957,7 +10942,7 @@
                 </a:solidFill>
                 <a:latin typeface="Arial"/>
               </a:rPr>
-              <a:t>Design → segmentation → sensitivities → metrology → simulation, each one call — fully public-domain</a:t>
+              <a:t>System-level modeling from design through control</a:t>
             </a:r>
           </a:p>
         </p:txBody>
@@ -11015,7 +11000,7 @@
         <p:spPr>
           <a:xfrm>
             <a:off x="411480" y="1298448"/>
-            <a:ext cx="5806440" cy="274320"/>
+            <a:ext cx="11368735" cy="274320"/>
           </a:xfrm>
           <a:prstGeom prst="rect">
             <a:avLst/>
@@ -11034,13 +11019,13 @@
               </a:spcAft>
             </a:pPr>
             <a:r>
-              <a:rPr sz="1200" b="0">
+              <a:rPr sz="1500" b="0">
                 <a:solidFill>
                   <a:srgbClr val="282828"/>
                 </a:solidFill>
                 <a:latin typeface="Arial"/>
               </a:rPr>
-              <a:t>•  Drivers: telescope/bench design builders, sensitivity supervisors (rigid-body, alignment, surface-grid), metrology placement, model-vs-model comparison, closed-loop simulators, study orchestrators.</a:t>
+              <a:t>•  Applications: error budgeting, integrated observatory simulation, wavefront sensing and control for segmented telescopes, coronagraph testbeds and instruments.</a:t>
             </a:r>
           </a:p>
           <a:p>
@@ -11050,13 +11035,29 @@
               </a:spcAft>
             </a:pPr>
             <a:r>
-              <a:rPr sz="1200" b="0">
+              <a:rPr sz="1500" b="0">
                 <a:solidFill>
                   <a:srgbClr val="282828"/>
                 </a:solidFill>
                 <a:latin typeface="Arial"/>
               </a:rPr>
-              <a:t>•  One-call reconstructible studies: every figure in this deck rebuilds from a committed script and committed records.</a:t>
+              <a:t>•  The linear-model workflow: w = J·x + w₀ — wavefront sensitivity channels per element, per segment, per surface mode; stacked over fields and configurations; element groups move as one.</a:t>
+            </a:r>
+          </a:p>
+          <a:p>
+            <a:pPr>
+              <a:spcAft>
+                <a:spcPts val="600"/>
+              </a:spcAft>
+            </a:pPr>
+            <a:r>
+              <a:rPr sz="1500" b="0">
+                <a:solidFill>
+                  <a:srgbClr val="282828"/>
+                </a:solidFill>
+                <a:latin typeface="Arial"/>
+              </a:rPr>
+              <a:t>•  From model to control: the same sensitivity matrices drive metrology design, estimator synthesis, and closed-loop simulation — one model, one bookkeeping, design to control.</a:t>
             </a:r>
           </a:p>
         </p:txBody>
@@ -11069,8 +11070,8 @@
         </p:nvSpPr>
         <p:spPr>
           <a:xfrm>
-            <a:off x="6400800" y="1298448"/>
-            <a:ext cx="5394960" cy="274320"/>
+            <a:off x="411480" y="3241547"/>
+            <a:ext cx="11368735" cy="274320"/>
           </a:xfrm>
           <a:prstGeom prst="rect">
             <a:avLst/>
@@ -11089,68 +11090,13 @@
               </a:spcAft>
             </a:pPr>
             <a:r>
-              <a:rPr sz="1200" b="0">
-                <a:solidFill>
-                  <a:srgbClr val="282828"/>
-                </a:solidFill>
-                <a:latin typeface="Arial"/>
-              </a:rPr>
-              <a:t>•  Utilities: trace, wavefront, perturb, pupil find; layout and ray-bundle viewers; Jones pupils, polarization elements; segment grid bases and grid file IO; multi-wavelength composition; spot, intensity, complex field.</a:t>
-            </a:r>
-          </a:p>
-          <a:p>
-            <a:pPr>
-              <a:spcAft>
-                <a:spcPts val="600"/>
-              </a:spcAft>
-            </a:pPr>
-            <a:r>
-              <a:rPr sz="1200" b="0">
-                <a:solidFill>
-                  <a:srgbClr val="282828"/>
-                </a:solidFill>
-                <a:latin typeface="Arial"/>
-              </a:rPr>
-              <a:t>•  Why a design layer: the whole stack is public-domain — a design study needs no proprietary prescription to start from.</a:t>
-            </a:r>
-          </a:p>
-        </p:txBody>
-      </p:sp>
-      <p:sp>
-        <p:nvSpPr>
-          <p:cNvPr id="6" name="TextBox 5"/>
-          <p:cNvSpPr txBox="1"/>
-          <p:nvPr/>
-        </p:nvSpPr>
-        <p:spPr>
-          <a:xfrm>
-            <a:off x="6400800" y="2804160"/>
-            <a:ext cx="5394960" cy="274320"/>
-          </a:xfrm>
-          <a:prstGeom prst="rect">
-            <a:avLst/>
-          </a:prstGeom>
-          <a:noFill/>
-        </p:spPr>
-        <p:txBody>
-          <a:bodyPr wrap="square">
-            <a:spAutoFit/>
-          </a:bodyPr>
-          <a:lstStyle/>
-          <a:p>
-            <a:pPr>
-              <a:spcAft>
-                <a:spcPts val="600"/>
-              </a:spcAft>
-            </a:pPr>
-            <a:r>
               <a:rPr sz="1050" b="0">
                 <a:solidFill>
                   <a:srgbClr val="6E6E6E"/>
                 </a:solidFill>
                 <a:latin typeface="Arial"/>
               </a:rPr>
-              <a:t>The two live demonstrations exercised exactly these layers: the bench builder and a design-family driver.</a:t>
+              <a:t>Every capability shown today is in the committed test suites; validation anchors: next slide.</a:t>
             </a:r>
           </a:p>
         </p:txBody>
@@ -11164,6 +11110,272 @@
 </file>
 
 <file path=ppt/slides/slide28.xml><?xml version="1.0" encoding="utf-8"?>
+<p:sld xmlns:a="http://schemas.openxmlformats.org/drawingml/2006/main" xmlns:p="http://schemas.openxmlformats.org/presentationml/2006/main" xmlns:r="http://schemas.openxmlformats.org/officeDocument/2006/relationships">
+  <p:cSld>
+    <p:spTree>
+      <p:nvGrpSpPr>
+        <p:cNvPr id="1" name=""/>
+        <p:cNvGrpSpPr/>
+        <p:nvPr/>
+      </p:nvGrpSpPr>
+      <p:grpSpPr/>
+      <p:sp>
+        <p:nvSpPr>
+          <p:cNvPr id="2" name="TextBox 1"/>
+          <p:cNvSpPr txBox="1"/>
+          <p:nvPr/>
+        </p:nvSpPr>
+        <p:spPr>
+          <a:xfrm>
+            <a:off x="411480" y="201168"/>
+            <a:ext cx="11368735" cy="914400"/>
+          </a:xfrm>
+          <a:prstGeom prst="rect">
+            <a:avLst/>
+          </a:prstGeom>
+          <a:noFill/>
+        </p:spPr>
+        <p:txBody>
+          <a:bodyPr wrap="square">
+            <a:spAutoFit/>
+          </a:bodyPr>
+          <a:lstStyle/>
+          <a:p>
+            <a:pPr>
+              <a:spcAft>
+                <a:spcPts val="400"/>
+              </a:spcAft>
+            </a:pPr>
+            <a:r>
+              <a:rPr sz="2400" b="1">
+                <a:solidFill>
+                  <a:srgbClr val="1F4E79"/>
+                </a:solidFill>
+                <a:latin typeface="Arial"/>
+              </a:rPr>
+              <a:t>The MATLAB toolbox and the design layer</a:t>
+            </a:r>
+          </a:p>
+          <a:p>
+            <a:pPr>
+              <a:spcAft>
+                <a:spcPts val="0"/>
+              </a:spcAft>
+            </a:pPr>
+            <a:r>
+              <a:rPr sz="1250" b="0">
+                <a:solidFill>
+                  <a:srgbClr val="6E6E6E"/>
+                </a:solidFill>
+                <a:latin typeface="Arial"/>
+              </a:rPr>
+              <a:t>Design → segmentation → sensitivities → metrology → simulation, each one call — fully public-domain</a:t>
+            </a:r>
+          </a:p>
+        </p:txBody>
+      </p:sp>
+      <p:sp>
+        <p:nvSpPr>
+          <p:cNvPr id="3" name="Rectangle 2"/>
+          <p:cNvSpPr/>
+          <p:nvPr/>
+        </p:nvSpPr>
+        <p:spPr>
+          <a:xfrm>
+            <a:off x="411480" y="1133856"/>
+            <a:ext cx="11368735" cy="20320"/>
+          </a:xfrm>
+          <a:prstGeom prst="rect">
+            <a:avLst/>
+          </a:prstGeom>
+          <a:solidFill>
+            <a:srgbClr val="B8C6D4"/>
+          </a:solidFill>
+          <a:ln>
+            <a:noFill/>
+          </a:ln>
+          <a:effectLst/>
+        </p:spPr>
+        <p:style>
+          <a:lnRef idx="1">
+            <a:schemeClr val="accent1"/>
+          </a:lnRef>
+          <a:fillRef idx="3">
+            <a:schemeClr val="accent1"/>
+          </a:fillRef>
+          <a:effectRef idx="2">
+            <a:schemeClr val="accent1"/>
+          </a:effectRef>
+          <a:fontRef idx="minor">
+            <a:schemeClr val="lt1"/>
+          </a:fontRef>
+        </p:style>
+        <p:txBody>
+          <a:bodyPr rtlCol="0" anchor="ctr"/>
+          <a:lstStyle/>
+          <a:p>
+            <a:pPr algn="ctr"/>
+          </a:p>
+        </p:txBody>
+      </p:sp>
+      <p:sp>
+        <p:nvSpPr>
+          <p:cNvPr id="4" name="TextBox 3"/>
+          <p:cNvSpPr txBox="1"/>
+          <p:nvPr/>
+        </p:nvSpPr>
+        <p:spPr>
+          <a:xfrm>
+            <a:off x="411480" y="1298448"/>
+            <a:ext cx="5806440" cy="274320"/>
+          </a:xfrm>
+          <a:prstGeom prst="rect">
+            <a:avLst/>
+          </a:prstGeom>
+          <a:noFill/>
+        </p:spPr>
+        <p:txBody>
+          <a:bodyPr wrap="square">
+            <a:spAutoFit/>
+          </a:bodyPr>
+          <a:lstStyle/>
+          <a:p>
+            <a:pPr>
+              <a:spcAft>
+                <a:spcPts val="600"/>
+              </a:spcAft>
+            </a:pPr>
+            <a:r>
+              <a:rPr sz="1200" b="0">
+                <a:solidFill>
+                  <a:srgbClr val="282828"/>
+                </a:solidFill>
+                <a:latin typeface="Arial"/>
+              </a:rPr>
+              <a:t>•  Drivers: telescope/bench design builders, sensitivity supervisors (rigid-body, alignment, surface-grid), metrology placement, model-vs-model comparison, closed-loop simulators, study orchestrators.</a:t>
+            </a:r>
+          </a:p>
+          <a:p>
+            <a:pPr>
+              <a:spcAft>
+                <a:spcPts val="600"/>
+              </a:spcAft>
+            </a:pPr>
+            <a:r>
+              <a:rPr sz="1200" b="0">
+                <a:solidFill>
+                  <a:srgbClr val="282828"/>
+                </a:solidFill>
+                <a:latin typeface="Arial"/>
+              </a:rPr>
+              <a:t>•  One-call reconstructible studies: every figure in this deck rebuilds from a committed script and committed records.</a:t>
+            </a:r>
+          </a:p>
+        </p:txBody>
+      </p:sp>
+      <p:sp>
+        <p:nvSpPr>
+          <p:cNvPr id="5" name="TextBox 4"/>
+          <p:cNvSpPr txBox="1"/>
+          <p:nvPr/>
+        </p:nvSpPr>
+        <p:spPr>
+          <a:xfrm>
+            <a:off x="6400800" y="1298448"/>
+            <a:ext cx="5394960" cy="274320"/>
+          </a:xfrm>
+          <a:prstGeom prst="rect">
+            <a:avLst/>
+          </a:prstGeom>
+          <a:noFill/>
+        </p:spPr>
+        <p:txBody>
+          <a:bodyPr wrap="square">
+            <a:spAutoFit/>
+          </a:bodyPr>
+          <a:lstStyle/>
+          <a:p>
+            <a:pPr>
+              <a:spcAft>
+                <a:spcPts val="600"/>
+              </a:spcAft>
+            </a:pPr>
+            <a:r>
+              <a:rPr sz="1200" b="0">
+                <a:solidFill>
+                  <a:srgbClr val="282828"/>
+                </a:solidFill>
+                <a:latin typeface="Arial"/>
+              </a:rPr>
+              <a:t>•  Utilities: trace, wavefront, perturb, pupil find; layout and ray-bundle viewers; Jones pupils, polarization elements; segment grid bases and grid file IO; multi-wavelength composition; spot, intensity, complex field.</a:t>
+            </a:r>
+          </a:p>
+          <a:p>
+            <a:pPr>
+              <a:spcAft>
+                <a:spcPts val="600"/>
+              </a:spcAft>
+            </a:pPr>
+            <a:r>
+              <a:rPr sz="1200" b="0">
+                <a:solidFill>
+                  <a:srgbClr val="282828"/>
+                </a:solidFill>
+                <a:latin typeface="Arial"/>
+              </a:rPr>
+              <a:t>•  Why a design layer: the whole stack is public-domain — a design study needs no proprietary prescription to start from.</a:t>
+            </a:r>
+          </a:p>
+        </p:txBody>
+      </p:sp>
+      <p:sp>
+        <p:nvSpPr>
+          <p:cNvPr id="6" name="TextBox 5"/>
+          <p:cNvSpPr txBox="1"/>
+          <p:nvPr/>
+        </p:nvSpPr>
+        <p:spPr>
+          <a:xfrm>
+            <a:off x="6400800" y="2804160"/>
+            <a:ext cx="5394960" cy="274320"/>
+          </a:xfrm>
+          <a:prstGeom prst="rect">
+            <a:avLst/>
+          </a:prstGeom>
+          <a:noFill/>
+        </p:spPr>
+        <p:txBody>
+          <a:bodyPr wrap="square">
+            <a:spAutoFit/>
+          </a:bodyPr>
+          <a:lstStyle/>
+          <a:p>
+            <a:pPr>
+              <a:spcAft>
+                <a:spcPts val="600"/>
+              </a:spcAft>
+            </a:pPr>
+            <a:r>
+              <a:rPr sz="1050" b="0">
+                <a:solidFill>
+                  <a:srgbClr val="6E6E6E"/>
+                </a:solidFill>
+                <a:latin typeface="Arial"/>
+              </a:rPr>
+              <a:t>The two live demonstrations exercised exactly these layers: the bench builder and a design-family driver.</a:t>
+            </a:r>
+          </a:p>
+        </p:txBody>
+      </p:sp>
+    </p:spTree>
+  </p:cSld>
+  <p:clrMapOvr>
+    <a:masterClrMapping/>
+  </p:clrMapOvr>
+</p:sld>
+</file>
+
+<file path=ppt/slides/slide29.xml><?xml version="1.0" encoding="utf-8"?>
 <p:sld xmlns:a="http://schemas.openxmlformats.org/drawingml/2006/main" xmlns:p="http://schemas.openxmlformats.org/presentationml/2006/main" xmlns:r="http://schemas.openxmlformats.org/officeDocument/2006/relationships">
   <p:cSld>
     <p:spTree>
@@ -11793,7 +12005,251 @@
 </p:sld>
 </file>
 
-<file path=ppt/slides/slide29.xml><?xml version="1.0" encoding="utf-8"?>
+<file path=ppt/slides/slide3.xml><?xml version="1.0" encoding="utf-8"?>
+<p:sld xmlns:a="http://schemas.openxmlformats.org/drawingml/2006/main" xmlns:p="http://schemas.openxmlformats.org/presentationml/2006/main" xmlns:r="http://schemas.openxmlformats.org/officeDocument/2006/relationships">
+  <p:cSld>
+    <p:spTree>
+      <p:nvGrpSpPr>
+        <p:cNvPr id="1" name=""/>
+        <p:cNvGrpSpPr/>
+        <p:nvPr/>
+      </p:nvGrpSpPr>
+      <p:grpSpPr/>
+      <p:sp>
+        <p:nvSpPr>
+          <p:cNvPr id="2" name="TextBox 1"/>
+          <p:cNvSpPr txBox="1"/>
+          <p:nvPr/>
+        </p:nvSpPr>
+        <p:spPr>
+          <a:xfrm>
+            <a:off x="411480" y="201168"/>
+            <a:ext cx="11368735" cy="914400"/>
+          </a:xfrm>
+          <a:prstGeom prst="rect">
+            <a:avLst/>
+          </a:prstGeom>
+          <a:noFill/>
+        </p:spPr>
+        <p:txBody>
+          <a:bodyPr wrap="square">
+            <a:spAutoFit/>
+          </a:bodyPr>
+          <a:lstStyle/>
+          <a:p>
+            <a:pPr>
+              <a:spcAft>
+                <a:spcPts val="400"/>
+              </a:spcAft>
+            </a:pPr>
+            <a:r>
+              <a:rPr sz="2400" b="1">
+                <a:solidFill>
+                  <a:srgbClr val="1F4E79"/>
+                </a:solidFill>
+                <a:latin typeface="Arial"/>
+              </a:rPr>
+              <a:t>One engine, four surfaces</a:t>
+            </a:r>
+          </a:p>
+          <a:p>
+            <a:pPr>
+              <a:spcAft>
+                <a:spcPts val="0"/>
+              </a:spcAft>
+            </a:pPr>
+            <a:r>
+              <a:rPr sz="1250" b="0">
+                <a:solidFill>
+                  <a:srgbClr val="6E6E6E"/>
+                </a:solidFill>
+                <a:latin typeface="Arial"/>
+              </a:rPr>
+              <a:t>The same Fortran core answers a terminal, a library call, MATLAB, and Python</a:t>
+            </a:r>
+          </a:p>
+        </p:txBody>
+      </p:sp>
+      <p:sp>
+        <p:nvSpPr>
+          <p:cNvPr id="3" name="Rectangle 2"/>
+          <p:cNvSpPr/>
+          <p:nvPr/>
+        </p:nvSpPr>
+        <p:spPr>
+          <a:xfrm>
+            <a:off x="411480" y="1133856"/>
+            <a:ext cx="11368735" cy="20320"/>
+          </a:xfrm>
+          <a:prstGeom prst="rect">
+            <a:avLst/>
+          </a:prstGeom>
+          <a:solidFill>
+            <a:srgbClr val="B8C6D4"/>
+          </a:solidFill>
+          <a:ln>
+            <a:noFill/>
+          </a:ln>
+          <a:effectLst/>
+        </p:spPr>
+        <p:style>
+          <a:lnRef idx="1">
+            <a:schemeClr val="accent1"/>
+          </a:lnRef>
+          <a:fillRef idx="3">
+            <a:schemeClr val="accent1"/>
+          </a:fillRef>
+          <a:effectRef idx="2">
+            <a:schemeClr val="accent1"/>
+          </a:effectRef>
+          <a:fontRef idx="minor">
+            <a:schemeClr val="lt1"/>
+          </a:fontRef>
+        </p:style>
+        <p:txBody>
+          <a:bodyPr rtlCol="0" anchor="ctr"/>
+          <a:lstStyle/>
+          <a:p>
+            <a:pPr algn="ctr"/>
+          </a:p>
+        </p:txBody>
+      </p:sp>
+      <p:pic>
+        <p:nvPicPr>
+          <p:cNvPr id="4" name="Picture 3" descr="fig_ecosystem.png"/>
+          <p:cNvPicPr>
+            <a:picLocks noChangeAspect="1"/>
+          </p:cNvPicPr>
+          <p:nvPr/>
+        </p:nvPicPr>
+        <p:blipFill>
+          <a:blip r:embed="rId2"/>
+          <a:stretch>
+            <a:fillRect/>
+          </a:stretch>
+        </p:blipFill>
+        <p:spPr>
+          <a:xfrm>
+            <a:off x="2419370" y="1298448"/>
+            <a:ext cx="7352954" cy="3383280"/>
+          </a:xfrm>
+          <a:prstGeom prst="rect">
+            <a:avLst/>
+          </a:prstGeom>
+        </p:spPr>
+      </p:pic>
+      <p:sp>
+        <p:nvSpPr>
+          <p:cNvPr id="5" name="TextBox 4"/>
+          <p:cNvSpPr txBox="1"/>
+          <p:nvPr/>
+        </p:nvSpPr>
+        <p:spPr>
+          <a:xfrm>
+            <a:off x="411480" y="4681728"/>
+            <a:ext cx="11368735" cy="274320"/>
+          </a:xfrm>
+          <a:prstGeom prst="rect">
+            <a:avLst/>
+          </a:prstGeom>
+          <a:noFill/>
+        </p:spPr>
+        <p:txBody>
+          <a:bodyPr wrap="square">
+            <a:spAutoFit/>
+          </a:bodyPr>
+          <a:lstStyle/>
+          <a:p>
+            <a:pPr>
+              <a:spcAft>
+                <a:spcPts val="600"/>
+              </a:spcAft>
+            </a:pPr>
+            <a:r>
+              <a:rPr sz="1500" b="0">
+                <a:solidFill>
+                  <a:srgbClr val="282828"/>
+                </a:solidFill>
+                <a:latin typeface="Arial"/>
+              </a:rPr>
+              <a:t>•  Physics lives in the engine: a capability added there is everywhere at once</a:t>
+            </a:r>
+          </a:p>
+          <a:p>
+            <a:pPr>
+              <a:spcAft>
+                <a:spcPts val="600"/>
+              </a:spcAft>
+            </a:pPr>
+            <a:r>
+              <a:rPr sz="1500" b="0">
+                <a:solidFill>
+                  <a:srgbClr val="282828"/>
+                </a:solidFill>
+                <a:latin typeface="Arial"/>
+              </a:rPr>
+              <a:t>•  One shared library layer serves the MATLAB and Python toolboxes.</a:t>
+            </a:r>
+          </a:p>
+          <a:p>
+            <a:pPr>
+              <a:spcAft>
+                <a:spcPts val="600"/>
+              </a:spcAft>
+            </a:pPr>
+            <a:r>
+              <a:rPr sz="1500" b="0">
+                <a:solidFill>
+                  <a:srgbClr val="282828"/>
+                </a:solidFill>
+                <a:latin typeface="Arial"/>
+              </a:rPr>
+              <a:t>•  The prescription generators and the CODE V converter feed the same Rx language.</a:t>
+            </a:r>
+          </a:p>
+          <a:p>
+            <a:pPr>
+              <a:spcAft>
+                <a:spcPts val="600"/>
+              </a:spcAft>
+            </a:pPr>
+            <a:r>
+              <a:rPr sz="1500" b="0">
+                <a:solidFill>
+                  <a:srgbClr val="282828"/>
+                </a:solidFill>
+                <a:latin typeface="Arial"/>
+              </a:rPr>
+              <a:t>•  CODE V and PROPER provide independent cross-checks.</a:t>
+            </a:r>
+          </a:p>
+          <a:p>
+            <a:pPr>
+              <a:spcAft>
+                <a:spcPts val="600"/>
+              </a:spcAft>
+            </a:pPr>
+            <a:r>
+              <a:rPr sz="1500" b="0">
+                <a:solidFill>
+                  <a:srgbClr val="282828"/>
+                </a:solidFill>
+                <a:latin typeface="Arial"/>
+              </a:rPr>
+              <a:t>•  One source tree: github nasa-jpl/macos and /MACOS_resources contain it all.</a:t>
+            </a:r>
+          </a:p>
+        </p:txBody>
+      </p:sp>
+    </p:spTree>
+  </p:cSld>
+  <p:clrMapOvr>
+    <a:masterClrMapping/>
+  </p:clrMapOvr>
+</p:sld>
+</file>
+
+<file path=ppt/slides/slide30.xml><?xml version="1.0" encoding="utf-8"?>
 <p:sld xmlns:a="http://schemas.openxmlformats.org/drawingml/2006/main" xmlns:p="http://schemas.openxmlformats.org/presentationml/2006/main" xmlns:r="http://schemas.openxmlformats.org/officeDocument/2006/relationships">
   <p:cSld>
     <p:spTree>
@@ -12659,7 +13115,7 @@
 </p:sld>
 </file>
 
-<file path=ppt/slides/slide3.xml><?xml version="1.0" encoding="utf-8"?>
+<file path=ppt/slides/slide31.xml><?xml version="1.0" encoding="utf-8"?>
 <p:sld xmlns:a="http://schemas.openxmlformats.org/drawingml/2006/main" xmlns:p="http://schemas.openxmlformats.org/presentationml/2006/main" xmlns:r="http://schemas.openxmlformats.org/officeDocument/2006/relationships">
   <p:cSld>
     <p:spTree>
@@ -12703,7 +13159,7 @@
                 </a:solidFill>
                 <a:latin typeface="Arial"/>
               </a:rPr>
-              <a:t>One engine, four surfaces</a:t>
+              <a:t>Interferometer demonstration backups</a:t>
             </a:r>
           </a:p>
           <a:p>
@@ -12719,7 +13175,7 @@
                 </a:solidFill>
                 <a:latin typeface="Arial"/>
               </a:rPr>
-              <a:t>The same Fortran core answers a terminal, a library call, MATLAB, and Python</a:t>
+              <a:t>One pre-rendered image per live step</a:t>
             </a:r>
           </a:p>
         </p:txBody>
@@ -12770,7 +13226,7 @@
       </p:sp>
       <p:pic>
         <p:nvPicPr>
-          <p:cNvPr id="4" name="Picture 3" descr="fig_ecosystem.png"/>
+          <p:cNvPr id="4" name="Picture 3" descr="demo_beat5_poke.png"/>
           <p:cNvPicPr>
             <a:picLocks noChangeAspect="1"/>
           </p:cNvPicPr>
@@ -12784,250 +13240,6 @@
         </p:blipFill>
         <p:spPr>
           <a:xfrm>
-            <a:off x="2419370" y="1298448"/>
-            <a:ext cx="7352954" cy="3383280"/>
-          </a:xfrm>
-          <a:prstGeom prst="rect">
-            <a:avLst/>
-          </a:prstGeom>
-        </p:spPr>
-      </p:pic>
-      <p:sp>
-        <p:nvSpPr>
-          <p:cNvPr id="5" name="TextBox 4"/>
-          <p:cNvSpPr txBox="1"/>
-          <p:nvPr/>
-        </p:nvSpPr>
-        <p:spPr>
-          <a:xfrm>
-            <a:off x="411480" y="4681728"/>
-            <a:ext cx="11368735" cy="274320"/>
-          </a:xfrm>
-          <a:prstGeom prst="rect">
-            <a:avLst/>
-          </a:prstGeom>
-          <a:noFill/>
-        </p:spPr>
-        <p:txBody>
-          <a:bodyPr wrap="square">
-            <a:spAutoFit/>
-          </a:bodyPr>
-          <a:lstStyle/>
-          <a:p>
-            <a:pPr>
-              <a:spcAft>
-                <a:spcPts val="600"/>
-              </a:spcAft>
-            </a:pPr>
-            <a:r>
-              <a:rPr sz="1500" b="0">
-                <a:solidFill>
-                  <a:srgbClr val="282828"/>
-                </a:solidFill>
-                <a:latin typeface="Arial"/>
-              </a:rPr>
-              <a:t>•  Physics lives in the engine: a capability added there is everywhere at once</a:t>
-            </a:r>
-          </a:p>
-          <a:p>
-            <a:pPr>
-              <a:spcAft>
-                <a:spcPts val="600"/>
-              </a:spcAft>
-            </a:pPr>
-            <a:r>
-              <a:rPr sz="1500" b="0">
-                <a:solidFill>
-                  <a:srgbClr val="282828"/>
-                </a:solidFill>
-                <a:latin typeface="Arial"/>
-              </a:rPr>
-              <a:t>•  One shared library layer serves the MATLAB and Python toolboxes.</a:t>
-            </a:r>
-          </a:p>
-          <a:p>
-            <a:pPr>
-              <a:spcAft>
-                <a:spcPts val="600"/>
-              </a:spcAft>
-            </a:pPr>
-            <a:r>
-              <a:rPr sz="1500" b="0">
-                <a:solidFill>
-                  <a:srgbClr val="282828"/>
-                </a:solidFill>
-                <a:latin typeface="Arial"/>
-              </a:rPr>
-              <a:t>•  The prescription generators and the CODE V converter feed the same Rx language.</a:t>
-            </a:r>
-          </a:p>
-          <a:p>
-            <a:pPr>
-              <a:spcAft>
-                <a:spcPts val="600"/>
-              </a:spcAft>
-            </a:pPr>
-            <a:r>
-              <a:rPr sz="1500" b="0">
-                <a:solidFill>
-                  <a:srgbClr val="282828"/>
-                </a:solidFill>
-                <a:latin typeface="Arial"/>
-              </a:rPr>
-              <a:t>•  CODE V and PROPER provide independent cross-checks.</a:t>
-            </a:r>
-          </a:p>
-          <a:p>
-            <a:pPr>
-              <a:spcAft>
-                <a:spcPts val="600"/>
-              </a:spcAft>
-            </a:pPr>
-            <a:r>
-              <a:rPr sz="1500" b="0">
-                <a:solidFill>
-                  <a:srgbClr val="282828"/>
-                </a:solidFill>
-                <a:latin typeface="Arial"/>
-              </a:rPr>
-              <a:t>•  One source tree: github nasa-jpl/macos and /MACOS_resources contain it all.</a:t>
-            </a:r>
-          </a:p>
-        </p:txBody>
-      </p:sp>
-    </p:spTree>
-  </p:cSld>
-  <p:clrMapOvr>
-    <a:masterClrMapping/>
-  </p:clrMapOvr>
-</p:sld>
-</file>
-
-<file path=ppt/slides/slide30.xml><?xml version="1.0" encoding="utf-8"?>
-<p:sld xmlns:a="http://schemas.openxmlformats.org/drawingml/2006/main" xmlns:p="http://schemas.openxmlformats.org/presentationml/2006/main" xmlns:r="http://schemas.openxmlformats.org/officeDocument/2006/relationships">
-  <p:cSld>
-    <p:spTree>
-      <p:nvGrpSpPr>
-        <p:cNvPr id="1" name=""/>
-        <p:cNvGrpSpPr/>
-        <p:nvPr/>
-      </p:nvGrpSpPr>
-      <p:grpSpPr/>
-      <p:sp>
-        <p:nvSpPr>
-          <p:cNvPr id="2" name="TextBox 1"/>
-          <p:cNvSpPr txBox="1"/>
-          <p:nvPr/>
-        </p:nvSpPr>
-        <p:spPr>
-          <a:xfrm>
-            <a:off x="411480" y="201168"/>
-            <a:ext cx="11368735" cy="914400"/>
-          </a:xfrm>
-          <a:prstGeom prst="rect">
-            <a:avLst/>
-          </a:prstGeom>
-          <a:noFill/>
-        </p:spPr>
-        <p:txBody>
-          <a:bodyPr wrap="square">
-            <a:spAutoFit/>
-          </a:bodyPr>
-          <a:lstStyle/>
-          <a:p>
-            <a:pPr>
-              <a:spcAft>
-                <a:spcPts val="400"/>
-              </a:spcAft>
-            </a:pPr>
-            <a:r>
-              <a:rPr sz="2400" b="1">
-                <a:solidFill>
-                  <a:srgbClr val="1F4E79"/>
-                </a:solidFill>
-                <a:latin typeface="Arial"/>
-              </a:rPr>
-              <a:t>Interferometer demonstration backups</a:t>
-            </a:r>
-          </a:p>
-          <a:p>
-            <a:pPr>
-              <a:spcAft>
-                <a:spcPts val="0"/>
-              </a:spcAft>
-            </a:pPr>
-            <a:r>
-              <a:rPr sz="1250" b="0">
-                <a:solidFill>
-                  <a:srgbClr val="6E6E6E"/>
-                </a:solidFill>
-                <a:latin typeface="Arial"/>
-              </a:rPr>
-              <a:t>One pre-rendered image per live step</a:t>
-            </a:r>
-          </a:p>
-        </p:txBody>
-      </p:sp>
-      <p:sp>
-        <p:nvSpPr>
-          <p:cNvPr id="3" name="Rectangle 2"/>
-          <p:cNvSpPr/>
-          <p:nvPr/>
-        </p:nvSpPr>
-        <p:spPr>
-          <a:xfrm>
-            <a:off x="411480" y="1133856"/>
-            <a:ext cx="11368735" cy="20320"/>
-          </a:xfrm>
-          <a:prstGeom prst="rect">
-            <a:avLst/>
-          </a:prstGeom>
-          <a:solidFill>
-            <a:srgbClr val="B8C6D4"/>
-          </a:solidFill>
-          <a:ln>
-            <a:noFill/>
-          </a:ln>
-          <a:effectLst/>
-        </p:spPr>
-        <p:style>
-          <a:lnRef idx="1">
-            <a:schemeClr val="accent1"/>
-          </a:lnRef>
-          <a:fillRef idx="3">
-            <a:schemeClr val="accent1"/>
-          </a:fillRef>
-          <a:effectRef idx="2">
-            <a:schemeClr val="accent1"/>
-          </a:effectRef>
-          <a:fontRef idx="minor">
-            <a:schemeClr val="lt1"/>
-          </a:fontRef>
-        </p:style>
-        <p:txBody>
-          <a:bodyPr rtlCol="0" anchor="ctr"/>
-          <a:lstStyle/>
-          <a:p>
-            <a:pPr algn="ctr"/>
-          </a:p>
-        </p:txBody>
-      </p:sp>
-      <p:pic>
-        <p:nvPicPr>
-          <p:cNvPr id="4" name="Picture 3" descr="demo_beat5_poke.png"/>
-          <p:cNvPicPr>
-            <a:picLocks noChangeAspect="1"/>
-          </p:cNvPicPr>
-          <p:nvPr/>
-        </p:nvPicPr>
-        <p:blipFill>
-          <a:blip r:embed="rId2"/>
-          <a:stretch>
-            <a:fillRect/>
-          </a:stretch>
-        </p:blipFill>
-        <p:spPr>
-          <a:xfrm>
             <a:off x="3771562" y="1298448"/>
             <a:ext cx="4648570" cy="1782572"/>
           </a:xfrm>
@@ -13236,343 +13448,6 @@
                 <a:latin typeface="Arial"/>
               </a:rPr>
               <a:t>All seven steps have backups in templates/90_polarization/tg_psi_dm.</a:t>
-            </a:r>
-          </a:p>
-        </p:txBody>
-      </p:sp>
-    </p:spTree>
-  </p:cSld>
-  <p:clrMapOvr>
-    <a:masterClrMapping/>
-  </p:clrMapOvr>
-</p:sld>
-</file>
-
-<file path=ppt/slides/slide31.xml><?xml version="1.0" encoding="utf-8"?>
-<p:sld xmlns:a="http://schemas.openxmlformats.org/drawingml/2006/main" xmlns:p="http://schemas.openxmlformats.org/presentationml/2006/main" xmlns:r="http://schemas.openxmlformats.org/officeDocument/2006/relationships">
-  <p:cSld>
-    <p:spTree>
-      <p:nvGrpSpPr>
-        <p:cNvPr id="1" name=""/>
-        <p:cNvGrpSpPr/>
-        <p:nvPr/>
-      </p:nvGrpSpPr>
-      <p:grpSpPr/>
-      <p:sp>
-        <p:nvSpPr>
-          <p:cNvPr id="2" name="TextBox 1"/>
-          <p:cNvSpPr txBox="1"/>
-          <p:nvPr/>
-        </p:nvSpPr>
-        <p:spPr>
-          <a:xfrm>
-            <a:off x="411480" y="201168"/>
-            <a:ext cx="11368735" cy="914400"/>
-          </a:xfrm>
-          <a:prstGeom prst="rect">
-            <a:avLst/>
-          </a:prstGeom>
-          <a:noFill/>
-        </p:spPr>
-        <p:txBody>
-          <a:bodyPr wrap="square">
-            <a:spAutoFit/>
-          </a:bodyPr>
-          <a:lstStyle/>
-          <a:p>
-            <a:pPr>
-              <a:spcAft>
-                <a:spcPts val="400"/>
-              </a:spcAft>
-            </a:pPr>
-            <a:r>
-              <a:rPr sz="2400" b="1">
-                <a:solidFill>
-                  <a:srgbClr val="1F4E79"/>
-                </a:solidFill>
-                <a:latin typeface="Arial"/>
-              </a:rPr>
-              <a:t>The e2e worked example: specification to design</a:t>
-            </a:r>
-          </a:p>
-          <a:p>
-            <a:pPr>
-              <a:spcAft>
-                <a:spcPts val="0"/>
-              </a:spcAft>
-            </a:pPr>
-            <a:r>
-              <a:rPr sz="1250" b="0">
-                <a:solidFill>
-                  <a:srgbClr val="6E6E6E"/>
-                </a:solidFill>
-                <a:latin typeface="Arial"/>
-              </a:rPr>
-              <a:t>A 4 m f/18 visible-band telescope from a closed-form seed — no starting prescription</a:t>
-            </a:r>
-          </a:p>
-        </p:txBody>
-      </p:sp>
-      <p:sp>
-        <p:nvSpPr>
-          <p:cNvPr id="3" name="Rectangle 2"/>
-          <p:cNvSpPr/>
-          <p:nvPr/>
-        </p:nvSpPr>
-        <p:spPr>
-          <a:xfrm>
-            <a:off x="411480" y="1133856"/>
-            <a:ext cx="11368735" cy="20320"/>
-          </a:xfrm>
-          <a:prstGeom prst="rect">
-            <a:avLst/>
-          </a:prstGeom>
-          <a:solidFill>
-            <a:srgbClr val="B8C6D4"/>
-          </a:solidFill>
-          <a:ln>
-            <a:noFill/>
-          </a:ln>
-          <a:effectLst/>
-        </p:spPr>
-        <p:style>
-          <a:lnRef idx="1">
-            <a:schemeClr val="accent1"/>
-          </a:lnRef>
-          <a:fillRef idx="3">
-            <a:schemeClr val="accent1"/>
-          </a:fillRef>
-          <a:effectRef idx="2">
-            <a:schemeClr val="accent1"/>
-          </a:effectRef>
-          <a:fontRef idx="minor">
-            <a:schemeClr val="lt1"/>
-          </a:fontRef>
-        </p:style>
-        <p:txBody>
-          <a:bodyPr rtlCol="0" anchor="ctr"/>
-          <a:lstStyle/>
-          <a:p>
-            <a:pPr algn="ctr"/>
-          </a:p>
-        </p:txBody>
-      </p:sp>
-      <p:sp>
-        <p:nvSpPr>
-          <p:cNvPr id="4" name="TextBox 3"/>
-          <p:cNvSpPr txBox="1"/>
-          <p:nvPr/>
-        </p:nvSpPr>
-        <p:spPr>
-          <a:xfrm>
-            <a:off x="411480" y="1298448"/>
-            <a:ext cx="5806440" cy="274320"/>
-          </a:xfrm>
-          <a:prstGeom prst="rect">
-            <a:avLst/>
-          </a:prstGeom>
-          <a:noFill/>
-        </p:spPr>
-        <p:txBody>
-          <a:bodyPr wrap="square">
-            <a:spAutoFit/>
-          </a:bodyPr>
-          <a:lstStyle/>
-          <a:p>
-            <a:pPr>
-              <a:spcAft>
-                <a:spcPts val="600"/>
-              </a:spcAft>
-            </a:pPr>
-            <a:r>
-              <a:rPr sz="1200" b="0">
-                <a:solidFill>
-                  <a:srgbClr val="282828"/>
-                </a:solidFill>
-                <a:latin typeface="Arial"/>
-              </a:rPr>
-              <a:t>•  The stage-runner sequence on the smaller worked example: specification → design → segmentation → metrology → comparison → simulation, each stage a committed runner handing its prescription to the next.</a:t>
-            </a:r>
-          </a:p>
-          <a:p>
-            <a:pPr>
-              <a:spcAft>
-                <a:spcPts val="600"/>
-              </a:spcAft>
-            </a:pPr>
-            <a:r>
-              <a:rPr sz="1200" b="0">
-                <a:solidFill>
-                  <a:srgbClr val="282828"/>
-                </a:solidFill>
-                <a:latin typeface="Arial"/>
-              </a:rPr>
-              <a:t>•  A 4 m f/18 telescope (f/1.75 primary) from a closed-form first-order seed; diffraction-limited over ±1′ alone, and the Offner ring-field relay buys the full ±2′ (Strehl floor 0.965, on pure spheres).</a:t>
-            </a:r>
-          </a:p>
-        </p:txBody>
-      </p:sp>
-      <p:pic>
-        <p:nvPicPr>
-          <p:cNvPr id="5" name="Picture 4" descr="rowpair_s1_views.png"/>
-          <p:cNvPicPr>
-            <a:picLocks noChangeAspect="1"/>
-          </p:cNvPicPr>
-          <p:nvPr/>
-        </p:nvPicPr>
-        <p:blipFill>
-          <a:blip r:embed="rId2"/>
-          <a:stretch>
-            <a:fillRect/>
-          </a:stretch>
-        </p:blipFill>
-        <p:spPr>
-          <a:xfrm>
-            <a:off x="6738659" y="1298448"/>
-            <a:ext cx="4719240" cy="2056892"/>
-          </a:xfrm>
-          <a:prstGeom prst="rect">
-            <a:avLst/>
-          </a:prstGeom>
-        </p:spPr>
-      </p:pic>
-      <p:sp>
-        <p:nvSpPr>
-          <p:cNvPr id="6" name="TextBox 5"/>
-          <p:cNvSpPr txBox="1"/>
-          <p:nvPr/>
-        </p:nvSpPr>
-        <p:spPr>
-          <a:xfrm>
-            <a:off x="6400800" y="3373628"/>
-            <a:ext cx="5394960" cy="229107"/>
-          </a:xfrm>
-          <a:prstGeom prst="rect">
-            <a:avLst/>
-          </a:prstGeom>
-          <a:noFill/>
-        </p:spPr>
-        <p:txBody>
-          <a:bodyPr wrap="square">
-            <a:spAutoFit/>
-          </a:bodyPr>
-          <a:lstStyle/>
-          <a:p>
-            <a:pPr algn="ctr">
-              <a:spcAft>
-                <a:spcPts val="0"/>
-              </a:spcAft>
-            </a:pPr>
-            <a:r>
-              <a:rPr sz="1000" b="0">
-                <a:solidFill>
-                  <a:srgbClr val="6E6E6E"/>
-                </a:solidFill>
-                <a:latin typeface="Arial"/>
-              </a:rPr>
-              <a:t>The telescope as designed (front + iso views), with the traced field.</a:t>
-            </a:r>
-          </a:p>
-        </p:txBody>
-      </p:sp>
-      <p:pic>
-        <p:nvPicPr>
-          <p:cNvPr id="7" name="Picture 6" descr="s1_wfe_field.png"/>
-          <p:cNvPicPr>
-            <a:picLocks noChangeAspect="1"/>
-          </p:cNvPicPr>
-          <p:nvPr/>
-        </p:nvPicPr>
-        <p:blipFill>
-          <a:blip r:embed="rId3"/>
-          <a:stretch>
-            <a:fillRect/>
-          </a:stretch>
-        </p:blipFill>
-        <p:spPr>
-          <a:xfrm>
-            <a:off x="7993860" y="3639312"/>
-            <a:ext cx="2208839" cy="1782572"/>
-          </a:xfrm>
-          <a:prstGeom prst="rect">
-            <a:avLst/>
-          </a:prstGeom>
-        </p:spPr>
-      </p:pic>
-      <p:sp>
-        <p:nvSpPr>
-          <p:cNvPr id="8" name="TextBox 7"/>
-          <p:cNvSpPr txBox="1"/>
-          <p:nvPr/>
-        </p:nvSpPr>
-        <p:spPr>
-          <a:xfrm>
-            <a:off x="6400800" y="5440171"/>
-            <a:ext cx="5394960" cy="229107"/>
-          </a:xfrm>
-          <a:prstGeom prst="rect">
-            <a:avLst/>
-          </a:prstGeom>
-          <a:noFill/>
-        </p:spPr>
-        <p:txBody>
-          <a:bodyPr wrap="square">
-            <a:spAutoFit/>
-          </a:bodyPr>
-          <a:lstStyle/>
-          <a:p>
-            <a:pPr algn="ctr">
-              <a:spcAft>
-                <a:spcPts val="0"/>
-              </a:spcAft>
-            </a:pPr>
-            <a:r>
-              <a:rPr sz="1000" b="0">
-                <a:solidFill>
-                  <a:srgbClr val="6E6E6E"/>
-                </a:solidFill>
-                <a:latin typeface="Arial"/>
-              </a:rPr>
-              <a:t>Wavefront error over the field: diffraction-limited across the box.</a:t>
-            </a:r>
-          </a:p>
-        </p:txBody>
-      </p:sp>
-      <p:sp>
-        <p:nvSpPr>
-          <p:cNvPr id="9" name="TextBox 8"/>
-          <p:cNvSpPr txBox="1"/>
-          <p:nvPr/>
-        </p:nvSpPr>
-        <p:spPr>
-          <a:xfrm>
-            <a:off x="6400800" y="5705855"/>
-            <a:ext cx="5394960" cy="274320"/>
-          </a:xfrm>
-          <a:prstGeom prst="rect">
-            <a:avLst/>
-          </a:prstGeom>
-          <a:noFill/>
-        </p:spPr>
-        <p:txBody>
-          <a:bodyPr wrap="square">
-            <a:spAutoFit/>
-          </a:bodyPr>
-          <a:lstStyle/>
-          <a:p>
-            <a:pPr>
-              <a:spcAft>
-                <a:spcPts val="600"/>
-              </a:spcAft>
-            </a:pPr>
-            <a:r>
-              <a:rPr sz="1050" b="0">
-                <a:solidFill>
-                  <a:srgbClr val="6E6E6E"/>
-                </a:solidFill>
-                <a:latin typeface="Arial"/>
-              </a:rPr>
-              <a:t>Record: templates/80_end_to_end/e2e — staged worked example, committed at every step.</a:t>
             </a:r>
           </a:p>
         </p:txBody>
@@ -13629,7 +13504,7 @@
                 </a:solidFill>
                 <a:latin typeface="Arial"/>
               </a:rPr>
-              <a:t>The e2e worked example: segmentation and metrology</a:t>
+              <a:t>The e2e worked example: specification to design</a:t>
             </a:r>
           </a:p>
           <a:p>
@@ -13645,7 +13520,7 @@
                 </a:solidFill>
                 <a:latin typeface="Arial"/>
               </a:rPr>
-              <a:t>The monolith segments in one call; the metrology is designed on the same Jacobian</a:t>
+              <a:t>A 4 m f/18 visible-band telescope from a closed-form seed — no starting prescription</a:t>
             </a:r>
           </a:p>
         </p:txBody>
@@ -13728,7 +13603,7 @@
                 </a:solidFill>
                 <a:latin typeface="Arial"/>
               </a:rPr>
-              <a:t>•  The primary segments into a pie or hex tiling with physical apertures; every segment gets rigid-body and surface-figure sensitivity channels, stacked into one Jacobian — the control basis.</a:t>
+              <a:t>•  The stage-runner sequence on the smaller worked example: specification → design → segmentation → metrology → comparison → simulation, each stage a committed runner handing its prescription to the next.</a:t>
             </a:r>
           </a:p>
           <a:p>
@@ -13744,14 +13619,14 @@
                 </a:solidFill>
                 <a:latin typeface="Arial"/>
               </a:rPr>
-              <a:t>•  Metrology is an optimization on that basis: edge-sensor and beam-launcher layouts scored by the control information they carry, not by symmetry; the winning pattern exports as a reusable preset.</a:t>
+              <a:t>•  A 4 m f/18 telescope (f/1.75 primary) from a closed-form first-order seed; diffraction-limited over ±1′ alone, and the Offner ring-field relay buys the full ±2′ (Strehl floor 0.965, on pure spheres).</a:t>
             </a:r>
           </a:p>
         </p:txBody>
       </p:sp>
       <p:pic>
         <p:nvPicPr>
-          <p:cNvPr id="5" name="Picture 4" descr="rowpair_s3_views_pie.png"/>
+          <p:cNvPr id="5" name="Picture 4" descr="rowpair_s1_views.png"/>
           <p:cNvPicPr>
             <a:picLocks noChangeAspect="1"/>
           </p:cNvPicPr>
@@ -13765,8 +13640,8 @@
         </p:blipFill>
         <p:spPr>
           <a:xfrm>
-            <a:off x="6618167" y="1298448"/>
-            <a:ext cx="4960224" cy="1965451"/>
+            <a:off x="6738659" y="1298448"/>
+            <a:ext cx="4719240" cy="2056892"/>
           </a:xfrm>
           <a:prstGeom prst="rect">
             <a:avLst/>
@@ -13781,7 +13656,7 @@
         </p:nvSpPr>
         <p:spPr>
           <a:xfrm>
-            <a:off x="6400800" y="3282188"/>
+            <a:off x="6400800" y="3373628"/>
             <a:ext cx="5394960" cy="229107"/>
           </a:xfrm>
           <a:prstGeom prst="rect">
@@ -13807,14 +13682,14 @@
                 </a:solidFill>
                 <a:latin typeface="Arial"/>
               </a:rPr>
-              <a:t>The segmented primary with physical apertures (front + iso views).</a:t>
+              <a:t>The telescope as designed (front + iso views), with the traced field.</a:t>
             </a:r>
           </a:p>
         </p:txBody>
       </p:sp>
       <p:pic>
         <p:nvPicPr>
-          <p:cNvPr id="7" name="Picture 6" descr="e2e_pie_met_view_rx.png"/>
+          <p:cNvPr id="7" name="Picture 6" descr="s1_wfe_field.png"/>
           <p:cNvPicPr>
             <a:picLocks noChangeAspect="1"/>
           </p:cNvPicPr>
@@ -13828,8 +13703,8 @@
         </p:blipFill>
         <p:spPr>
           <a:xfrm>
-            <a:off x="7662896" y="3547872"/>
-            <a:ext cx="2870767" cy="1874011"/>
+            <a:off x="7993860" y="3639312"/>
+            <a:ext cx="2208839" cy="1782572"/>
           </a:xfrm>
           <a:prstGeom prst="rect">
             <a:avLst/>
@@ -13870,7 +13745,7 @@
                 </a:solidFill>
                 <a:latin typeface="Arial"/>
               </a:rPr>
-              <a:t>The optimized metrology layout on the segmented primary.</a:t>
+              <a:t>Wavefront error over the field: diffraction-limited across the box.</a:t>
             </a:r>
           </a:p>
         </p:txBody>
@@ -13909,7 +13784,7 @@
                 </a:solidFill>
                 <a:latin typeface="Arial"/>
               </a:rPr>
-              <a:t>Record: templates/80_end_to_end/e2e, stages 3–5.</a:t>
+              <a:t>Record: templates/80_end_to_end/e2e — staged worked example, committed at every step.</a:t>
             </a:r>
           </a:p>
         </p:txBody>
@@ -13923,6 +13798,343 @@
 </file>
 
 <file path=ppt/slides/slide33.xml><?xml version="1.0" encoding="utf-8"?>
+<p:sld xmlns:a="http://schemas.openxmlformats.org/drawingml/2006/main" xmlns:p="http://schemas.openxmlformats.org/presentationml/2006/main" xmlns:r="http://schemas.openxmlformats.org/officeDocument/2006/relationships">
+  <p:cSld>
+    <p:spTree>
+      <p:nvGrpSpPr>
+        <p:cNvPr id="1" name=""/>
+        <p:cNvGrpSpPr/>
+        <p:nvPr/>
+      </p:nvGrpSpPr>
+      <p:grpSpPr/>
+      <p:sp>
+        <p:nvSpPr>
+          <p:cNvPr id="2" name="TextBox 1"/>
+          <p:cNvSpPr txBox="1"/>
+          <p:nvPr/>
+        </p:nvSpPr>
+        <p:spPr>
+          <a:xfrm>
+            <a:off x="411480" y="201168"/>
+            <a:ext cx="11368735" cy="914400"/>
+          </a:xfrm>
+          <a:prstGeom prst="rect">
+            <a:avLst/>
+          </a:prstGeom>
+          <a:noFill/>
+        </p:spPr>
+        <p:txBody>
+          <a:bodyPr wrap="square">
+            <a:spAutoFit/>
+          </a:bodyPr>
+          <a:lstStyle/>
+          <a:p>
+            <a:pPr>
+              <a:spcAft>
+                <a:spcPts val="400"/>
+              </a:spcAft>
+            </a:pPr>
+            <a:r>
+              <a:rPr sz="2400" b="1">
+                <a:solidFill>
+                  <a:srgbClr val="1F4E79"/>
+                </a:solidFill>
+                <a:latin typeface="Arial"/>
+              </a:rPr>
+              <a:t>The e2e worked example: segmentation and metrology</a:t>
+            </a:r>
+          </a:p>
+          <a:p>
+            <a:pPr>
+              <a:spcAft>
+                <a:spcPts val="0"/>
+              </a:spcAft>
+            </a:pPr>
+            <a:r>
+              <a:rPr sz="1250" b="0">
+                <a:solidFill>
+                  <a:srgbClr val="6E6E6E"/>
+                </a:solidFill>
+                <a:latin typeface="Arial"/>
+              </a:rPr>
+              <a:t>The monolith segments in one call; the metrology is designed on the same Jacobian</a:t>
+            </a:r>
+          </a:p>
+        </p:txBody>
+      </p:sp>
+      <p:sp>
+        <p:nvSpPr>
+          <p:cNvPr id="3" name="Rectangle 2"/>
+          <p:cNvSpPr/>
+          <p:nvPr/>
+        </p:nvSpPr>
+        <p:spPr>
+          <a:xfrm>
+            <a:off x="411480" y="1133856"/>
+            <a:ext cx="11368735" cy="20320"/>
+          </a:xfrm>
+          <a:prstGeom prst="rect">
+            <a:avLst/>
+          </a:prstGeom>
+          <a:solidFill>
+            <a:srgbClr val="B8C6D4"/>
+          </a:solidFill>
+          <a:ln>
+            <a:noFill/>
+          </a:ln>
+          <a:effectLst/>
+        </p:spPr>
+        <p:style>
+          <a:lnRef idx="1">
+            <a:schemeClr val="accent1"/>
+          </a:lnRef>
+          <a:fillRef idx="3">
+            <a:schemeClr val="accent1"/>
+          </a:fillRef>
+          <a:effectRef idx="2">
+            <a:schemeClr val="accent1"/>
+          </a:effectRef>
+          <a:fontRef idx="minor">
+            <a:schemeClr val="lt1"/>
+          </a:fontRef>
+        </p:style>
+        <p:txBody>
+          <a:bodyPr rtlCol="0" anchor="ctr"/>
+          <a:lstStyle/>
+          <a:p>
+            <a:pPr algn="ctr"/>
+          </a:p>
+        </p:txBody>
+      </p:sp>
+      <p:sp>
+        <p:nvSpPr>
+          <p:cNvPr id="4" name="TextBox 3"/>
+          <p:cNvSpPr txBox="1"/>
+          <p:nvPr/>
+        </p:nvSpPr>
+        <p:spPr>
+          <a:xfrm>
+            <a:off x="411480" y="1298448"/>
+            <a:ext cx="5806440" cy="274320"/>
+          </a:xfrm>
+          <a:prstGeom prst="rect">
+            <a:avLst/>
+          </a:prstGeom>
+          <a:noFill/>
+        </p:spPr>
+        <p:txBody>
+          <a:bodyPr wrap="square">
+            <a:spAutoFit/>
+          </a:bodyPr>
+          <a:lstStyle/>
+          <a:p>
+            <a:pPr>
+              <a:spcAft>
+                <a:spcPts val="600"/>
+              </a:spcAft>
+            </a:pPr>
+            <a:r>
+              <a:rPr sz="1200" b="0">
+                <a:solidFill>
+                  <a:srgbClr val="282828"/>
+                </a:solidFill>
+                <a:latin typeface="Arial"/>
+              </a:rPr>
+              <a:t>•  The primary segments into a pie or hex tiling with physical apertures; every segment gets rigid-body and surface-figure sensitivity channels, stacked into one Jacobian — the control basis.</a:t>
+            </a:r>
+          </a:p>
+          <a:p>
+            <a:pPr>
+              <a:spcAft>
+                <a:spcPts val="600"/>
+              </a:spcAft>
+            </a:pPr>
+            <a:r>
+              <a:rPr sz="1200" b="0">
+                <a:solidFill>
+                  <a:srgbClr val="282828"/>
+                </a:solidFill>
+                <a:latin typeface="Arial"/>
+              </a:rPr>
+              <a:t>•  Metrology is an optimization on that basis: edge-sensor and beam-launcher layouts scored by the control information they carry, not by symmetry; the winning pattern exports as a reusable preset.</a:t>
+            </a:r>
+          </a:p>
+        </p:txBody>
+      </p:sp>
+      <p:pic>
+        <p:nvPicPr>
+          <p:cNvPr id="5" name="Picture 4" descr="rowpair_s3_views_pie.png"/>
+          <p:cNvPicPr>
+            <a:picLocks noChangeAspect="1"/>
+          </p:cNvPicPr>
+          <p:nvPr/>
+        </p:nvPicPr>
+        <p:blipFill>
+          <a:blip r:embed="rId2"/>
+          <a:stretch>
+            <a:fillRect/>
+          </a:stretch>
+        </p:blipFill>
+        <p:spPr>
+          <a:xfrm>
+            <a:off x="6618167" y="1298448"/>
+            <a:ext cx="4960224" cy="1965451"/>
+          </a:xfrm>
+          <a:prstGeom prst="rect">
+            <a:avLst/>
+          </a:prstGeom>
+        </p:spPr>
+      </p:pic>
+      <p:sp>
+        <p:nvSpPr>
+          <p:cNvPr id="6" name="TextBox 5"/>
+          <p:cNvSpPr txBox="1"/>
+          <p:nvPr/>
+        </p:nvSpPr>
+        <p:spPr>
+          <a:xfrm>
+            <a:off x="6400800" y="3282188"/>
+            <a:ext cx="5394960" cy="229107"/>
+          </a:xfrm>
+          <a:prstGeom prst="rect">
+            <a:avLst/>
+          </a:prstGeom>
+          <a:noFill/>
+        </p:spPr>
+        <p:txBody>
+          <a:bodyPr wrap="square">
+            <a:spAutoFit/>
+          </a:bodyPr>
+          <a:lstStyle/>
+          <a:p>
+            <a:pPr algn="ctr">
+              <a:spcAft>
+                <a:spcPts val="0"/>
+              </a:spcAft>
+            </a:pPr>
+            <a:r>
+              <a:rPr sz="1000" b="0">
+                <a:solidFill>
+                  <a:srgbClr val="6E6E6E"/>
+                </a:solidFill>
+                <a:latin typeface="Arial"/>
+              </a:rPr>
+              <a:t>The segmented primary with physical apertures (front + iso views).</a:t>
+            </a:r>
+          </a:p>
+        </p:txBody>
+      </p:sp>
+      <p:pic>
+        <p:nvPicPr>
+          <p:cNvPr id="7" name="Picture 6" descr="e2e_pie_met_view_rx.png"/>
+          <p:cNvPicPr>
+            <a:picLocks noChangeAspect="1"/>
+          </p:cNvPicPr>
+          <p:nvPr/>
+        </p:nvPicPr>
+        <p:blipFill>
+          <a:blip r:embed="rId3"/>
+          <a:stretch>
+            <a:fillRect/>
+          </a:stretch>
+        </p:blipFill>
+        <p:spPr>
+          <a:xfrm>
+            <a:off x="7662896" y="3547872"/>
+            <a:ext cx="2870767" cy="1874011"/>
+          </a:xfrm>
+          <a:prstGeom prst="rect">
+            <a:avLst/>
+          </a:prstGeom>
+        </p:spPr>
+      </p:pic>
+      <p:sp>
+        <p:nvSpPr>
+          <p:cNvPr id="8" name="TextBox 7"/>
+          <p:cNvSpPr txBox="1"/>
+          <p:nvPr/>
+        </p:nvSpPr>
+        <p:spPr>
+          <a:xfrm>
+            <a:off x="6400800" y="5440171"/>
+            <a:ext cx="5394960" cy="229107"/>
+          </a:xfrm>
+          <a:prstGeom prst="rect">
+            <a:avLst/>
+          </a:prstGeom>
+          <a:noFill/>
+        </p:spPr>
+        <p:txBody>
+          <a:bodyPr wrap="square">
+            <a:spAutoFit/>
+          </a:bodyPr>
+          <a:lstStyle/>
+          <a:p>
+            <a:pPr algn="ctr">
+              <a:spcAft>
+                <a:spcPts val="0"/>
+              </a:spcAft>
+            </a:pPr>
+            <a:r>
+              <a:rPr sz="1000" b="0">
+                <a:solidFill>
+                  <a:srgbClr val="6E6E6E"/>
+                </a:solidFill>
+                <a:latin typeface="Arial"/>
+              </a:rPr>
+              <a:t>The optimized metrology layout on the segmented primary.</a:t>
+            </a:r>
+          </a:p>
+        </p:txBody>
+      </p:sp>
+      <p:sp>
+        <p:nvSpPr>
+          <p:cNvPr id="9" name="TextBox 8"/>
+          <p:cNvSpPr txBox="1"/>
+          <p:nvPr/>
+        </p:nvSpPr>
+        <p:spPr>
+          <a:xfrm>
+            <a:off x="6400800" y="5705855"/>
+            <a:ext cx="5394960" cy="274320"/>
+          </a:xfrm>
+          <a:prstGeom prst="rect">
+            <a:avLst/>
+          </a:prstGeom>
+          <a:noFill/>
+        </p:spPr>
+        <p:txBody>
+          <a:bodyPr wrap="square">
+            <a:spAutoFit/>
+          </a:bodyPr>
+          <a:lstStyle/>
+          <a:p>
+            <a:pPr>
+              <a:spcAft>
+                <a:spcPts val="600"/>
+              </a:spcAft>
+            </a:pPr>
+            <a:r>
+              <a:rPr sz="1050" b="0">
+                <a:solidFill>
+                  <a:srgbClr val="6E6E6E"/>
+                </a:solidFill>
+                <a:latin typeface="Arial"/>
+              </a:rPr>
+              <a:t>Record: templates/80_end_to_end/e2e, stages 3–5.</a:t>
+            </a:r>
+          </a:p>
+        </p:txBody>
+      </p:sp>
+    </p:spTree>
+  </p:cSld>
+  <p:clrMapOvr>
+    <a:masterClrMapping/>
+  </p:clrMapOvr>
+</p:sld>
+</file>
+
+<file path=ppt/slides/slide34.xml><?xml version="1.0" encoding="utf-8"?>
 <p:sld xmlns:a="http://schemas.openxmlformats.org/drawingml/2006/main" xmlns:p="http://schemas.openxmlformats.org/presentationml/2006/main" xmlns:r="http://schemas.openxmlformats.org/officeDocument/2006/relationships">
   <p:cSld>
     <p:spTree>

</xml_diff>

<commit_message>
deck: slide 13 = the defect no fold could fix, resolved (Dave sign-off 2026-08-30)
The four-fold recipe is retired as the headline (Path A does not close
on the cleared deck and is not needed): slide 13 now carries the
field-walk ratio law (2.43x needed, 1.30 measured, one scale pinned by
the interface), the -10 deg extraction-tilt fix at +37.8 mm with the
wavefront 14% better, the price stated (blur 157->553 um, breathing
0.12->0.82%), the self-packaging (1.81x -> 1.24x, zero flats), and the
promoted union gate with its non-vacuity line.  Figure = TO's
afocal4_clear_layouts three-way, interior blank bands squeezed
(_tight variant, content untouched).  Slide 12 footnote now bridges:
'buildability re-prices this trade -- next slide.'

Numbers may be re-cut once the walled, converged frontier lands
(BRIEF_afocal4_wall Task 2) -- with fresh sign-off.

Co-Authored-By: Claude Fable 5 <noreply@anthropic.com>
</commit_message>
<xml_diff>
--- a/demo_session/deck_keysight.pptx
+++ b/demo_session/deck_keysight.pptx
@@ -5562,7 +5562,7 @@
                 </a:solidFill>
                 <a:latin typeface="Arial"/>
               </a:rPr>
-              <a:t>Yardsticks: pupil imaging resolves 2.7 µm across the 33 mm pupil, depth of focus ~30 µm — the measured defects sit 50–350× above these floors.  Per-point trade table: the design/rodgers2 record.  Packaging the 343 mm point: next slide.</a:t>
+              <a:t>Yardsticks: pupil imaging resolves 2.7 µm across the 33 mm pupil, depth of focus ~30 µm — the measured defects sit 50–350× above these floors.  Per-point trade table: the design/rodgers2 record.  Buildability re-prices this trade — next slide.</a:t>
             </a:r>
           </a:p>
         </p:txBody>
@@ -5619,7 +5619,7 @@
                 </a:solidFill>
                 <a:latin typeface="Arial"/>
               </a:rPr>
-              <a:t>Challenge 2: packaging behind the primary</a:t>
+              <a:t>Challenge 2: packaging — and the defect no fold could fix</a:t>
             </a:r>
           </a:p>
           <a:p>
@@ -5635,7 +5635,7 @@
                 </a:solidFill>
                 <a:latin typeface="Arial"/>
               </a:rPr>
-              <a:t>As committed, the deepest optic overhangs the M1–M2 span 1.81× — four folds bring it to 0.86×</a:t>
+              <a:t>The collimator stood in its own feed beam by −80 mm; a −10° extraction tilt clears it at +38 mm — wavefront 14% better</a:t>
             </a:r>
           </a:p>
         </p:txBody>
@@ -5686,7 +5686,7 @@
       </p:sp>
       <p:pic>
         <p:nvPicPr>
-          <p:cNvPr id="4" name="Picture 3" descr="afocal4_pack_compare.png"/>
+          <p:cNvPr id="4" name="Picture 3" descr="afocal4_clear_layouts_tight.png"/>
           <p:cNvPicPr>
             <a:picLocks noChangeAspect="1"/>
           </p:cNvPicPr>
@@ -5700,8 +5700,8 @@
         </p:blipFill>
         <p:spPr>
           <a:xfrm>
-            <a:off x="3223672" y="1298448"/>
-            <a:ext cx="5744349" cy="2458212"/>
+            <a:off x="1757567" y="1298448"/>
+            <a:ext cx="8676559" cy="2275332"/>
           </a:xfrm>
           <a:prstGeom prst="rect">
             <a:avLst/>
@@ -5716,7 +5716,7 @@
         </p:nvSpPr>
         <p:spPr>
           <a:xfrm>
-            <a:off x="411480" y="3774947"/>
+            <a:off x="411480" y="3592068"/>
             <a:ext cx="11368735" cy="559307"/>
           </a:xfrm>
           <a:prstGeom prst="rect">
@@ -5742,7 +5742,7 @@
                 </a:solidFill>
                 <a:latin typeface="Arial"/>
               </a:rPr>
-              <a:t>Engine-truth packaging, three ways: as committed, the deepest optic sits 1.887 m behind the primary against a 1.042 m M1–M2 span (left); the recorded single-fold recipe touches no depth and throws the instrument radially (middle); four folds in the feed leg bring the deepest optic to 0.893 m — inside the telescope's own envelope — at Ø1.120 × 2.832 m (right).</a:t>
+              <a:t>Engine truth, three ways: the committed 343 mm deck (deepest optic 1.887 m behind the 1.042 m M1–M2 span, the feed beam through the collimator by −79.9 mm over the field box); the four-flat fold recipe (0.893 m deep — but a fold is an isometry, and the interference rides across unchanged); the cleared −10° extraction-tilt deck: +37.8 mm of daylight, deepest optic 1.287 m, zero flats.</a:t>
             </a:r>
           </a:p>
         </p:txBody>
@@ -5755,7 +5755,7 @@
         </p:nvSpPr>
         <p:spPr>
           <a:xfrm>
-            <a:off x="411480" y="4370831"/>
+            <a:off x="411480" y="4187952"/>
             <a:ext cx="11368735" cy="274320"/>
           </a:xfrm>
           <a:prstGeom prst="rect">
@@ -5781,7 +5781,7 @@
                 </a:solidFill>
                 <a:latin typeface="Arial"/>
               </a:rPr>
-              <a:t>•  The fix is real and priced: zero rays lost, fold null asserted at 3×10⁻⁸ nm; costs stated, not smoothed — the new flats clear by +5.8 mm, are ~300 mm across and decentred 100–146 mm, and four 45° folds are an unopened polarization budget.</a:t>
+              <a:t>•  Why no fold could ever fix it: a part's union footprint and a beam's at one station are scaled copies of the same off-axis field box — they separate only if their scales differ by 2.43×, and the measured ratio is 1.30, one scale pinned by the customer interface.  The best flat placement anywhere reproduces −79.9 mm to the last digit; every point of the committed trade curve fails the same gate.</a:t>
             </a:r>
           </a:p>
           <a:p>
@@ -5797,7 +5797,7 @@
                 </a:solidFill>
                 <a:latin typeface="Arial"/>
               </a:rPr>
-              <a:t>•  The measurement found what no fold can fix: over the field box, the collimator stands in the union of its own feed beams — −55 mm against bare glass with no allowance at all.  A fold is an isometry and carries it across unchanged; the redesign is queued.</a:t>
+              <a:t>•  The fix is optical, and priced: tilt the field mirror −10° and re-solve around it.  Clears at +37.8 mm with zero rays lost; wavefront 8993 vs 10407 nm; the interface holds (30.015×, 33.57 mm exit beam).  It packages itself — deepest optic 1.81× → 1.24× the M1–M2 spacing, with zero fold flats.  The price is the fourth mirror's pupil control: blur 157 → 553 µm, breathing 0.12 → 0.82% — still 4× steadier than three mirrors.</a:t>
             </a:r>
           </a:p>
         </p:txBody>
@@ -5810,7 +5810,7 @@
         </p:nvSpPr>
         <p:spPr>
           <a:xfrm>
-            <a:off x="411480" y="6173723"/>
+            <a:off x="411480" y="6486144"/>
             <a:ext cx="11368735" cy="274320"/>
           </a:xfrm>
           <a:prstGeom prst="rect">
@@ -5836,7 +5836,7 @@
                 </a:solidFill>
                 <a:latin typeface="Arial"/>
               </a:rPr>
-              <a:t>The recorded single-fold layout passed its gate on a 17.5-vs-15 mm margin while its flat clips the feed beam by −74 mm — a gate's margin is a number, not a body.  Record: challenges/afocal4/packaging.</a:t>
+              <a:t>The recorded single-fold layout passed its gate on a 17.5-vs-15 mm margin while its flat clips the feed beam by −74 mm — a gate's margin is a number, not a body.  The union-footprint check is now a standing gate: it fails the committed deck and passes the cleared one.  Record: challenges/afocal4/{packaging,clearing}.</a:t>
             </a:r>
           </a:p>
         </p:txBody>

</xml_diff>

<commit_message>
deck slide 20: the coronagraph bench still needs packaging work -- stated forward (Dave 2026-08-31)
Dave's ruling: no assert-and-retract.  The slide now says what is done
(the telescope packaged to the 8 m shroud) and what remains, with the
plan: the challenge-2 body-in-beam gate -- which, run on this train,
finds the bench nicking the M1-M2 beam (Backend -5.1 mm bare) and the
DM pocket's folded legs overlapping (-13.1 mm bare both ways) -- joins
the template's standing checks; the bench clocks and drops out of the
trunk beam via a pickoff-fold re-pose (an optical null); the pocket's
fold angles open with a small re-solve priced in wavefront; the train
re-verifies end to end.  Edit-deck sync deferred: the gate refused
(Impress lock present -- Dave is in the file); sync follows his close.

Co-Authored-By: Claude Fable 5 <noreply@anthropic.com>
</commit_message>
<xml_diff>
--- a/demo_session/deck_keysight.pptx
+++ b/demo_session/deck_keysight.pptx
@@ -9412,7 +9412,23 @@
                 </a:solidFill>
                 <a:latin typeface="Arial"/>
               </a:rPr>
-              <a:t>•  The testbed is where the models are built and proven; the same modeling then builds the flight-like system: an unobscured 6 m telescope from the design-layer templates — imaging leg and coronagraph leg, with the same DMs, apodizer, focal-plane mask and Lyot machinery — packaged to an 8 m launch shroud, drawn and checked.</a:t>
+              <a:t>•  The testbed is where the models are built and proven; the same modeling then builds the flight-like system: an unobscured 6 m telescope from the design-layer templates — imaging leg and coronagraph leg, with the same DMs, apodizer, focal-plane mask and Lyot machinery — the telescope packaged to an 8 m launch shroud.</a:t>
+            </a:r>
+          </a:p>
+          <a:p>
+            <a:pPr>
+              <a:spcAft>
+                <a:spcPts val="600"/>
+              </a:spcAft>
+            </a:pPr>
+            <a:r>
+              <a:rPr sz="1500" b="0">
+                <a:solidFill>
+                  <a:srgbClr val="282828"/>
+                </a:solidFill>
+                <a:latin typeface="Arial"/>
+              </a:rPr>
+              <a:t>•  The coronagraph bench still needs packaging work: the body-in-beam gate built for challenge 2, run on this train, finds the bench nicking the M1–M2 beam and the DM pocket's folded legs overlapping.  In the days ahead: the gate joins the template's standing checks; the bench clocks and drops out of the trunk beam by re-posing its pickoff fold — an optical null; the pocket's fold angles open with a small re-solve, priced in wavefront; the train re-verifies end to end.</a:t>
             </a:r>
           </a:p>
         </p:txBody>
@@ -9433,8 +9449,8 @@
         </p:blipFill>
         <p:spPr>
           <a:xfrm>
-            <a:off x="859353" y="2218182"/>
-            <a:ext cx="4910692" cy="3537712"/>
+            <a:off x="1684384" y="3348989"/>
+            <a:ext cx="3260631" cy="2348992"/>
           </a:xfrm>
           <a:prstGeom prst="rect">
             <a:avLst/>
@@ -9449,7 +9465,7 @@
         </p:nvSpPr>
         <p:spPr>
           <a:xfrm>
-            <a:off x="411480" y="5774181"/>
+            <a:off x="411480" y="5716269"/>
             <a:ext cx="5806440" cy="394208"/>
           </a:xfrm>
           <a:prstGeom prst="rect">
@@ -9480,9 +9496,48 @@
           </a:p>
         </p:txBody>
       </p:sp>
+      <p:sp>
+        <p:nvSpPr>
+          <p:cNvPr id="7" name="TextBox 6"/>
+          <p:cNvSpPr txBox="1"/>
+          <p:nvPr/>
+        </p:nvSpPr>
+        <p:spPr>
+          <a:xfrm>
+            <a:off x="411480" y="6147053"/>
+            <a:ext cx="5806440" cy="274320"/>
+          </a:xfrm>
+          <a:prstGeom prst="rect">
+            <a:avLst/>
+          </a:prstGeom>
+          <a:noFill/>
+        </p:spPr>
+        <p:txBody>
+          <a:bodyPr wrap="square">
+            <a:spAutoFit/>
+          </a:bodyPr>
+          <a:lstStyle/>
+          <a:p>
+            <a:pPr>
+              <a:spcAft>
+                <a:spcPts val="600"/>
+              </a:spcAft>
+            </a:pPr>
+            <a:r>
+              <a:rPr sz="1050" b="0">
+                <a:solidFill>
+                  <a:srgbClr val="6E6E6E"/>
+                </a:solidFill>
+                <a:latin typeface="Arial"/>
+              </a:rPr>
+              <a:t>The telescope is diffraction-limited at 500 nm (imaging-leg Strehl 0.9993).  Record: templates/80_end_to_end/e2e6m_r2.</a:t>
+            </a:r>
+          </a:p>
+        </p:txBody>
+      </p:sp>
       <p:pic>
         <p:nvPicPr>
-          <p:cNvPr id="7" name="Picture 6" descr="r1_seg_d110_shroud.png"/>
+          <p:cNvPr id="8" name="Picture 7" descr="r1_seg_d110_shroud.png"/>
           <p:cNvPicPr>
             <a:picLocks noChangeAspect="1"/>
           </p:cNvPicPr>
@@ -9496,8 +9551,8 @@
         </p:blipFill>
         <p:spPr>
           <a:xfrm>
-            <a:off x="7030679" y="2218182"/>
-            <a:ext cx="4135200" cy="2989072"/>
+            <a:off x="7410184" y="3348989"/>
+            <a:ext cx="3376190" cy="2440432"/>
           </a:xfrm>
           <a:prstGeom prst="rect">
             <a:avLst/>
@@ -9506,13 +9561,13 @@
       </p:pic>
       <p:sp>
         <p:nvSpPr>
-          <p:cNvPr id="8" name="TextBox 7"/>
+          <p:cNvPr id="9" name="TextBox 8"/>
           <p:cNvSpPr txBox="1"/>
           <p:nvPr/>
         </p:nvSpPr>
         <p:spPr>
           <a:xfrm>
-            <a:off x="6400800" y="5225542"/>
+            <a:off x="6400800" y="5807709"/>
             <a:ext cx="5394960" cy="394208"/>
           </a:xfrm>
           <a:prstGeom prst="rect">
@@ -9539,45 +9594,6 @@
                 <a:latin typeface="Arial"/>
               </a:rPr>
               <a:t>End-on in the shroud: the hex-19 telescope and instrument legs — hardware union 7.451 m against the 8.0 m gate.</a:t>
-            </a:r>
-          </a:p>
-        </p:txBody>
-      </p:sp>
-      <p:sp>
-        <p:nvSpPr>
-          <p:cNvPr id="9" name="TextBox 8"/>
-          <p:cNvSpPr txBox="1"/>
-          <p:nvPr/>
-        </p:nvSpPr>
-        <p:spPr>
-          <a:xfrm>
-            <a:off x="6400800" y="5656326"/>
-            <a:ext cx="5394960" cy="274320"/>
-          </a:xfrm>
-          <a:prstGeom prst="rect">
-            <a:avLst/>
-          </a:prstGeom>
-          <a:noFill/>
-        </p:spPr>
-        <p:txBody>
-          <a:bodyPr wrap="square">
-            <a:spAutoFit/>
-          </a:bodyPr>
-          <a:lstStyle/>
-          <a:p>
-            <a:pPr>
-              <a:spcAft>
-                <a:spcPts val="600"/>
-              </a:spcAft>
-            </a:pPr>
-            <a:r>
-              <a:rPr sz="1050" b="0">
-                <a:solidFill>
-                  <a:srgbClr val="6E6E6E"/>
-                </a:solidFill>
-                <a:latin typeface="Arial"/>
-              </a:rPr>
-              <a:t>The telescope is one of the design-layer templates, diffraction-limited at 500 nm (imaging-leg Strehl 0.9993); the two-leg light-order chart is in the record.  Record: templates/80_end_to_end/e2e6m_r2.</a:t>
             </a:r>
           </a:p>
         </p:txBody>

</xml_diff>

<commit_message>
deck slide 10: chief column dropped; centroid column relabeled as what it is -- piston + tilt removed (packet 8.7 equivalence; Dave 2026-08-31); edit-deck sync deferred (Impress lock)
Co-Authored-By: Claude Fable 5 <noreply@anthropic.com>
</commit_message>
<xml_diff>
--- a/demo_session/deck_keysight.pptx
+++ b/demo_session/deck_keysight.pptx
@@ -3362,7 +3362,7 @@
         </p:nvGraphicFramePr>
         <p:xfrm>
           <a:off x="411480" y="1298448"/>
-          <a:ext cx="11368732" cy="1680210"/>
+          <a:ext cx="11368733" cy="1680210"/>
         </p:xfrm>
         <a:graphic>
           <a:graphicData uri="http://schemas.openxmlformats.org/drawingml/2006/table">
@@ -3372,8 +3372,7 @@
               </a:tblPr>
               <a:tblGrid>
                 <a:gridCol w="2734252"/>
-                <a:gridCol w="1870804"/>
-                <a:gridCol w="2158620"/>
+                <a:gridCol w="4029425"/>
                 <a:gridCol w="2446436"/>
                 <a:gridCol w="2158620"/>
               </a:tblGrid>
@@ -3412,29 +3411,7 @@
                           </a:solidFill>
                           <a:latin typeface="Arial"/>
                         </a:rPr>
-                        <a:t>centroid</a:t>
-                      </a:r>
-                    </a:p>
-                  </a:txBody>
-                  <a:tcPr marL="54864" marR="54864" marT="18288" marB="18288">
-                    <a:solidFill>
-                      <a:srgbClr val="1F4E79"/>
-                    </a:solidFill>
-                  </a:tcPr>
-                </a:tc>
-                <a:tc>
-                  <a:txBody>
-                    <a:bodyPr wrap="square"/>
-                    <a:lstStyle/>
-                    <a:p>
-                      <a:r>
-                        <a:rPr sz="1100" b="1">
-                          <a:solidFill>
-                            <a:srgbClr val="FFFFFF"/>
-                          </a:solidFill>
-                          <a:latin typeface="Arial"/>
-                        </a:rPr>
-                        <a:t>(chief)</a:t>
+                        <a:t>MACOS, piston + tilt removed</a:t>
                       </a:r>
                     </a:p>
                   </a:txBody>
@@ -3546,28 +3523,6 @@
                           </a:solidFill>
                           <a:latin typeface="Arial"/>
                         </a:rPr>
-                        <a:t>(672.9 / 390.9)</a:t>
-                      </a:r>
-                    </a:p>
-                  </a:txBody>
-                  <a:tcPr marL="54864" marR="54864" marT="18288" marB="18288">
-                    <a:solidFill>
-                      <a:srgbClr val="FFFFFF"/>
-                    </a:solidFill>
-                  </a:tcPr>
-                </a:tc>
-                <a:tc>
-                  <a:txBody>
-                    <a:bodyPr wrap="square"/>
-                    <a:lstStyle/>
-                    <a:p>
-                      <a:r>
-                        <a:rPr sz="1100" b="0">
-                          <a:solidFill>
-                            <a:srgbClr val="282828"/>
-                          </a:solidFill>
-                          <a:latin typeface="Arial"/>
-                        </a:rPr>
                         <a:t>371.4 / 201.4</a:t>
                       </a:r>
                     </a:p>
@@ -3637,28 +3592,6 @@
                           <a:latin typeface="Arial"/>
                         </a:rPr>
                         <a:t>116.8 / 68.1</a:t>
-                      </a:r>
-                    </a:p>
-                  </a:txBody>
-                  <a:tcPr marL="54864" marR="54864" marT="18288" marB="18288">
-                    <a:solidFill>
-                      <a:srgbClr val="ECF1F6"/>
-                    </a:solidFill>
-                  </a:tcPr>
-                </a:tc>
-                <a:tc>
-                  <a:txBody>
-                    <a:bodyPr wrap="square"/>
-                    <a:lstStyle/>
-                    <a:p>
-                      <a:r>
-                        <a:rPr sz="1100" b="0">
-                          <a:solidFill>
-                            <a:srgbClr val="282828"/>
-                          </a:solidFill>
-                          <a:latin typeface="Arial"/>
-                        </a:rPr>
-                        <a:t>(173.4 / 95.1)</a:t>
                       </a:r>
                     </a:p>
                   </a:txBody>
@@ -3770,28 +3703,6 @@
                           </a:solidFill>
                           <a:latin typeface="Arial"/>
                         </a:rPr>
-                        <a:t>(176.7 / 94.7)</a:t>
-                      </a:r>
-                    </a:p>
-                  </a:txBody>
-                  <a:tcPr marL="54864" marR="54864" marT="18288" marB="18288">
-                    <a:solidFill>
-                      <a:srgbClr val="FFFFFF"/>
-                    </a:solidFill>
-                  </a:tcPr>
-                </a:tc>
-                <a:tc>
-                  <a:txBody>
-                    <a:bodyPr wrap="square"/>
-                    <a:lstStyle/>
-                    <a:p>
-                      <a:r>
-                        <a:rPr sz="1100" b="0">
-                          <a:solidFill>
-                            <a:srgbClr val="282828"/>
-                          </a:solidFill>
-                          <a:latin typeface="Arial"/>
-                        </a:rPr>
                         <a:t>91.9 / 50.2</a:t>
                       </a:r>
                     </a:p>
@@ -3861,28 +3772,6 @@
                           <a:latin typeface="Arial"/>
                         </a:rPr>
                         <a:t>65.6 / 36.4</a:t>
-                      </a:r>
-                    </a:p>
-                  </a:txBody>
-                  <a:tcPr marL="54864" marR="54864" marT="18288" marB="18288">
-                    <a:solidFill>
-                      <a:srgbClr val="ECF1F6"/>
-                    </a:solidFill>
-                  </a:tcPr>
-                </a:tc>
-                <a:tc>
-                  <a:txBody>
-                    <a:bodyPr wrap="square"/>
-                    <a:lstStyle/>
-                    <a:p>
-                      <a:r>
-                        <a:rPr sz="1100" b="0">
-                          <a:solidFill>
-                            <a:srgbClr val="282828"/>
-                          </a:solidFill>
-                          <a:latin typeface="Arial"/>
-                        </a:rPr>
-                        <a:t>(115.9 / 56.9)</a:t>
                       </a:r>
                     </a:p>
                   </a:txBody>
@@ -3994,28 +3883,6 @@
                           </a:solidFill>
                           <a:latin typeface="Arial"/>
                         </a:rPr>
-                        <a:t>(100.5 / 54.4)</a:t>
-                      </a:r>
-                    </a:p>
-                  </a:txBody>
-                  <a:tcPr marL="54864" marR="54864" marT="18288" marB="18288">
-                    <a:solidFill>
-                      <a:srgbClr val="FFFFFF"/>
-                    </a:solidFill>
-                  </a:tcPr>
-                </a:tc>
-                <a:tc>
-                  <a:txBody>
-                    <a:bodyPr wrap="square"/>
-                    <a:lstStyle/>
-                    <a:p>
-                      <a:r>
-                        <a:rPr sz="1100" b="0">
-                          <a:solidFill>
-                            <a:srgbClr val="282828"/>
-                          </a:solidFill>
-                          <a:latin typeface="Arial"/>
-                        </a:rPr>
                         <a:t>39.8 / 22.1</a:t>
                       </a:r>
                     </a:p>
@@ -4221,7 +4088,7 @@
                 </a:solidFill>
                 <a:latin typeface="Arial"/>
               </a:rPr>
-              <a:t>Box max / avg, nm, at the .seq configuration; centroid reference primary, chief in parentheses.  Full record: design/rodgers1 — packet with 10 addenda, every retraction in place.</a:t>
+              <a:t>Box max / avg, nm, at the .seq configuration.  Piston + per-field tip/tilt removed = a centroid-referenced sphere (a chief-referenced sphere leaves the tilt in).  Full record: design/rodgers1 — packet with 10 addenda, every retraction in place.</a:t>
             </a:r>
           </a:p>
         </p:txBody>

</xml_diff>

<commit_message>
deck: Dave's slide 20/21 picture crops+resizes captured; builder gains crop support (cl/cr/ct/cb via sidecar, native pptx picture crops)
Co-Authored-By: Claude Fable 5 <noreply@anthropic.com>
</commit_message>
<xml_diff>
--- a/demo_session/deck_keysight.pptx
+++ b/demo_session/deck_keysight.pptx
@@ -9313,14 +9313,15 @@
         </p:nvPicPr>
         <p:blipFill>
           <a:blip r:embed="rId2"/>
+          <a:srcRect t="21300"/>
           <a:stretch>
             <a:fillRect/>
           </a:stretch>
         </p:blipFill>
         <p:spPr>
           <a:xfrm>
-            <a:off x="996696" y="2980944"/>
-            <a:ext cx="5175504" cy="2825496"/>
+            <a:off x="996696" y="3008376"/>
+            <a:ext cx="5175504" cy="2898648"/>
           </a:xfrm>
           <a:prstGeom prst="rect">
             <a:avLst/>
@@ -9421,8 +9422,8 @@
         </p:blipFill>
         <p:spPr>
           <a:xfrm>
-            <a:off x="7410184" y="3348989"/>
-            <a:ext cx="3376190" cy="2440432"/>
+            <a:off x="7406640" y="2971800"/>
+            <a:ext cx="3895344" cy="2816352"/>
           </a:xfrm>
           <a:prstGeom prst="rect">
             <a:avLst/>
@@ -9437,8 +9438,8 @@
         </p:nvSpPr>
         <p:spPr>
           <a:xfrm>
-            <a:off x="6400800" y="5807709"/>
-            <a:ext cx="5394960" cy="394208"/>
+            <a:off x="7406640" y="5806440"/>
+            <a:ext cx="3895344" cy="394208"/>
           </a:xfrm>
           <a:prstGeom prst="rect">
             <a:avLst/>
@@ -9666,14 +9667,15 @@
         </p:nvPicPr>
         <p:blipFill>
           <a:blip r:embed="rId2"/>
+          <a:srcRect l="29400" r="29400" t="4200" b="5900"/>
           <a:stretch>
             <a:fillRect/>
           </a:stretch>
         </p:blipFill>
         <p:spPr>
           <a:xfrm>
-            <a:off x="7086600" y="1371600"/>
-            <a:ext cx="3886200" cy="5413248"/>
+            <a:off x="7315200" y="1298448"/>
+            <a:ext cx="4114800" cy="5477256"/>
           </a:xfrm>
           <a:prstGeom prst="rect">
             <a:avLst/>

</xml_diff>

<commit_message>
deck: Dave's pass-5 folded + slide-21 actuator kinematics (dw/du)
Slide 21 per Dave: x = (dx/du) u via Stewart-platform kinematics
(segments + M2), control Jacobian dw/du = J dx/du; wavefront control
u = -(dw/du)+ w; metrology command through (dx/du)+.  Pass-5 text:
MACOS_resources added to the title-page public line; 'modeling tools
and practices'; make_mmacos_fig pointer dropped; 'The state equations
I/II/III' retitles (sidecar keys renamed); dw/dDM bullet on III;
'never in the numerics'.  Geometry/typography: toolbox footnote pin;
MET caption right-aligned at its new spot (builder gains cal
alignment); dwdgrid footnote pin; agent-sit slide 20pt + footnote
13pt; recommendations slide 16pt.  Edit-deck sync deferred (lock).

Co-Authored-By: Claude Fable 5 <noreply@anthropic.com>
</commit_message>
<xml_diff>
--- a/demo_session/deck_keysight.pptx
+++ b/demo_session/deck_keysight.pptx
@@ -3208,7 +3208,7 @@
                 </a:solidFill>
                 <a:latin typeface="Arial"/>
               </a:rPr>
-              <a:t>The code is public: github.com/nasa-jpl/macos</a:t>
+              <a:t>The code is public: github.com/nasa-jpl/macos and github.com/nasa-jpl/MACOS_resources</a:t>
             </a:r>
           </a:p>
         </p:txBody>
@@ -9079,7 +9079,7 @@
                 </a:solidFill>
                 <a:latin typeface="Arial"/>
               </a:rPr>
-              <a:t>•  We are now modernizing and extending the capabilities of our modeling to meet new challenges.</a:t>
+              <a:t>•  We are now modernizing and extending our modeling tools and practices to meet new challenges.</a:t>
             </a:r>
           </a:p>
           <a:p>
@@ -9701,7 +9701,7 @@
                 </a:solidFill>
                 <a:latin typeface="Arial"/>
               </a:rPr>
-              <a:t>•  Control using wavefront measurements:   u  =  −J⁺·w ,    J⁺  =  ( JᵀJ + ρI )⁻¹ Jᵀ</a:t>
+              <a:t>•  Actuators to states:   x  =  (∂x/∂u)·u ,   so   ∂w/∂u  =  J·(∂x/∂u)</a:t>
             </a:r>
           </a:p>
           <a:p>
@@ -9717,6 +9717,38 @@
                 </a:solidFill>
                 <a:latin typeface="Arial"/>
               </a:rPr>
+              <a:t>–  Stewart-platform kinematics carry the actuator strokes u of each segment and of M2 into rigid-body states x; ∂w/∂u is the control Jacobian.</a:t>
+            </a:r>
+          </a:p>
+          <a:p>
+            <a:pPr>
+              <a:spcAft>
+                <a:spcPts val="600"/>
+              </a:spcAft>
+            </a:pPr>
+            <a:r>
+              <a:rPr sz="1500" b="0">
+                <a:solidFill>
+                  <a:srgbClr val="282828"/>
+                </a:solidFill>
+                <a:latin typeface="Arial"/>
+              </a:rPr>
+              <a:t>•  Control using wavefront measurements:   u  =  −(∂w/∂u)⁺·w</a:t>
+            </a:r>
+          </a:p>
+          <a:p>
+            <a:pPr marL="594360" indent="-137160">
+              <a:spcAft>
+                <a:spcPts val="500"/>
+              </a:spcAft>
+            </a:pPr>
+            <a:r>
+              <a:rPr sz="1300" b="0">
+                <a:solidFill>
+                  <a:srgbClr val="6E6E6E"/>
+                </a:solidFill>
+                <a:latin typeface="Arial"/>
+              </a:rPr>
               <a:t>–  Wavefront sensing and control in one step, enveloping telescope initialization controls.</a:t>
             </a:r>
           </a:p>
@@ -9733,7 +9765,7 @@
                 </a:solidFill>
                 <a:latin typeface="Arial"/>
               </a:rPr>
-              <a:t>•  Estimation and control using metrology measurements:   x̂  =  ( HᵀWH + ρI )⁻¹ HᵀW·m ;    u  ←  u − g·x̂</a:t>
+              <a:t>•  Estimation and control using metrology measurements:   x̂  =  ( HᵀWH + ρI )⁻¹ HᵀW·m ;    u  ←  u − g·(∂x/∂u)⁺·x̂</a:t>
             </a:r>
           </a:p>
           <a:p>
@@ -9762,7 +9794,7 @@
         </p:nvSpPr>
         <p:spPr>
           <a:xfrm>
-            <a:off x="411480" y="4684268"/>
+            <a:off x="411480" y="5628894"/>
             <a:ext cx="11368735" cy="274320"/>
           </a:xfrm>
           <a:prstGeom prst="rect">
@@ -10321,7 +10353,7 @@
         </p:nvSpPr>
         <p:spPr>
           <a:xfrm>
-            <a:off x="4535424" y="4169663"/>
+            <a:off x="5148072" y="4517136"/>
             <a:ext cx="2514600" cy="1054608"/>
           </a:xfrm>
           <a:prstGeom prst="rect">
@@ -10335,7 +10367,7 @@
           </a:bodyPr>
           <a:lstStyle/>
           <a:p>
-            <a:pPr algn="ctr">
+            <a:pPr algn="r">
               <a:spcAft>
                 <a:spcPts val="0"/>
               </a:spcAft>
@@ -10443,7 +10475,7 @@
                 </a:solidFill>
                 <a:latin typeface="Arial"/>
               </a:rPr>
-              <a:t>The control basis I: rigid-body channels — dw/dx</a:t>
+              <a:t>The state equations I: rigid-body channels — dw/dx</a:t>
             </a:r>
           </a:p>
           <a:p>
@@ -10701,7 +10733,7 @@
                 </a:solidFill>
                 <a:latin typeface="Arial"/>
               </a:rPr>
-              <a:t>The control basis II: segment-figure channels — dw/dz</a:t>
+              <a:t>The state equations II: segment-figure channels — dw/dz</a:t>
             </a:r>
           </a:p>
           <a:p>
@@ -10991,7 +11023,7 @@
                 </a:solidFill>
                 <a:latin typeface="Arial"/>
               </a:rPr>
-              <a:t>The control basis III: shape-normalized modes — dw/dgrid</a:t>
+              <a:t>The state equations III: shape-normalized modes — dw/dgrid</a:t>
             </a:r>
           </a:p>
           <a:p>
@@ -11169,7 +11201,23 @@
                 </a:solidFill>
                 <a:latin typeface="Arial"/>
               </a:rPr>
-              <a:t>•  These plots illustrate grid-basis influence shapes on 2 of the 19 segments, using the interface for measured influence functions and actuator maps — the same machinery the DM Jacobians use.</a:t>
+              <a:t>•  These plots illustrate grid-basis influence shapes on 2 of the 19 segments, using the interface for measured influence functions and actuator maps.</a:t>
+            </a:r>
+          </a:p>
+          <a:p>
+            <a:pPr>
+              <a:spcAft>
+                <a:spcPts val="600"/>
+              </a:spcAft>
+            </a:pPr>
+            <a:r>
+              <a:rPr sz="1500" b="0">
+                <a:solidFill>
+                  <a:srgbClr val="282828"/>
+                </a:solidFill>
+                <a:latin typeface="Arial"/>
+              </a:rPr>
+              <a:t>•  DM Jacobians use the same form: dw/dDM.</a:t>
             </a:r>
           </a:p>
         </p:txBody>
@@ -11182,7 +11230,7 @@
         </p:nvSpPr>
         <p:spPr>
           <a:xfrm>
-            <a:off x="411480" y="6018784"/>
+            <a:off x="411480" y="6163056"/>
             <a:ext cx="11368735" cy="274320"/>
           </a:xfrm>
           <a:prstGeom prst="rect">
@@ -12433,7 +12481,7 @@
               </a:spcAft>
             </a:pPr>
             <a:r>
-              <a:rPr sz="1500" b="0">
+              <a:rPr sz="2000" b="0">
                 <a:solidFill>
                   <a:srgbClr val="282828"/>
                 </a:solidFill>
@@ -12449,7 +12497,7 @@
               </a:spcAft>
             </a:pPr>
             <a:r>
-              <a:rPr sz="1500" b="0">
+              <a:rPr sz="2000" b="0">
                 <a:solidFill>
                   <a:srgbClr val="282828"/>
                 </a:solidFill>
@@ -12465,7 +12513,7 @@
               </a:spcAft>
             </a:pPr>
             <a:r>
-              <a:rPr sz="1500" b="0">
+              <a:rPr sz="2000" b="0">
                 <a:solidFill>
                   <a:srgbClr val="282828"/>
                 </a:solidFill>
@@ -12481,7 +12529,7 @@
               </a:spcAft>
             </a:pPr>
             <a:r>
-              <a:rPr sz="1500" b="0">
+              <a:rPr sz="2000" b="0">
                 <a:solidFill>
                   <a:srgbClr val="282828"/>
                 </a:solidFill>
@@ -12497,7 +12545,7 @@
               </a:spcAft>
             </a:pPr>
             <a:r>
-              <a:rPr sz="1500" b="0">
+              <a:rPr sz="2000" b="0">
                 <a:solidFill>
                   <a:srgbClr val="282828"/>
                 </a:solidFill>
@@ -12516,7 +12564,7 @@
         </p:nvSpPr>
         <p:spPr>
           <a:xfrm>
-            <a:off x="411480" y="4760214"/>
+            <a:off x="411480" y="6658864"/>
             <a:ext cx="11368735" cy="274320"/>
           </a:xfrm>
           <a:prstGeom prst="rect">
@@ -12692,7 +12740,7 @@
               </a:spcAft>
             </a:pPr>
             <a:r>
-              <a:rPr sz="1500" b="0">
+              <a:rPr sz="1600" b="0">
                 <a:solidFill>
                   <a:srgbClr val="282828"/>
                 </a:solidFill>
@@ -12708,7 +12756,7 @@
               </a:spcAft>
             </a:pPr>
             <a:r>
-              <a:rPr sz="1500" b="0">
+              <a:rPr sz="1600" b="0">
                 <a:solidFill>
                   <a:srgbClr val="282828"/>
                 </a:solidFill>
@@ -12724,7 +12772,7 @@
               </a:spcAft>
             </a:pPr>
             <a:r>
-              <a:rPr sz="1500" b="0">
+              <a:rPr sz="1600" b="0">
                 <a:solidFill>
                   <a:srgbClr val="282828"/>
                 </a:solidFill>
@@ -12740,13 +12788,13 @@
               </a:spcAft>
             </a:pPr>
             <a:r>
-              <a:rPr sz="1500" b="0">
+              <a:rPr sz="1600" b="0">
                 <a:solidFill>
                   <a:srgbClr val="282828"/>
                 </a:solidFill>
                 <a:latin typeface="Arial"/>
               </a:rPr>
-              <a:t>•  Put the agent in the search, never the numerics — starting points and basins (a warm-started walk beat the cold start 8500×); variable-set audits (35% of a metric unclaimed because one freedom was never offered); optimization schedules (a restart ladder opened decades of dark-hole floor overnight); tolerancing and glass searches.  The agent proposes; the trusted engine disposes.</a:t>
+              <a:t>•  Put the agent in the search, never in the numerics — starting points and basins (a warm-started walk beat the cold start 8500×); variable-set audits (35% of a metric unclaimed because one freedom was never offered); optimization schedules (a restart ladder opened decades of dark-hole floor overnight); tolerancing and glass searches.  The agent proposes; the trusted engine disposes.</a:t>
             </a:r>
           </a:p>
           <a:p>
@@ -12756,7 +12804,7 @@
               </a:spcAft>
             </a:pPr>
             <a:r>
-              <a:rPr sz="1500" b="0">
+              <a:rPr sz="1600" b="0">
                 <a:solidFill>
                   <a:srgbClr val="282828"/>
                 </a:solidFill>
@@ -12775,7 +12823,7 @@
         </p:nvSpPr>
         <p:spPr>
           <a:xfrm>
-            <a:off x="411480" y="5750814"/>
+            <a:off x="411480" y="6262624"/>
             <a:ext cx="11368735" cy="274320"/>
           </a:xfrm>
           <a:prstGeom prst="rect">
@@ -16111,8 +16159,8 @@
         </p:nvSpPr>
         <p:spPr>
           <a:xfrm>
-            <a:off x="411480" y="5596128"/>
-            <a:ext cx="11368735" cy="274320"/>
+            <a:off x="914400" y="5596128"/>
+            <a:ext cx="10863072" cy="274320"/>
           </a:xfrm>
           <a:prstGeom prst="rect">
             <a:avLst/>
@@ -16137,7 +16185,7 @@
                 </a:solidFill>
                 <a:latin typeface="Arial"/>
               </a:rPr>
-              <a:t>Counts as of 2026-08.  Every area is exercised by the committed test suites and by the worked examples beside it — the same templates this talk's studies live in.  Rebuild the figure: make_mmacos_fig.py.</a:t>
+              <a:t>Counts as of 2026-08.  Every area is exercised by the committed test suites and by the worked examples beside it — the same templates this talk's studies live in.</a:t>
             </a:r>
           </a:p>
         </p:txBody>

</xml_diff>

<commit_message>
deck: the overnight restart ladder folded -- new slide 28, drift slide re-scoped, closing claim quantified
cf3d DONE 1.215e-6 -> 1.133e-9 (10 digging rounds / 4.6 h; plateau
proven by 3 no-step rounds; la(G) 3.5e-11 remains = the FALCO case).
Dave's directive 'redo the e2e6m_r2 reports and the deck_keysight*
decks' executed; record committed in MACOS_res_dev.  Edit-deck sync
HELD on the Impress lock -- capture Dave's diffs before syncing.

Co-Authored-By: Claude Fable 5 <noreply@anthropic.com>
</commit_message>
<xml_diff>
--- a/demo_session/deck_keysight.pptx
+++ b/demo_session/deck_keysight.pptx
@@ -44,6 +44,7 @@
     <p:sldId id="292" r:id="rId43"/>
     <p:sldId id="293" r:id="rId44"/>
     <p:sldId id="294" r:id="rId45"/>
+    <p:sldId id="295" r:id="rId46"/>
   </p:sldIdLst>
   <p:sldSz cx="12191695" cy="6858000" type="screen4x3"/>
   <p:notesSz cx="6858000" cy="9144000"/>
@@ -11444,7 +11445,7 @@
                 </a:solidFill>
                 <a:latin typeface="Arial"/>
               </a:rPr>
-              <a:t>•  Honest gap, attributed: the segmented-pupil contrast floor sits above the clear-pupil testbed's — the gaps and edges carry it, not the control.</a:t>
+              <a:t>•  Honest gap, attributed: the hold level is the loop mechanization's floor (sensor noise through the gain, damped EFC), not the model's limit — the next slide digs the static dark hole three decades deeper, overnight.</a:t>
             </a:r>
           </a:p>
         </p:txBody>
@@ -11603,7 +11604,7 @@
                 </a:solidFill>
                 <a:latin typeface="Arial"/>
               </a:rPr>
-              <a:t>The live design, revealed</a:t>
+              <a:t>Digging the dark hole: the overnight restart ladder</a:t>
             </a:r>
           </a:p>
           <a:p>
@@ -11619,7 +11620,7 @@
                 </a:solidFill>
                 <a:latin typeface="Arial"/>
               </a:rPr>
-              <a:t>Predicted from the frontier before solving; solved in one warm-started step while we talked</a:t>
+              <a:t>1.2×10⁻⁶ → 1.1×10⁻⁹ — three decades from restart scheduling alone; no new hardware, no new physics</a:t>
             </a:r>
           </a:p>
         </p:txBody>
@@ -11702,7 +11703,7 @@
                 </a:solidFill>
                 <a:latin typeface="Arial"/>
               </a:rPr>
-              <a:t>•  The ask: a field-box width, anywhere in 5–15°.  The prediction, stated before the solve: interpolated from the committed frontier rows.</a:t>
+              <a:t>•  The recipe: EFC to a floor, relinearize about the dug state, restart at that floor — rinse and repeat.  Ten digging rounds, ~4 h unattended, on the d = 1.10 m two-DM variant — the spacing study's best linear substrate; three stall rounds then prove the plateau.</a:t>
             </a:r>
           </a:p>
           <a:p>
@@ -11718,7 +11719,7 @@
                 </a:solidFill>
                 <a:latin typeface="Arial"/>
               </a:rPr>
-              <a:t>•  The pre-run rehearsal of the default ask (12°): predicted 33.7 nm; solved 33.6 nm — 1.00× — at a 24.9 mm clearance floor, both checks pass, in 15 minutes.</a:t>
+              <a:t>•  The controller was the bottleneck, measured: a single linearization stalls at 9.0×10⁻⁷; every restart bought another step down.  DM strokes end at 33 nm rms, well inside the 50 nm budget.</a:t>
             </a:r>
           </a:p>
           <a:p>
@@ -11734,14 +11735,14 @@
                 </a:solidFill>
                 <a:latin typeface="Arial"/>
               </a:rPr>
-              <a:t>•  The run is deterministic to every printed digit, and every ask is a genuine continuation step — never a re-score of a stored design.</a:t>
+              <a:t>•  The remaining 1.5 decades are priced: re-measured at every dug state, the linear-achievable floor holds at 2–4×10⁻¹¹ — HWO-class 5×10⁻¹¹ is within this substrate's reach.  The plateau at 1.1×10⁻⁹ is the monotone Tikhonov step rule: the measured case for FALCO-grade step control on this same model.</a:t>
             </a:r>
           </a:p>
         </p:txBody>
       </p:sp>
       <p:pic>
         <p:nvPicPr>
-          <p:cNvPr id="5" name="Picture 4" descr="oi_demo_12deg_layout.png"/>
+          <p:cNvPr id="5" name="Picture 4" descr="fig_cf3d_ladder.png"/>
           <p:cNvPicPr>
             <a:picLocks noChangeAspect="1"/>
           </p:cNvPicPr>
@@ -11755,8 +11756,8 @@
         </p:blipFill>
         <p:spPr>
           <a:xfrm>
-            <a:off x="8000103" y="1298448"/>
-            <a:ext cx="2196352" cy="1891792"/>
+            <a:off x="6400800" y="1298448"/>
+            <a:ext cx="5394960" cy="3637305"/>
           </a:xfrm>
           <a:prstGeom prst="rect">
             <a:avLst/>
@@ -11771,7 +11772,7 @@
         </p:nvSpPr>
         <p:spPr>
           <a:xfrm>
-            <a:off x="6400800" y="3208528"/>
+            <a:off x="6400800" y="4954041"/>
             <a:ext cx="5394960" cy="394208"/>
           </a:xfrm>
           <a:prstGeom prst="rect">
@@ -11797,44 +11798,20 @@
                 </a:solidFill>
                 <a:latin typeface="Arial"/>
               </a:rPr>
-              <a:t>The 12° rehearsal design and its field map: 33.6 nm max against a 33.7 nm prediction.</a:t>
-            </a:r>
-          </a:p>
-        </p:txBody>
-      </p:sp>
-      <p:pic>
-        <p:nvPicPr>
-          <p:cNvPr id="7" name="Picture 6" descr="oi_demo_12deg_map.png"/>
-          <p:cNvPicPr>
-            <a:picLocks noChangeAspect="1"/>
-          </p:cNvPicPr>
-          <p:nvPr/>
-        </p:nvPicPr>
-        <p:blipFill>
-          <a:blip r:embed="rId3"/>
-          <a:stretch>
-            <a:fillRect/>
-          </a:stretch>
-        </p:blipFill>
-        <p:spPr>
-          <a:xfrm>
-            <a:off x="7951092" y="3639312"/>
-            <a:ext cx="2294375" cy="2011680"/>
-          </a:xfrm>
-          <a:prstGeom prst="rect">
-            <a:avLst/>
-          </a:prstGeom>
-        </p:spPr>
-      </p:pic>
-      <p:sp>
-        <p:nvSpPr>
-          <p:cNvPr id="8" name="TextBox 7"/>
+              <a:t>The ladder: measured dark-zone floor by restart round, with the linear-achievable substrate re-measured at every dug state.</a:t>
+            </a:r>
+          </a:p>
+        </p:txBody>
+      </p:sp>
+      <p:sp>
+        <p:nvSpPr>
+          <p:cNvPr id="7" name="TextBox 6"/>
           <p:cNvSpPr txBox="1"/>
           <p:nvPr/>
         </p:nvSpPr>
         <p:spPr>
           <a:xfrm>
-            <a:off x="6400800" y="5650992"/>
+            <a:off x="6400800" y="5384825"/>
             <a:ext cx="5394960" cy="274320"/>
           </a:xfrm>
           <a:prstGeom prst="rect">
@@ -11860,7 +11837,7 @@
                 </a:solidFill>
                 <a:latin typeface="Arial"/>
               </a:rPr>
-              <a:t>On demo day the live run's figures replace these panels; this pre-generated bundle is the fallback if the room's ask matches nothing better.</a:t>
+              <a:t>Record: templates/80_end_to_end/e2e6m_r2, CF3d stage — checkpointed and resumable; every round is a finished floor.</a:t>
             </a:r>
           </a:p>
         </p:txBody>
@@ -11917,7 +11894,7 @@
                 </a:solidFill>
                 <a:latin typeface="Arial"/>
               </a:rPr>
-              <a:t>AI in design and analysis — the working questions</a:t>
+              <a:t>The live design, revealed</a:t>
             </a:r>
           </a:p>
           <a:p>
@@ -11933,7 +11910,7 @@
                 </a:solidFill>
                 <a:latin typeface="Arial"/>
               </a:rPr>
-              <a:t>What we ask of an AI-driven study before believing it</a:t>
+              <a:t>Predicted from the frontier before solving; solved in one warm-started step while we talked</a:t>
             </a:r>
           </a:p>
         </p:txBody>
@@ -11991,7 +11968,7 @@
         <p:spPr>
           <a:xfrm>
             <a:off x="411480" y="1298448"/>
-            <a:ext cx="11368735" cy="274320"/>
+            <a:ext cx="5806440" cy="274320"/>
           </a:xfrm>
           <a:prstGeom prst="rect">
             <a:avLst/>
@@ -12010,13 +11987,13 @@
               </a:spcAft>
             </a:pPr>
             <a:r>
-              <a:rPr sz="1500" b="0">
+              <a:rPr sz="1200" b="0">
                 <a:solidFill>
                   <a:srgbClr val="282828"/>
                 </a:solidFill>
                 <a:latin typeface="Arial"/>
               </a:rPr>
-              <a:t>•  How is a machine's result verified?  Regression checks with negative controls; layout renders read against every claim — the checks caught the errors shown today.</a:t>
+              <a:t>•  The ask: a field-box width, anywhere in 5–15°.  The prediction, stated before the solve: interpolated from the committed frontier rows.</a:t>
             </a:r>
           </a:p>
           <a:p>
@@ -12026,13 +12003,13 @@
               </a:spcAft>
             </a:pPr>
             <a:r>
-              <a:rPr sz="1500" b="0">
+              <a:rPr sz="1200" b="0">
                 <a:solidFill>
                   <a:srgbClr val="282828"/>
                 </a:solidFill>
                 <a:latin typeface="Arial"/>
               </a:rPr>
-              <a:t>•  Where does the human rule?  Constraints, metrics, and every outward claim — the AI proposes, the record decides.</a:t>
+              <a:t>•  The pre-run rehearsal of the default ask (12°): predicted 33.7 nm; solved 33.6 nm — 1.00× — at a 24.9 mm clearance floor, both checks pass, in 15 minutes.</a:t>
             </a:r>
           </a:p>
           <a:p>
@@ -12042,27 +12019,51 @@
               </a:spcAft>
             </a:pPr>
             <a:r>
-              <a:rPr sz="1500" b="0">
+              <a:rPr sz="1200" b="0">
                 <a:solidFill>
                   <a:srgbClr val="282828"/>
                 </a:solidFill>
                 <a:latin typeface="Arial"/>
               </a:rPr>
-              <a:t>•  Is it reproducible?  Every number in this deck rebuilds from committed scripts and committed records — including the design solved during this talk.</a:t>
-            </a:r>
-          </a:p>
-        </p:txBody>
-      </p:sp>
-      <p:sp>
-        <p:nvSpPr>
-          <p:cNvPr id="5" name="TextBox 4"/>
+              <a:t>•  The run is deterministic to every printed digit, and every ask is a genuine continuation step — never a re-score of a stored design.</a:t>
+            </a:r>
+          </a:p>
+        </p:txBody>
+      </p:sp>
+      <p:pic>
+        <p:nvPicPr>
+          <p:cNvPr id="5" name="Picture 4" descr="oi_demo_12deg_layout.png"/>
+          <p:cNvPicPr>
+            <a:picLocks noChangeAspect="1"/>
+          </p:cNvPicPr>
+          <p:nvPr/>
+        </p:nvPicPr>
+        <p:blipFill>
+          <a:blip r:embed="rId2"/>
+          <a:stretch>
+            <a:fillRect/>
+          </a:stretch>
+        </p:blipFill>
+        <p:spPr>
+          <a:xfrm>
+            <a:off x="8000103" y="1298448"/>
+            <a:ext cx="2196352" cy="1891792"/>
+          </a:xfrm>
+          <a:prstGeom prst="rect">
+            <a:avLst/>
+          </a:prstGeom>
+        </p:spPr>
+      </p:pic>
+      <p:sp>
+        <p:nvSpPr>
+          <p:cNvPr id="6" name="TextBox 5"/>
           <p:cNvSpPr txBox="1"/>
           <p:nvPr/>
         </p:nvSpPr>
         <p:spPr>
           <a:xfrm>
-            <a:off x="411480" y="2993898"/>
-            <a:ext cx="11368735" cy="274320"/>
+            <a:off x="6400800" y="3208528"/>
+            <a:ext cx="5394960" cy="394208"/>
           </a:xfrm>
           <a:prstGeom prst="rect">
             <a:avLst/>
@@ -12075,6 +12076,69 @@
           </a:bodyPr>
           <a:lstStyle/>
           <a:p>
+            <a:pPr algn="ctr">
+              <a:spcAft>
+                <a:spcPts val="0"/>
+              </a:spcAft>
+            </a:pPr>
+            <a:r>
+              <a:rPr sz="1000" b="0">
+                <a:solidFill>
+                  <a:srgbClr val="6E6E6E"/>
+                </a:solidFill>
+                <a:latin typeface="Arial"/>
+              </a:rPr>
+              <a:t>The 12° rehearsal design and its field map: 33.6 nm max against a 33.7 nm prediction.</a:t>
+            </a:r>
+          </a:p>
+        </p:txBody>
+      </p:sp>
+      <p:pic>
+        <p:nvPicPr>
+          <p:cNvPr id="7" name="Picture 6" descr="oi_demo_12deg_map.png"/>
+          <p:cNvPicPr>
+            <a:picLocks noChangeAspect="1"/>
+          </p:cNvPicPr>
+          <p:nvPr/>
+        </p:nvPicPr>
+        <p:blipFill>
+          <a:blip r:embed="rId3"/>
+          <a:stretch>
+            <a:fillRect/>
+          </a:stretch>
+        </p:blipFill>
+        <p:spPr>
+          <a:xfrm>
+            <a:off x="7951092" y="3639312"/>
+            <a:ext cx="2294375" cy="2011680"/>
+          </a:xfrm>
+          <a:prstGeom prst="rect">
+            <a:avLst/>
+          </a:prstGeom>
+        </p:spPr>
+      </p:pic>
+      <p:sp>
+        <p:nvSpPr>
+          <p:cNvPr id="8" name="TextBox 7"/>
+          <p:cNvSpPr txBox="1"/>
+          <p:nvPr/>
+        </p:nvSpPr>
+        <p:spPr>
+          <a:xfrm>
+            <a:off x="6400800" y="5650992"/>
+            <a:ext cx="5394960" cy="274320"/>
+          </a:xfrm>
+          <a:prstGeom prst="rect">
+            <a:avLst/>
+          </a:prstGeom>
+          <a:noFill/>
+        </p:spPr>
+        <p:txBody>
+          <a:bodyPr wrap="square">
+            <a:spAutoFit/>
+          </a:bodyPr>
+          <a:lstStyle/>
+          <a:p>
             <a:pPr>
               <a:spcAft>
                 <a:spcPts val="600"/>
@@ -12087,7 +12151,7 @@
                 </a:solidFill>
                 <a:latin typeface="Arial"/>
               </a:rPr>
-              <a:t>Offered as discussion questions, not settled doctrine — the next slide takes one of them to architecture.</a:t>
+              <a:t>On demo day the live run's figures replace these panels; this pre-generated bundle is the fallback if the room's ask matches nothing better.</a:t>
             </a:r>
           </a:p>
         </p:txBody>
@@ -12388,7 +12452,7 @@
                 </a:solidFill>
                 <a:latin typeface="Arial"/>
               </a:rPr>
-              <a:t>Discussion: where should the agent sit?</a:t>
+              <a:t>AI in design and analysis — the working questions</a:t>
             </a:r>
           </a:p>
           <a:p>
@@ -12404,7 +12468,7 @@
                 </a:solidFill>
                 <a:latin typeface="Arial"/>
               </a:rPr>
-              <a:t>Three modes — two exercised by these studies, one open — and the boundary between them is the question</a:t>
+              <a:t>What we ask of an AI-driven study before believing it</a:t>
             </a:r>
           </a:p>
         </p:txBody>
@@ -12481,13 +12545,13 @@
               </a:spcAft>
             </a:pPr>
             <a:r>
-              <a:rPr sz="2000" b="0">
+              <a:rPr sz="1500" b="0">
                 <a:solidFill>
                   <a:srgbClr val="282828"/>
                 </a:solidFill>
                 <a:latin typeface="Arial"/>
               </a:rPr>
-              <a:t>•  A · The compiled tool, no agent — what ships: versioned, regression-tested, inspectable, and it runs unattended.  But measured on a cold user, the docs alone did not carry them.</a:t>
+              <a:t>•  How is a machine's result verified?  Regression checks with negative controls; layout renders read against every claim — the checks caught the errors shown today.</a:t>
             </a:r>
           </a:p>
           <a:p>
@@ -12497,13 +12561,13 @@
               </a:spcAft>
             </a:pPr>
             <a:r>
-              <a:rPr sz="2000" b="0">
+              <a:rPr sz="1500" b="0">
                 <a:solidFill>
                   <a:srgbClr val="282828"/>
                 </a:solidFill>
                 <a:latin typeface="Arial"/>
               </a:rPr>
-              <a:t>•  B · An agent alongside the tool — what these studies did: it found and fixed the conceptual defects in hours and chose what was worth compiling.  Its knowledge is current — but not versioned with the tool.</a:t>
+              <a:t>•  Where does the human rule?  Constraints, metrics, and every outward claim — the AI proposes, the record decides.</a:t>
             </a:r>
           </a:p>
           <a:p>
@@ -12513,45 +12577,13 @@
               </a:spcAft>
             </a:pPr>
             <a:r>
-              <a:rPr sz="2000" b="0">
+              <a:rPr sz="1500" b="0">
                 <a:solidFill>
                   <a:srgbClr val="282828"/>
                 </a:solidFill>
                 <a:latin typeface="Arial"/>
               </a:rPr>
-              <a:t>•  C · A helper embedded in the tool — the open question: advice at the moment of use, catching the failure class that was documented and still fatal.</a:t>
-            </a:r>
-          </a:p>
-          <a:p>
-            <a:pPr>
-              <a:spcAft>
-                <a:spcPts val="600"/>
-              </a:spcAft>
-            </a:pPr>
-            <a:r>
-              <a:rPr sz="2000" b="0">
-                <a:solidFill>
-                  <a:srgbClr val="282828"/>
-                </a:solidFill>
-                <a:latin typeface="Arial"/>
-              </a:rPr>
-              <a:t>•  Shapes for C, in increasing authority:  agent-readable state (the user's own assistant drives the tool); a failure-triage assistant (fires on a failed check, returns a diagnosis and a next command); a policy assistant inside hard limits (chooses schedules and targets; the code enforces limits and logs every choice).</a:t>
-            </a:r>
-          </a:p>
-          <a:p>
-            <a:pPr>
-              <a:spcAft>
-                <a:spcPts val="600"/>
-              </a:spcAft>
-            </a:pPr>
-            <a:r>
-              <a:rPr sz="2000" b="0">
-                <a:solidFill>
-                  <a:srgbClr val="282828"/>
-                </a:solidFill>
-                <a:latin typeface="Arial"/>
-              </a:rPr>
-              <a:t>•  At any level, tier the agents: an orchestrator plans and delegates bounded tasks; the committed records — not any agent's memory — are the shared memory.</a:t>
+              <a:t>•  Is it reproducible?  Every number in this deck rebuilds from committed scripts and committed records — including the design solved during this talk.</a:t>
             </a:r>
           </a:p>
         </p:txBody>
@@ -12564,7 +12596,7 @@
         </p:nvSpPr>
         <p:spPr>
           <a:xfrm>
-            <a:off x="411480" y="6658864"/>
+            <a:off x="411480" y="2993898"/>
             <a:ext cx="11368735" cy="274320"/>
           </a:xfrm>
           <a:prstGeom prst="rect">
@@ -12590,7 +12622,7 @@
                 </a:solidFill>
                 <a:latin typeface="Arial"/>
               </a:rPr>
-              <a:t>A stale check fails loudly; stale advice fails silently.  Measured: the tool alone did not carry a new user; an agent alongside it closed every gap — and most of what it learned is now in the tool, as checks and defaults.</a:t>
+              <a:t>Offered as discussion questions, not settled doctrine — the next slide takes one of them to architecture.</a:t>
             </a:r>
           </a:p>
         </p:txBody>
@@ -12647,7 +12679,7 @@
                 </a:solidFill>
                 <a:latin typeface="Arial"/>
               </a:rPr>
-              <a:t>If you asked us: AI around CODE V and LightTools</a:t>
+              <a:t>Discussion: where should the agent sit?</a:t>
             </a:r>
           </a:p>
           <a:p>
@@ -12663,7 +12695,7 @@
                 </a:solidFill>
                 <a:latin typeface="Arial"/>
               </a:rPr>
-              <a:t>Add it around the optics, not in them — every claim below is measured, not speculative</a:t>
+              <a:t>Three modes — two exercised by these studies, one open — and the boundary between them is the question</a:t>
             </a:r>
           </a:p>
         </p:txBody>
@@ -12740,13 +12772,13 @@
               </a:spcAft>
             </a:pPr>
             <a:r>
-              <a:rPr sz="1600" b="0">
+              <a:rPr sz="2000" b="0">
                 <a:solidFill>
                   <a:srgbClr val="282828"/>
                 </a:solidFill>
                 <a:latin typeface="Arial"/>
               </a:rPr>
-              <a:t>•  Make the tools agent-readable first — state, results, warnings and docs as structured data through the existing macro/API surface.  Every user's assistant then attaches today, and the vendor ships no intelligence at all.  This whole talk ran in that mode.</a:t>
+              <a:t>•  A · The compiled tool, no agent — what ships: versioned, regression-tested, inspectable, and it runs unattended.  But measured on a cold user, the docs alone did not carry them.</a:t>
             </a:r>
           </a:p>
           <a:p>
@@ -12756,13 +12788,13 @@
               </a:spcAft>
             </a:pPr>
             <a:r>
-              <a:rPr sz="1600" b="0">
+              <a:rPr sz="2000" b="0">
                 <a:solidFill>
                   <a:srgbClr val="282828"/>
                 </a:solidFill>
                 <a:latin typeface="Arial"/>
               </a:rPr>
-              <a:t>•  Ship the conventions as data.  The largest defect class our agent found was conventions — the sign of a radius, DAR versus a coordinate break, which reference sphere a number is quoted against.  Make them queryable and the dominant error source disappears for humans and agents alike.</a:t>
+              <a:t>•  B · An agent alongside the tool — what these studies did: it found and fixed the conceptual defects in hours and chose what was worth compiling.  Its knowledge is current — but not versioned with the tool.</a:t>
             </a:r>
           </a:p>
           <a:p>
@@ -12772,13 +12804,13 @@
               </a:spcAft>
             </a:pPr>
             <a:r>
-              <a:rPr sz="1600" b="0">
+              <a:rPr sz="2000" b="0">
                 <a:solidFill>
                   <a:srgbClr val="282828"/>
                 </a:solidFill>
                 <a:latin typeface="Arial"/>
               </a:rPr>
-              <a:t>•  Embed a failure-triage assistant first — it wakes on a failed trace or a stalled solve, reads the saved state, and returns one line of diagnosis plus a next command the person runs.  Our stalled solve was a finite-difference step reading the gradient 17% low: a one-line answer sitting in state the tool already had.</a:t>
+              <a:t>•  C · A helper embedded in the tool — the open question: advice at the moment of use, catching the failure class that was documented and still fatal.</a:t>
             </a:r>
           </a:p>
           <a:p>
@@ -12788,13 +12820,13 @@
               </a:spcAft>
             </a:pPr>
             <a:r>
-              <a:rPr sz="1600" b="0">
+              <a:rPr sz="2000" b="0">
                 <a:solidFill>
                   <a:srgbClr val="282828"/>
                 </a:solidFill>
                 <a:latin typeface="Arial"/>
               </a:rPr>
-              <a:t>•  Put the agent in the search, never in the numerics — starting points and basins (a warm-started walk beat the cold start 8500×); variable-set audits (35% of a metric unclaimed because one freedom was never offered); optimization schedules (a restart ladder opened decades of dark-hole floor overnight); tolerancing and glass searches.  The agent proposes; the trusted engine disposes.</a:t>
+              <a:t>•  Shapes for C, in increasing authority:  agent-readable state (the user's own assistant drives the tool); a failure-triage assistant (fires on a failed check, returns a diagnosis and a next command); a policy assistant inside hard limits (chooses schedules and targets; the code enforces limits and logs every choice).</a:t>
             </a:r>
           </a:p>
           <a:p>
@@ -12804,13 +12836,13 @@
               </a:spcAft>
             </a:pPr>
             <a:r>
-              <a:rPr sz="1600" b="0">
+              <a:rPr sz="2000" b="0">
                 <a:solidFill>
                   <a:srgbClr val="282828"/>
                 </a:solidFill>
                 <a:latin typeface="Arial"/>
               </a:rPr>
-              <a:t>•  Ship the trust machinery with it: every AI action a readable, replayable script — never an opaque state mutation; every proposal a before/after check with negative controls; the assistant's knowledge versioned with the release.</a:t>
+              <a:t>•  At any level, tier the agents: an orchestrator plans and delegates bounded tasks; the committed records — not any agent's memory — are the shared memory.</a:t>
             </a:r>
           </a:p>
         </p:txBody>
@@ -12823,7 +12855,7 @@
         </p:nvSpPr>
         <p:spPr>
           <a:xfrm>
-            <a:off x="411480" y="6262624"/>
+            <a:off x="411480" y="6658864"/>
             <a:ext cx="11368735" cy="274320"/>
           </a:xfrm>
           <a:prstGeom prst="rect">
@@ -12849,7 +12881,7 @@
                 </a:solidFill>
                 <a:latin typeface="Arial"/>
               </a:rPr>
-              <a:t>A stale check fails loudly; stale advice fails silently — and the best advice ends up compiled into the tool, as checks and defaults.</a:t>
+              <a:t>A stale check fails loudly; stale advice fails silently.  Measured: the tool alone did not carry a new user; an agent alongside it closed every gap — and most of what it learned is now in the tool, as checks and defaults.</a:t>
             </a:r>
           </a:p>
         </p:txBody>
@@ -12906,7 +12938,23 @@
                 </a:solidFill>
                 <a:latin typeface="Arial"/>
               </a:rPr>
-              <a:t>Backup Slides</a:t>
+              <a:t>If you asked us: AI around CODE V and LightTools</a:t>
+            </a:r>
+          </a:p>
+          <a:p>
+            <a:pPr>
+              <a:spcAft>
+                <a:spcPts val="0"/>
+              </a:spcAft>
+            </a:pPr>
+            <a:r>
+              <a:rPr sz="1250" b="0">
+                <a:solidFill>
+                  <a:srgbClr val="6E6E6E"/>
+                </a:solidFill>
+                <a:latin typeface="Arial"/>
+              </a:rPr>
+              <a:t>Add it around the optics, not in them — every claim below is measured, not speculative</a:t>
             </a:r>
           </a:p>
         </p:txBody>
@@ -12919,7 +12967,7 @@
         </p:nvSpPr>
         <p:spPr>
           <a:xfrm>
-            <a:off x="411480" y="914400"/>
+            <a:off x="411480" y="1133856"/>
             <a:ext cx="11368735" cy="20320"/>
           </a:xfrm>
           <a:prstGeom prst="rect">
@@ -12955,6 +13003,148 @@
           </a:p>
         </p:txBody>
       </p:sp>
+      <p:sp>
+        <p:nvSpPr>
+          <p:cNvPr id="4" name="TextBox 3"/>
+          <p:cNvSpPr txBox="1"/>
+          <p:nvPr/>
+        </p:nvSpPr>
+        <p:spPr>
+          <a:xfrm>
+            <a:off x="411480" y="1298448"/>
+            <a:ext cx="11368735" cy="274320"/>
+          </a:xfrm>
+          <a:prstGeom prst="rect">
+            <a:avLst/>
+          </a:prstGeom>
+          <a:noFill/>
+        </p:spPr>
+        <p:txBody>
+          <a:bodyPr wrap="square">
+            <a:spAutoFit/>
+          </a:bodyPr>
+          <a:lstStyle/>
+          <a:p>
+            <a:pPr>
+              <a:spcAft>
+                <a:spcPts val="600"/>
+              </a:spcAft>
+            </a:pPr>
+            <a:r>
+              <a:rPr sz="1600" b="0">
+                <a:solidFill>
+                  <a:srgbClr val="282828"/>
+                </a:solidFill>
+                <a:latin typeface="Arial"/>
+              </a:rPr>
+              <a:t>•  Make the tools agent-readable first — state, results, warnings and docs as structured data through the existing macro/API surface.  Every user's assistant then attaches today, and the vendor ships no intelligence at all.  This whole talk ran in that mode.</a:t>
+            </a:r>
+          </a:p>
+          <a:p>
+            <a:pPr>
+              <a:spcAft>
+                <a:spcPts val="600"/>
+              </a:spcAft>
+            </a:pPr>
+            <a:r>
+              <a:rPr sz="1600" b="0">
+                <a:solidFill>
+                  <a:srgbClr val="282828"/>
+                </a:solidFill>
+                <a:latin typeface="Arial"/>
+              </a:rPr>
+              <a:t>•  Ship the conventions as data.  The largest defect class our agent found was conventions — the sign of a radius, DAR versus a coordinate break, which reference sphere a number is quoted against.  Make them queryable and the dominant error source disappears for humans and agents alike.</a:t>
+            </a:r>
+          </a:p>
+          <a:p>
+            <a:pPr>
+              <a:spcAft>
+                <a:spcPts val="600"/>
+              </a:spcAft>
+            </a:pPr>
+            <a:r>
+              <a:rPr sz="1600" b="0">
+                <a:solidFill>
+                  <a:srgbClr val="282828"/>
+                </a:solidFill>
+                <a:latin typeface="Arial"/>
+              </a:rPr>
+              <a:t>•  Embed a failure-triage assistant first — it wakes on a failed trace or a stalled solve, reads the saved state, and returns one line of diagnosis plus a next command the person runs.  Our stalled solve was a finite-difference step reading the gradient 17% low: a one-line answer sitting in state the tool already had.</a:t>
+            </a:r>
+          </a:p>
+          <a:p>
+            <a:pPr>
+              <a:spcAft>
+                <a:spcPts val="600"/>
+              </a:spcAft>
+            </a:pPr>
+            <a:r>
+              <a:rPr sz="1600" b="0">
+                <a:solidFill>
+                  <a:srgbClr val="282828"/>
+                </a:solidFill>
+                <a:latin typeface="Arial"/>
+              </a:rPr>
+              <a:t>•  Put the agent in the search, never in the numerics — starting points and basins (a warm-started walk beat the cold start 8500×); variable-set audits (35% of a metric unclaimed because one freedom was never offered); optimization schedules (a restart ladder dug the dark hole 1.2×10⁻⁶ → 1.1×10⁻⁹ overnight); tolerancing and glass searches.  The agent proposes; the trusted engine disposes.</a:t>
+            </a:r>
+          </a:p>
+          <a:p>
+            <a:pPr>
+              <a:spcAft>
+                <a:spcPts val="600"/>
+              </a:spcAft>
+            </a:pPr>
+            <a:r>
+              <a:rPr sz="1600" b="0">
+                <a:solidFill>
+                  <a:srgbClr val="282828"/>
+                </a:solidFill>
+                <a:latin typeface="Arial"/>
+              </a:rPr>
+              <a:t>•  Ship the trust machinery with it: every AI action a readable, replayable script — never an opaque state mutation; every proposal a before/after check with negative controls; the assistant's knowledge versioned with the release.</a:t>
+            </a:r>
+          </a:p>
+        </p:txBody>
+      </p:sp>
+      <p:sp>
+        <p:nvSpPr>
+          <p:cNvPr id="5" name="TextBox 4"/>
+          <p:cNvSpPr txBox="1"/>
+          <p:nvPr/>
+        </p:nvSpPr>
+        <p:spPr>
+          <a:xfrm>
+            <a:off x="411480" y="6262624"/>
+            <a:ext cx="11368735" cy="274320"/>
+          </a:xfrm>
+          <a:prstGeom prst="rect">
+            <a:avLst/>
+          </a:prstGeom>
+          <a:noFill/>
+        </p:spPr>
+        <p:txBody>
+          <a:bodyPr wrap="square">
+            <a:spAutoFit/>
+          </a:bodyPr>
+          <a:lstStyle/>
+          <a:p>
+            <a:pPr>
+              <a:spcAft>
+                <a:spcPts val="600"/>
+              </a:spcAft>
+            </a:pPr>
+            <a:r>
+              <a:rPr sz="1050" b="0">
+                <a:solidFill>
+                  <a:srgbClr val="6E6E6E"/>
+                </a:solidFill>
+                <a:latin typeface="Arial"/>
+              </a:rPr>
+              <a:t>A stale check fails loudly; stale advice fails silently — and the best advice ends up compiled into the tool, as checks and defaults.</a:t>
+            </a:r>
+          </a:p>
+        </p:txBody>
+      </p:sp>
     </p:spTree>
   </p:cSld>
   <p:clrMapOvr>
@@ -12964,6 +13154,107 @@
 </file>
 
 <file path=ppt/slides/slide33.xml><?xml version="1.0" encoding="utf-8"?>
+<p:sld xmlns:a="http://schemas.openxmlformats.org/drawingml/2006/main" xmlns:p="http://schemas.openxmlformats.org/presentationml/2006/main" xmlns:r="http://schemas.openxmlformats.org/officeDocument/2006/relationships">
+  <p:cSld>
+    <p:spTree>
+      <p:nvGrpSpPr>
+        <p:cNvPr id="1" name=""/>
+        <p:cNvGrpSpPr/>
+        <p:nvPr/>
+      </p:nvGrpSpPr>
+      <p:grpSpPr/>
+      <p:sp>
+        <p:nvSpPr>
+          <p:cNvPr id="2" name="TextBox 1"/>
+          <p:cNvSpPr txBox="1"/>
+          <p:nvPr/>
+        </p:nvSpPr>
+        <p:spPr>
+          <a:xfrm>
+            <a:off x="411480" y="201168"/>
+            <a:ext cx="11368735" cy="914400"/>
+          </a:xfrm>
+          <a:prstGeom prst="rect">
+            <a:avLst/>
+          </a:prstGeom>
+          <a:noFill/>
+        </p:spPr>
+        <p:txBody>
+          <a:bodyPr wrap="square">
+            <a:spAutoFit/>
+          </a:bodyPr>
+          <a:lstStyle/>
+          <a:p>
+            <a:pPr>
+              <a:spcAft>
+                <a:spcPts val="400"/>
+              </a:spcAft>
+            </a:pPr>
+            <a:r>
+              <a:rPr sz="2400" b="1">
+                <a:solidFill>
+                  <a:srgbClr val="1F4E79"/>
+                </a:solidFill>
+                <a:latin typeface="Arial"/>
+              </a:rPr>
+              <a:t>Backup Slides</a:t>
+            </a:r>
+          </a:p>
+        </p:txBody>
+      </p:sp>
+      <p:sp>
+        <p:nvSpPr>
+          <p:cNvPr id="3" name="Rectangle 2"/>
+          <p:cNvSpPr/>
+          <p:nvPr/>
+        </p:nvSpPr>
+        <p:spPr>
+          <a:xfrm>
+            <a:off x="411480" y="914400"/>
+            <a:ext cx="11368735" cy="20320"/>
+          </a:xfrm>
+          <a:prstGeom prst="rect">
+            <a:avLst/>
+          </a:prstGeom>
+          <a:solidFill>
+            <a:srgbClr val="B8C6D4"/>
+          </a:solidFill>
+          <a:ln>
+            <a:noFill/>
+          </a:ln>
+          <a:effectLst/>
+        </p:spPr>
+        <p:style>
+          <a:lnRef idx="1">
+            <a:schemeClr val="accent1"/>
+          </a:lnRef>
+          <a:fillRef idx="3">
+            <a:schemeClr val="accent1"/>
+          </a:fillRef>
+          <a:effectRef idx="2">
+            <a:schemeClr val="accent1"/>
+          </a:effectRef>
+          <a:fontRef idx="minor">
+            <a:schemeClr val="lt1"/>
+          </a:fontRef>
+        </p:style>
+        <p:txBody>
+          <a:bodyPr rtlCol="0" anchor="ctr"/>
+          <a:lstStyle/>
+          <a:p>
+            <a:pPr algn="ctr"/>
+          </a:p>
+        </p:txBody>
+      </p:sp>
+    </p:spTree>
+  </p:cSld>
+  <p:clrMapOvr>
+    <a:masterClrMapping/>
+  </p:clrMapOvr>
+</p:sld>
+</file>
+
+<file path=ppt/slides/slide34.xml><?xml version="1.0" encoding="utf-8"?>
 <p:sld xmlns:a="http://schemas.openxmlformats.org/drawingml/2006/main" xmlns:p="http://schemas.openxmlformats.org/presentationml/2006/main" xmlns:r="http://schemas.openxmlformats.org/officeDocument/2006/relationships">
   <p:cSld>
     <p:spTree>
@@ -13593,7 +13884,7 @@
 </p:sld>
 </file>
 
-<file path=ppt/slides/slide34.xml><?xml version="1.0" encoding="utf-8"?>
+<file path=ppt/slides/slide35.xml><?xml version="1.0" encoding="utf-8"?>
 <p:sld xmlns:a="http://schemas.openxmlformats.org/drawingml/2006/main" xmlns:p="http://schemas.openxmlformats.org/presentationml/2006/main" xmlns:r="http://schemas.openxmlformats.org/officeDocument/2006/relationships">
   <p:cSld>
     <p:spTree>
@@ -14459,7 +14750,7 @@
 </p:sld>
 </file>
 
-<file path=ppt/slides/slide35.xml><?xml version="1.0" encoding="utf-8"?>
+<file path=ppt/slides/slide36.xml><?xml version="1.0" encoding="utf-8"?>
 <p:sld xmlns:a="http://schemas.openxmlformats.org/drawingml/2006/main" xmlns:p="http://schemas.openxmlformats.org/presentationml/2006/main" xmlns:r="http://schemas.openxmlformats.org/officeDocument/2006/relationships">
   <p:cSld>
     <p:spTree>
@@ -14666,351 +14957,6 @@
                 <a:latin typeface="Arial"/>
               </a:rPr>
               <a:t>Committed: deepest optic 1.887 m = 1.81× the spacing, the feed beam through the collimator by −79.9 mm.  Four-flat recipe: 0.893 m deep, but a fold is an isometry — the interference rides across — and it does not close on the cleared deck (96 routes, every admissible one loses rays).  Cleared −10°: 1.287 m = 1.24×, zero flats, +37.8 mm of daylight.  Record: challenges/afocal4/{packaging,clearing}.</a:t>
-            </a:r>
-          </a:p>
-        </p:txBody>
-      </p:sp>
-    </p:spTree>
-  </p:cSld>
-  <p:clrMapOvr>
-    <a:masterClrMapping/>
-  </p:clrMapOvr>
-</p:sld>
-</file>
-
-<file path=ppt/slides/slide36.xml><?xml version="1.0" encoding="utf-8"?>
-<p:sld xmlns:a="http://schemas.openxmlformats.org/drawingml/2006/main" xmlns:p="http://schemas.openxmlformats.org/presentationml/2006/main" xmlns:r="http://schemas.openxmlformats.org/officeDocument/2006/relationships">
-  <p:cSld>
-    <p:spTree>
-      <p:nvGrpSpPr>
-        <p:cNvPr id="1" name=""/>
-        <p:cNvGrpSpPr/>
-        <p:nvPr/>
-      </p:nvGrpSpPr>
-      <p:grpSpPr/>
-      <p:sp>
-        <p:nvSpPr>
-          <p:cNvPr id="2" name="TextBox 1"/>
-          <p:cNvSpPr txBox="1"/>
-          <p:nvPr/>
-        </p:nvSpPr>
-        <p:spPr>
-          <a:xfrm>
-            <a:off x="411480" y="201168"/>
-            <a:ext cx="11368735" cy="914400"/>
-          </a:xfrm>
-          <a:prstGeom prst="rect">
-            <a:avLst/>
-          </a:prstGeom>
-          <a:noFill/>
-        </p:spPr>
-        <p:txBody>
-          <a:bodyPr wrap="square">
-            <a:spAutoFit/>
-          </a:bodyPr>
-          <a:lstStyle/>
-          <a:p>
-            <a:pPr>
-              <a:spcAft>
-                <a:spcPts val="400"/>
-              </a:spcAft>
-            </a:pPr>
-            <a:r>
-              <a:rPr sz="2400" b="1">
-                <a:solidFill>
-                  <a:srgbClr val="1F4E79"/>
-                </a:solidFill>
-                <a:latin typeface="Arial"/>
-              </a:rPr>
-              <a:t>Interferometer demonstration backups</a:t>
-            </a:r>
-          </a:p>
-          <a:p>
-            <a:pPr>
-              <a:spcAft>
-                <a:spcPts val="0"/>
-              </a:spcAft>
-            </a:pPr>
-            <a:r>
-              <a:rPr sz="1250" b="0">
-                <a:solidFill>
-                  <a:srgbClr val="6E6E6E"/>
-                </a:solidFill>
-                <a:latin typeface="Arial"/>
-              </a:rPr>
-              <a:t>One committed image per live beat</a:t>
-            </a:r>
-          </a:p>
-        </p:txBody>
-      </p:sp>
-      <p:sp>
-        <p:nvSpPr>
-          <p:cNvPr id="3" name="Rectangle 2"/>
-          <p:cNvSpPr/>
-          <p:nvPr/>
-        </p:nvSpPr>
-        <p:spPr>
-          <a:xfrm>
-            <a:off x="411480" y="1133856"/>
-            <a:ext cx="11368735" cy="20320"/>
-          </a:xfrm>
-          <a:prstGeom prst="rect">
-            <a:avLst/>
-          </a:prstGeom>
-          <a:solidFill>
-            <a:srgbClr val="B8C6D4"/>
-          </a:solidFill>
-          <a:ln>
-            <a:noFill/>
-          </a:ln>
-          <a:effectLst/>
-        </p:spPr>
-        <p:style>
-          <a:lnRef idx="1">
-            <a:schemeClr val="accent1"/>
-          </a:lnRef>
-          <a:fillRef idx="3">
-            <a:schemeClr val="accent1"/>
-          </a:fillRef>
-          <a:effectRef idx="2">
-            <a:schemeClr val="accent1"/>
-          </a:effectRef>
-          <a:fontRef idx="minor">
-            <a:schemeClr val="lt1"/>
-          </a:fontRef>
-        </p:style>
-        <p:txBody>
-          <a:bodyPr rtlCol="0" anchor="ctr"/>
-          <a:lstStyle/>
-          <a:p>
-            <a:pPr algn="ctr"/>
-          </a:p>
-        </p:txBody>
-      </p:sp>
-      <p:pic>
-        <p:nvPicPr>
-          <p:cNvPr id="4" name="Picture 3" descr="demo2_beat5_poke.png"/>
-          <p:cNvPicPr>
-            <a:picLocks noChangeAspect="1"/>
-          </p:cNvPicPr>
-          <p:nvPr/>
-        </p:nvPicPr>
-        <p:blipFill>
-          <a:blip r:embed="rId2"/>
-          <a:stretch>
-            <a:fillRect/>
-          </a:stretch>
-        </p:blipFill>
-        <p:spPr>
-          <a:xfrm>
-            <a:off x="3772370" y="1298448"/>
-            <a:ext cx="4646955" cy="1782572"/>
-          </a:xfrm>
-          <a:prstGeom prst="rect">
-            <a:avLst/>
-          </a:prstGeom>
-        </p:spPr>
-      </p:pic>
-      <p:sp>
-        <p:nvSpPr>
-          <p:cNvPr id="5" name="TextBox 4"/>
-          <p:cNvSpPr txBox="1"/>
-          <p:nvPr/>
-        </p:nvSpPr>
-        <p:spPr>
-          <a:xfrm>
-            <a:off x="411480" y="3099308"/>
-            <a:ext cx="11368735" cy="229107"/>
-          </a:xfrm>
-          <a:prstGeom prst="rect">
-            <a:avLst/>
-          </a:prstGeom>
-          <a:noFill/>
-        </p:spPr>
-        <p:txBody>
-          <a:bodyPr wrap="square">
-            <a:spAutoFit/>
-          </a:bodyPr>
-          <a:lstStyle/>
-          <a:p>
-            <a:pPr algn="ctr">
-              <a:spcAft>
-                <a:spcPts val="0"/>
-              </a:spcAft>
-            </a:pPr>
-            <a:r>
-              <a:rPr sz="1000" b="0">
-                <a:solidFill>
-                  <a:srgbClr val="6E6E6E"/>
-                </a:solidFill>
-                <a:latin typeface="Arial"/>
-              </a:rPr>
-              <a:t>Beat 5 — one actuator poked: the fringes bend over it.</a:t>
-            </a:r>
-          </a:p>
-        </p:txBody>
-      </p:sp>
-      <p:pic>
-        <p:nvPicPr>
-          <p:cNvPr id="6" name="Picture 5" descr="demo2_beat6_sweep.png"/>
-          <p:cNvPicPr>
-            <a:picLocks noChangeAspect="1"/>
-          </p:cNvPicPr>
-          <p:nvPr/>
-        </p:nvPicPr>
-        <p:blipFill>
-          <a:blip r:embed="rId3"/>
-          <a:stretch>
-            <a:fillRect/>
-          </a:stretch>
-        </p:blipFill>
-        <p:spPr>
-          <a:xfrm>
-            <a:off x="4186821" y="3364992"/>
-            <a:ext cx="3818051" cy="1782572"/>
-          </a:xfrm>
-          <a:prstGeom prst="rect">
-            <a:avLst/>
-          </a:prstGeom>
-        </p:spPr>
-      </p:pic>
-      <p:sp>
-        <p:nvSpPr>
-          <p:cNvPr id="7" name="TextBox 6"/>
-          <p:cNvSpPr txBox="1"/>
-          <p:nvPr/>
-        </p:nvSpPr>
-        <p:spPr>
-          <a:xfrm>
-            <a:off x="411480" y="5165852"/>
-            <a:ext cx="11368735" cy="229107"/>
-          </a:xfrm>
-          <a:prstGeom prst="rect">
-            <a:avLst/>
-          </a:prstGeom>
-          <a:noFill/>
-        </p:spPr>
-        <p:txBody>
-          <a:bodyPr wrap="square">
-            <a:spAutoFit/>
-          </a:bodyPr>
-          <a:lstStyle/>
-          <a:p>
-            <a:pPr algn="ctr">
-              <a:spcAft>
-                <a:spcPts val="0"/>
-              </a:spcAft>
-            </a:pPr>
-            <a:r>
-              <a:rPr sz="1000" b="0">
-                <a:solidFill>
-                  <a:srgbClr val="6E6E6E"/>
-                </a:solidFill>
-                <a:latin typeface="Arial"/>
-              </a:rPr>
-              <a:t>Beat 6 — the analyzer sweep: phase-stepped frames, no re-trace.</a:t>
-            </a:r>
-          </a:p>
-        </p:txBody>
-      </p:sp>
-      <p:pic>
-        <p:nvPicPr>
-          <p:cNvPr id="8" name="Picture 7" descr="demo2_beat7_recovery.png"/>
-          <p:cNvPicPr>
-            <a:picLocks noChangeAspect="1"/>
-          </p:cNvPicPr>
-          <p:nvPr/>
-        </p:nvPicPr>
-        <p:blipFill>
-          <a:blip r:embed="rId4"/>
-          <a:stretch>
-            <a:fillRect/>
-          </a:stretch>
-        </p:blipFill>
-        <p:spPr>
-          <a:xfrm>
-            <a:off x="4177857" y="5431536"/>
-            <a:ext cx="3835980" cy="1032763"/>
-          </a:xfrm>
-          <a:prstGeom prst="rect">
-            <a:avLst/>
-          </a:prstGeom>
-        </p:spPr>
-      </p:pic>
-      <p:sp>
-        <p:nvSpPr>
-          <p:cNvPr id="9" name="TextBox 8"/>
-          <p:cNvSpPr txBox="1"/>
-          <p:nvPr/>
-        </p:nvSpPr>
-        <p:spPr>
-          <a:xfrm>
-            <a:off x="411480" y="6482588"/>
-            <a:ext cx="11368735" cy="229107"/>
-          </a:xfrm>
-          <a:prstGeom prst="rect">
-            <a:avLst/>
-          </a:prstGeom>
-          <a:noFill/>
-        </p:spPr>
-        <p:txBody>
-          <a:bodyPr wrap="square">
-            <a:spAutoFit/>
-          </a:bodyPr>
-          <a:lstStyle/>
-          <a:p>
-            <a:pPr algn="ctr">
-              <a:spcAft>
-                <a:spcPts val="0"/>
-              </a:spcAft>
-            </a:pPr>
-            <a:r>
-              <a:rPr sz="1000" b="0">
-                <a:solidFill>
-                  <a:srgbClr val="6E6E6E"/>
-                </a:solidFill>
-                <a:latin typeface="Arial"/>
-              </a:rPr>
-              <a:t>Beat 7 — the recovery beside the truth map.</a:t>
-            </a:r>
-          </a:p>
-        </p:txBody>
-      </p:sp>
-      <p:sp>
-        <p:nvSpPr>
-          <p:cNvPr id="10" name="TextBox 9"/>
-          <p:cNvSpPr txBox="1"/>
-          <p:nvPr/>
-        </p:nvSpPr>
-        <p:spPr>
-          <a:xfrm>
-            <a:off x="411480" y="6748272"/>
-            <a:ext cx="11368735" cy="274320"/>
-          </a:xfrm>
-          <a:prstGeom prst="rect">
-            <a:avLst/>
-          </a:prstGeom>
-          <a:noFill/>
-        </p:spPr>
-        <p:txBody>
-          <a:bodyPr wrap="square">
-            <a:spAutoFit/>
-          </a:bodyPr>
-          <a:lstStyle/>
-          <a:p>
-            <a:pPr>
-              <a:spcAft>
-                <a:spcPts val="600"/>
-              </a:spcAft>
-            </a:pPr>
-            <a:r>
-              <a:rPr sz="1050" b="0">
-                <a:solidFill>
-                  <a:srgbClr val="6E6E6E"/>
-                </a:solidFill>
-                <a:latin typeface="Arial"/>
-              </a:rPr>
-              <a:t>All eight beats have committed figures in templates/90_polarization/tg_psi_dm_v2 (v1 likewise); the driver opens them on the desktop as each beat runs.</a:t>
             </a:r>
           </a:p>
         </p:txBody>
@@ -15067,7 +15013,7 @@
                 </a:solidFill>
                 <a:latin typeface="Arial"/>
               </a:rPr>
-              <a:t>The e2e worked example: specification to design</a:t>
+              <a:t>Interferometer demonstration backups</a:t>
             </a:r>
           </a:p>
           <a:p>
@@ -15083,7 +15029,7 @@
                 </a:solidFill>
                 <a:latin typeface="Arial"/>
               </a:rPr>
-              <a:t>A 4 m f/18 visible-band telescope from a closed-form seed — no starting prescription</a:t>
+              <a:t>One committed image per live beat</a:t>
             </a:r>
           </a:p>
         </p:txBody>
@@ -15132,64 +15078,9 @@
           </a:p>
         </p:txBody>
       </p:sp>
-      <p:sp>
-        <p:nvSpPr>
-          <p:cNvPr id="4" name="TextBox 3"/>
-          <p:cNvSpPr txBox="1"/>
-          <p:nvPr/>
-        </p:nvSpPr>
-        <p:spPr>
-          <a:xfrm>
-            <a:off x="411480" y="1298448"/>
-            <a:ext cx="5806440" cy="274320"/>
-          </a:xfrm>
-          <a:prstGeom prst="rect">
-            <a:avLst/>
-          </a:prstGeom>
-          <a:noFill/>
-        </p:spPr>
-        <p:txBody>
-          <a:bodyPr wrap="square">
-            <a:spAutoFit/>
-          </a:bodyPr>
-          <a:lstStyle/>
-          <a:p>
-            <a:pPr>
-              <a:spcAft>
-                <a:spcPts val="600"/>
-              </a:spcAft>
-            </a:pPr>
-            <a:r>
-              <a:rPr sz="1200" b="0">
-                <a:solidFill>
-                  <a:srgbClr val="282828"/>
-                </a:solidFill>
-                <a:latin typeface="Arial"/>
-              </a:rPr>
-              <a:t>•  The stage-runner sequence on the smaller worked example: specification → design → segmentation → metrology → comparison → simulation, each stage a committed runner handing its prescription to the next.</a:t>
-            </a:r>
-          </a:p>
-          <a:p>
-            <a:pPr>
-              <a:spcAft>
-                <a:spcPts val="600"/>
-              </a:spcAft>
-            </a:pPr>
-            <a:r>
-              <a:rPr sz="1200" b="0">
-                <a:solidFill>
-                  <a:srgbClr val="282828"/>
-                </a:solidFill>
-                <a:latin typeface="Arial"/>
-              </a:rPr>
-              <a:t>•  A 4 m f/18 telescope (f/1.75 primary) from a closed-form first-order seed; diffraction-limited over ±1′ alone, and the Offner ring-field relay buys the full ±2′ (Strehl floor 0.965, on pure spheres).</a:t>
-            </a:r>
-          </a:p>
-        </p:txBody>
-      </p:sp>
       <p:pic>
         <p:nvPicPr>
-          <p:cNvPr id="5" name="Picture 4" descr="rowpair_s1_views.png"/>
+          <p:cNvPr id="4" name="Picture 3" descr="demo2_beat5_poke.png"/>
           <p:cNvPicPr>
             <a:picLocks noChangeAspect="1"/>
           </p:cNvPicPr>
@@ -15203,8 +15094,8 @@
         </p:blipFill>
         <p:spPr>
           <a:xfrm>
-            <a:off x="6738659" y="1298448"/>
-            <a:ext cx="4719240" cy="2056892"/>
+            <a:off x="3772370" y="1298448"/>
+            <a:ext cx="4646955" cy="1782572"/>
           </a:xfrm>
           <a:prstGeom prst="rect">
             <a:avLst/>
@@ -15213,14 +15104,14 @@
       </p:pic>
       <p:sp>
         <p:nvSpPr>
-          <p:cNvPr id="6" name="TextBox 5"/>
+          <p:cNvPr id="5" name="TextBox 4"/>
           <p:cNvSpPr txBox="1"/>
           <p:nvPr/>
         </p:nvSpPr>
         <p:spPr>
           <a:xfrm>
-            <a:off x="6400800" y="3373628"/>
-            <a:ext cx="5394960" cy="229107"/>
+            <a:off x="411480" y="3099308"/>
+            <a:ext cx="11368735" cy="229107"/>
           </a:xfrm>
           <a:prstGeom prst="rect">
             <a:avLst/>
@@ -15245,14 +15136,14 @@
                 </a:solidFill>
                 <a:latin typeface="Arial"/>
               </a:rPr>
-              <a:t>The telescope as designed (front + iso views), with the traced field.</a:t>
+              <a:t>Beat 5 — one actuator poked: the fringes bend over it.</a:t>
             </a:r>
           </a:p>
         </p:txBody>
       </p:sp>
       <p:pic>
         <p:nvPicPr>
-          <p:cNvPr id="7" name="Picture 6" descr="s1_wfe_field.png"/>
+          <p:cNvPr id="6" name="Picture 5" descr="demo2_beat6_sweep.png"/>
           <p:cNvPicPr>
             <a:picLocks noChangeAspect="1"/>
           </p:cNvPicPr>
@@ -15266,8 +15157,8 @@
         </p:blipFill>
         <p:spPr>
           <a:xfrm>
-            <a:off x="7993860" y="3639312"/>
-            <a:ext cx="2208839" cy="1782572"/>
+            <a:off x="4186821" y="3364992"/>
+            <a:ext cx="3818051" cy="1782572"/>
           </a:xfrm>
           <a:prstGeom prst="rect">
             <a:avLst/>
@@ -15276,14 +15167,14 @@
       </p:pic>
       <p:sp>
         <p:nvSpPr>
-          <p:cNvPr id="8" name="TextBox 7"/>
+          <p:cNvPr id="7" name="TextBox 6"/>
           <p:cNvSpPr txBox="1"/>
           <p:nvPr/>
         </p:nvSpPr>
         <p:spPr>
           <a:xfrm>
-            <a:off x="6400800" y="5440171"/>
-            <a:ext cx="5394960" cy="229107"/>
+            <a:off x="411480" y="5165852"/>
+            <a:ext cx="11368735" cy="229107"/>
           </a:xfrm>
           <a:prstGeom prst="rect">
             <a:avLst/>
@@ -15308,11 +15199,35 @@
                 </a:solidFill>
                 <a:latin typeface="Arial"/>
               </a:rPr>
-              <a:t>Wavefront error over the field: diffraction-limited across the box.</a:t>
-            </a:r>
-          </a:p>
-        </p:txBody>
-      </p:sp>
+              <a:t>Beat 6 — the analyzer sweep: phase-stepped frames, no re-trace.</a:t>
+            </a:r>
+          </a:p>
+        </p:txBody>
+      </p:sp>
+      <p:pic>
+        <p:nvPicPr>
+          <p:cNvPr id="8" name="Picture 7" descr="demo2_beat7_recovery.png"/>
+          <p:cNvPicPr>
+            <a:picLocks noChangeAspect="1"/>
+          </p:cNvPicPr>
+          <p:nvPr/>
+        </p:nvPicPr>
+        <p:blipFill>
+          <a:blip r:embed="rId4"/>
+          <a:stretch>
+            <a:fillRect/>
+          </a:stretch>
+        </p:blipFill>
+        <p:spPr>
+          <a:xfrm>
+            <a:off x="4177857" y="5431536"/>
+            <a:ext cx="3835980" cy="1032763"/>
+          </a:xfrm>
+          <a:prstGeom prst="rect">
+            <a:avLst/>
+          </a:prstGeom>
+        </p:spPr>
+      </p:pic>
       <p:sp>
         <p:nvSpPr>
           <p:cNvPr id="9" name="TextBox 8"/>
@@ -15321,8 +15236,8 @@
         </p:nvSpPr>
         <p:spPr>
           <a:xfrm>
-            <a:off x="6400800" y="5705855"/>
-            <a:ext cx="5394960" cy="274320"/>
+            <a:off x="411480" y="6482588"/>
+            <a:ext cx="11368735" cy="229107"/>
           </a:xfrm>
           <a:prstGeom prst="rect">
             <a:avLst/>
@@ -15335,6 +15250,45 @@
           </a:bodyPr>
           <a:lstStyle/>
           <a:p>
+            <a:pPr algn="ctr">
+              <a:spcAft>
+                <a:spcPts val="0"/>
+              </a:spcAft>
+            </a:pPr>
+            <a:r>
+              <a:rPr sz="1000" b="0">
+                <a:solidFill>
+                  <a:srgbClr val="6E6E6E"/>
+                </a:solidFill>
+                <a:latin typeface="Arial"/>
+              </a:rPr>
+              <a:t>Beat 7 — the recovery beside the truth map.</a:t>
+            </a:r>
+          </a:p>
+        </p:txBody>
+      </p:sp>
+      <p:sp>
+        <p:nvSpPr>
+          <p:cNvPr id="10" name="TextBox 9"/>
+          <p:cNvSpPr txBox="1"/>
+          <p:nvPr/>
+        </p:nvSpPr>
+        <p:spPr>
+          <a:xfrm>
+            <a:off x="411480" y="6748272"/>
+            <a:ext cx="11368735" cy="274320"/>
+          </a:xfrm>
+          <a:prstGeom prst="rect">
+            <a:avLst/>
+          </a:prstGeom>
+          <a:noFill/>
+        </p:spPr>
+        <p:txBody>
+          <a:bodyPr wrap="square">
+            <a:spAutoFit/>
+          </a:bodyPr>
+          <a:lstStyle/>
+          <a:p>
             <a:pPr>
               <a:spcAft>
                 <a:spcPts val="600"/>
@@ -15347,7 +15301,7 @@
                 </a:solidFill>
                 <a:latin typeface="Arial"/>
               </a:rPr>
-              <a:t>Record: templates/80_end_to_end/e2e — staged worked example, committed at every step.</a:t>
+              <a:t>All eight beats have committed figures in templates/90_polarization/tg_psi_dm_v2 (v1 likewise); the driver opens them on the desktop as each beat runs.</a:t>
             </a:r>
           </a:p>
         </p:txBody>
@@ -15404,7 +15358,7 @@
                 </a:solidFill>
                 <a:latin typeface="Arial"/>
               </a:rPr>
-              <a:t>The e2e worked example: segmentation and metrology</a:t>
+              <a:t>The e2e worked example: specification to design</a:t>
             </a:r>
           </a:p>
           <a:p>
@@ -15420,7 +15374,7 @@
                 </a:solidFill>
                 <a:latin typeface="Arial"/>
               </a:rPr>
-              <a:t>The monolith segments in one call; the metrology is designed on the same Jacobian</a:t>
+              <a:t>A 4 m f/18 visible-band telescope from a closed-form seed — no starting prescription</a:t>
             </a:r>
           </a:p>
         </p:txBody>
@@ -15503,7 +15457,7 @@
                 </a:solidFill>
                 <a:latin typeface="Arial"/>
               </a:rPr>
-              <a:t>•  The primary segments into a pie or hex tiling with physical apertures; every segment gets rigid-body and surface-figure sensitivity channels, stacked into one Jacobian — the control basis.</a:t>
+              <a:t>•  The stage-runner sequence on the smaller worked example: specification → design → segmentation → metrology → comparison → simulation, each stage a committed runner handing its prescription to the next.</a:t>
             </a:r>
           </a:p>
           <a:p>
@@ -15519,14 +15473,14 @@
                 </a:solidFill>
                 <a:latin typeface="Arial"/>
               </a:rPr>
-              <a:t>•  Metrology is an optimization on that basis: edge-sensor and beam-launcher layouts scored by the control information they carry, not by symmetry; the winning pattern exports as a reusable preset.</a:t>
+              <a:t>•  A 4 m f/18 telescope (f/1.75 primary) from a closed-form first-order seed; diffraction-limited over ±1′ alone, and the Offner ring-field relay buys the full ±2′ (Strehl floor 0.965, on pure spheres).</a:t>
             </a:r>
           </a:p>
         </p:txBody>
       </p:sp>
       <p:pic>
         <p:nvPicPr>
-          <p:cNvPr id="5" name="Picture 4" descr="rowpair_s3_views_pie.png"/>
+          <p:cNvPr id="5" name="Picture 4" descr="rowpair_s1_views.png"/>
           <p:cNvPicPr>
             <a:picLocks noChangeAspect="1"/>
           </p:cNvPicPr>
@@ -15540,8 +15494,8 @@
         </p:blipFill>
         <p:spPr>
           <a:xfrm>
-            <a:off x="6618167" y="1298448"/>
-            <a:ext cx="4960224" cy="1965451"/>
+            <a:off x="6738659" y="1298448"/>
+            <a:ext cx="4719240" cy="2056892"/>
           </a:xfrm>
           <a:prstGeom prst="rect">
             <a:avLst/>
@@ -15556,7 +15510,7 @@
         </p:nvSpPr>
         <p:spPr>
           <a:xfrm>
-            <a:off x="6400800" y="3282188"/>
+            <a:off x="6400800" y="3373628"/>
             <a:ext cx="5394960" cy="229107"/>
           </a:xfrm>
           <a:prstGeom prst="rect">
@@ -15582,14 +15536,14 @@
                 </a:solidFill>
                 <a:latin typeface="Arial"/>
               </a:rPr>
-              <a:t>The segmented primary with physical apertures (front + iso views).</a:t>
+              <a:t>The telescope as designed (front + iso views), with the traced field.</a:t>
             </a:r>
           </a:p>
         </p:txBody>
       </p:sp>
       <p:pic>
         <p:nvPicPr>
-          <p:cNvPr id="7" name="Picture 6" descr="e2e_pie_met_view_rx.png"/>
+          <p:cNvPr id="7" name="Picture 6" descr="s1_wfe_field.png"/>
           <p:cNvPicPr>
             <a:picLocks noChangeAspect="1"/>
           </p:cNvPicPr>
@@ -15603,8 +15557,8 @@
         </p:blipFill>
         <p:spPr>
           <a:xfrm>
-            <a:off x="7662896" y="3547872"/>
-            <a:ext cx="2870767" cy="1874011"/>
+            <a:off x="7993860" y="3639312"/>
+            <a:ext cx="2208839" cy="1782572"/>
           </a:xfrm>
           <a:prstGeom prst="rect">
             <a:avLst/>
@@ -15645,7 +15599,7 @@
                 </a:solidFill>
                 <a:latin typeface="Arial"/>
               </a:rPr>
-              <a:t>The optimized metrology layout on the segmented primary.</a:t>
+              <a:t>Wavefront error over the field: diffraction-limited across the box.</a:t>
             </a:r>
           </a:p>
         </p:txBody>
@@ -15684,7 +15638,7 @@
                 </a:solidFill>
                 <a:latin typeface="Arial"/>
               </a:rPr>
-              <a:t>Record: templates/80_end_to_end/e2e, stages 3–5.</a:t>
+              <a:t>Record: templates/80_end_to_end/e2e — staged worked example, committed at every step.</a:t>
             </a:r>
           </a:p>
         </p:txBody>
@@ -15741,7 +15695,7 @@
                 </a:solidFill>
                 <a:latin typeface="Arial"/>
               </a:rPr>
-              <a:t>The e2e worked example: comparison and simulation</a:t>
+              <a:t>The e2e worked example: segmentation and metrology</a:t>
             </a:r>
           </a:p>
           <a:p>
@@ -15757,7 +15711,7 @@
                 </a:solidFill>
                 <a:latin typeface="Arial"/>
               </a:rPr>
-              <a:t>Segment drift of 10⁵ nm rms is sensed and held at ~7 nm corrected</a:t>
+              <a:t>The monolith segments in one call; the metrology is designed on the same Jacobian</a:t>
             </a:r>
           </a:p>
         </p:txBody>
@@ -15815,7 +15769,7 @@
         <p:spPr>
           <a:xfrm>
             <a:off x="411480" y="1298448"/>
-            <a:ext cx="11368735" cy="274320"/>
+            <a:ext cx="5806440" cy="274320"/>
           </a:xfrm>
           <a:prstGeom prst="rect">
             <a:avLst/>
@@ -15834,20 +15788,36 @@
               </a:spcAft>
             </a:pPr>
             <a:r>
-              <a:rPr sz="1500" b="0">
+              <a:rPr sz="1200" b="0">
                 <a:solidFill>
                   <a:srgbClr val="282828"/>
                 </a:solidFill>
                 <a:latin typeface="Arial"/>
               </a:rPr>
-              <a:t>•  Every linear model is checked against the engine before it is trusted: step each channel, re-trace, render engine and model side by side (left).  Then the simulator closes the loop on the same model: inject drift, sense with the designed metrology, estimate, correct (right).</a:t>
+              <a:t>•  The primary segments into a pie or hex tiling with physical apertures; every segment gets rigid-body and surface-figure sensitivity channels, stacked into one Jacobian — the control basis.</a:t>
+            </a:r>
+          </a:p>
+          <a:p>
+            <a:pPr>
+              <a:spcAft>
+                <a:spcPts val="600"/>
+              </a:spcAft>
+            </a:pPr>
+            <a:r>
+              <a:rPr sz="1200" b="0">
+                <a:solidFill>
+                  <a:srgbClr val="282828"/>
+                </a:solidFill>
+                <a:latin typeface="Arial"/>
+              </a:rPr>
+              <a:t>•  Metrology is an optimization on that basis: edge-sensor and beam-launcher layouts scored by the control information they carry, not by symmetry; the winning pattern exports as a reusable preset.</a:t>
             </a:r>
           </a:p>
         </p:txBody>
       </p:sp>
       <p:pic>
         <p:nvPicPr>
-          <p:cNvPr id="5" name="Picture 4" descr="e2e_compare_p001.png"/>
+          <p:cNvPr id="5" name="Picture 4" descr="rowpair_s3_views_pie.png"/>
           <p:cNvPicPr>
             <a:picLocks noChangeAspect="1"/>
           </p:cNvPicPr>
@@ -15861,8 +15831,8 @@
         </p:blipFill>
         <p:spPr>
           <a:xfrm>
-            <a:off x="1466756" y="2218182"/>
-            <a:ext cx="3695887" cy="2714752"/>
+            <a:off x="6618167" y="1298448"/>
+            <a:ext cx="4960224" cy="1965451"/>
           </a:xfrm>
           <a:prstGeom prst="rect">
             <a:avLst/>
@@ -15877,8 +15847,8 @@
         </p:nvSpPr>
         <p:spPr>
           <a:xfrm>
-            <a:off x="411480" y="4951222"/>
-            <a:ext cx="5806440" cy="394208"/>
+            <a:off x="6400800" y="3282188"/>
+            <a:ext cx="5394960" cy="229107"/>
           </a:xfrm>
           <a:prstGeom prst="rect">
             <a:avLst/>
@@ -15903,14 +15873,14 @@
                 </a:solidFill>
                 <a:latin typeface="Arial"/>
               </a:rPr>
-              <a:t>The comparison stage: engine re-trace vs linear model, one perturbation channel (segment 1 Rx, +100 nrad).</a:t>
+              <a:t>The segmented primary with physical apertures (front + iso views).</a:t>
             </a:r>
           </a:p>
         </p:txBody>
       </p:sp>
       <p:pic>
         <p:nvPicPr>
-          <p:cNvPr id="7" name="Picture 6" descr="e2e_sim_t007.png"/>
+          <p:cNvPr id="7" name="Picture 6" descr="e2e_pie_met_view_rx.png"/>
           <p:cNvPicPr>
             <a:picLocks noChangeAspect="1"/>
           </p:cNvPicPr>
@@ -15924,8 +15894,8 @@
         </p:blipFill>
         <p:spPr>
           <a:xfrm>
-            <a:off x="6784520" y="2218182"/>
-            <a:ext cx="4627519" cy="2714752"/>
+            <a:off x="7662896" y="3547872"/>
+            <a:ext cx="2870767" cy="1874011"/>
           </a:xfrm>
           <a:prstGeom prst="rect">
             <a:avLst/>
@@ -15940,8 +15910,8 @@
         </p:nvSpPr>
         <p:spPr>
           <a:xfrm>
-            <a:off x="6400800" y="4951222"/>
-            <a:ext cx="5394960" cy="394208"/>
+            <a:off x="6400800" y="5440171"/>
+            <a:ext cx="5394960" cy="229107"/>
           </a:xfrm>
           <a:prstGeom prst="rect">
             <a:avLst/>
@@ -15966,7 +15936,7 @@
                 </a:solidFill>
                 <a:latin typeface="Arial"/>
               </a:rPr>
-              <a:t>The simulator at t = 70 s: uncorrected 1.0×10⁵ nm vs 6.8 nm corrected; accumulating WFE and Strehl vs time below.</a:t>
+              <a:t>The optimized metrology layout on the segmented primary.</a:t>
             </a:r>
           </a:p>
         </p:txBody>
@@ -15979,7 +15949,7 @@
         </p:nvSpPr>
         <p:spPr>
           <a:xfrm>
-            <a:off x="6400800" y="5382006"/>
+            <a:off x="6400800" y="5705855"/>
             <a:ext cx="5394960" cy="274320"/>
           </a:xfrm>
           <a:prstGeom prst="rect">
@@ -16005,7 +15975,7 @@
                 </a:solidFill>
                 <a:latin typeface="Arial"/>
               </a:rPr>
-              <a:t>Record: templates/80_end_to_end/e2e, comparison + simulator stages (s6/s7).</a:t>
+              <a:t>Record: templates/80_end_to_end/e2e, stages 3–5.</a:t>
             </a:r>
           </a:p>
         </p:txBody>
@@ -16186,6 +16156,327 @@
                 <a:latin typeface="Arial"/>
               </a:rPr>
               <a:t>Counts as of 2026-08.  Every area is exercised by the committed test suites and by the worked examples beside it — the same templates this talk's studies live in.</a:t>
+            </a:r>
+          </a:p>
+        </p:txBody>
+      </p:sp>
+    </p:spTree>
+  </p:cSld>
+  <p:clrMapOvr>
+    <a:masterClrMapping/>
+  </p:clrMapOvr>
+</p:sld>
+</file>
+
+<file path=ppt/slides/slide40.xml><?xml version="1.0" encoding="utf-8"?>
+<p:sld xmlns:a="http://schemas.openxmlformats.org/drawingml/2006/main" xmlns:p="http://schemas.openxmlformats.org/presentationml/2006/main" xmlns:r="http://schemas.openxmlformats.org/officeDocument/2006/relationships">
+  <p:cSld>
+    <p:spTree>
+      <p:nvGrpSpPr>
+        <p:cNvPr id="1" name=""/>
+        <p:cNvGrpSpPr/>
+        <p:nvPr/>
+      </p:nvGrpSpPr>
+      <p:grpSpPr/>
+      <p:sp>
+        <p:nvSpPr>
+          <p:cNvPr id="2" name="TextBox 1"/>
+          <p:cNvSpPr txBox="1"/>
+          <p:nvPr/>
+        </p:nvSpPr>
+        <p:spPr>
+          <a:xfrm>
+            <a:off x="411480" y="201168"/>
+            <a:ext cx="11368735" cy="914400"/>
+          </a:xfrm>
+          <a:prstGeom prst="rect">
+            <a:avLst/>
+          </a:prstGeom>
+          <a:noFill/>
+        </p:spPr>
+        <p:txBody>
+          <a:bodyPr wrap="square">
+            <a:spAutoFit/>
+          </a:bodyPr>
+          <a:lstStyle/>
+          <a:p>
+            <a:pPr>
+              <a:spcAft>
+                <a:spcPts val="400"/>
+              </a:spcAft>
+            </a:pPr>
+            <a:r>
+              <a:rPr sz="2400" b="1">
+                <a:solidFill>
+                  <a:srgbClr val="1F4E79"/>
+                </a:solidFill>
+                <a:latin typeface="Arial"/>
+              </a:rPr>
+              <a:t>The e2e worked example: comparison and simulation</a:t>
+            </a:r>
+          </a:p>
+          <a:p>
+            <a:pPr>
+              <a:spcAft>
+                <a:spcPts val="0"/>
+              </a:spcAft>
+            </a:pPr>
+            <a:r>
+              <a:rPr sz="1250" b="0">
+                <a:solidFill>
+                  <a:srgbClr val="6E6E6E"/>
+                </a:solidFill>
+                <a:latin typeface="Arial"/>
+              </a:rPr>
+              <a:t>Segment drift of 10⁵ nm rms is sensed and held at ~7 nm corrected</a:t>
+            </a:r>
+          </a:p>
+        </p:txBody>
+      </p:sp>
+      <p:sp>
+        <p:nvSpPr>
+          <p:cNvPr id="3" name="Rectangle 2"/>
+          <p:cNvSpPr/>
+          <p:nvPr/>
+        </p:nvSpPr>
+        <p:spPr>
+          <a:xfrm>
+            <a:off x="411480" y="1133856"/>
+            <a:ext cx="11368735" cy="20320"/>
+          </a:xfrm>
+          <a:prstGeom prst="rect">
+            <a:avLst/>
+          </a:prstGeom>
+          <a:solidFill>
+            <a:srgbClr val="B8C6D4"/>
+          </a:solidFill>
+          <a:ln>
+            <a:noFill/>
+          </a:ln>
+          <a:effectLst/>
+        </p:spPr>
+        <p:style>
+          <a:lnRef idx="1">
+            <a:schemeClr val="accent1"/>
+          </a:lnRef>
+          <a:fillRef idx="3">
+            <a:schemeClr val="accent1"/>
+          </a:fillRef>
+          <a:effectRef idx="2">
+            <a:schemeClr val="accent1"/>
+          </a:effectRef>
+          <a:fontRef idx="minor">
+            <a:schemeClr val="lt1"/>
+          </a:fontRef>
+        </p:style>
+        <p:txBody>
+          <a:bodyPr rtlCol="0" anchor="ctr"/>
+          <a:lstStyle/>
+          <a:p>
+            <a:pPr algn="ctr"/>
+          </a:p>
+        </p:txBody>
+      </p:sp>
+      <p:sp>
+        <p:nvSpPr>
+          <p:cNvPr id="4" name="TextBox 3"/>
+          <p:cNvSpPr txBox="1"/>
+          <p:nvPr/>
+        </p:nvSpPr>
+        <p:spPr>
+          <a:xfrm>
+            <a:off x="411480" y="1298448"/>
+            <a:ext cx="11368735" cy="274320"/>
+          </a:xfrm>
+          <a:prstGeom prst="rect">
+            <a:avLst/>
+          </a:prstGeom>
+          <a:noFill/>
+        </p:spPr>
+        <p:txBody>
+          <a:bodyPr wrap="square">
+            <a:spAutoFit/>
+          </a:bodyPr>
+          <a:lstStyle/>
+          <a:p>
+            <a:pPr>
+              <a:spcAft>
+                <a:spcPts val="600"/>
+              </a:spcAft>
+            </a:pPr>
+            <a:r>
+              <a:rPr sz="1500" b="0">
+                <a:solidFill>
+                  <a:srgbClr val="282828"/>
+                </a:solidFill>
+                <a:latin typeface="Arial"/>
+              </a:rPr>
+              <a:t>•  Every linear model is checked against the engine before it is trusted: step each channel, re-trace, render engine and model side by side (left).  Then the simulator closes the loop on the same model: inject drift, sense with the designed metrology, estimate, correct (right).</a:t>
+            </a:r>
+          </a:p>
+        </p:txBody>
+      </p:sp>
+      <p:pic>
+        <p:nvPicPr>
+          <p:cNvPr id="5" name="Picture 4" descr="e2e_compare_p001.png"/>
+          <p:cNvPicPr>
+            <a:picLocks noChangeAspect="1"/>
+          </p:cNvPicPr>
+          <p:nvPr/>
+        </p:nvPicPr>
+        <p:blipFill>
+          <a:blip r:embed="rId2"/>
+          <a:stretch>
+            <a:fillRect/>
+          </a:stretch>
+        </p:blipFill>
+        <p:spPr>
+          <a:xfrm>
+            <a:off x="1466756" y="2218182"/>
+            <a:ext cx="3695887" cy="2714752"/>
+          </a:xfrm>
+          <a:prstGeom prst="rect">
+            <a:avLst/>
+          </a:prstGeom>
+        </p:spPr>
+      </p:pic>
+      <p:sp>
+        <p:nvSpPr>
+          <p:cNvPr id="6" name="TextBox 5"/>
+          <p:cNvSpPr txBox="1"/>
+          <p:nvPr/>
+        </p:nvSpPr>
+        <p:spPr>
+          <a:xfrm>
+            <a:off x="411480" y="4951222"/>
+            <a:ext cx="5806440" cy="394208"/>
+          </a:xfrm>
+          <a:prstGeom prst="rect">
+            <a:avLst/>
+          </a:prstGeom>
+          <a:noFill/>
+        </p:spPr>
+        <p:txBody>
+          <a:bodyPr wrap="square">
+            <a:spAutoFit/>
+          </a:bodyPr>
+          <a:lstStyle/>
+          <a:p>
+            <a:pPr algn="ctr">
+              <a:spcAft>
+                <a:spcPts val="0"/>
+              </a:spcAft>
+            </a:pPr>
+            <a:r>
+              <a:rPr sz="1000" b="0">
+                <a:solidFill>
+                  <a:srgbClr val="6E6E6E"/>
+                </a:solidFill>
+                <a:latin typeface="Arial"/>
+              </a:rPr>
+              <a:t>The comparison stage: engine re-trace vs linear model, one perturbation channel (segment 1 Rx, +100 nrad).</a:t>
+            </a:r>
+          </a:p>
+        </p:txBody>
+      </p:sp>
+      <p:pic>
+        <p:nvPicPr>
+          <p:cNvPr id="7" name="Picture 6" descr="e2e_sim_t007.png"/>
+          <p:cNvPicPr>
+            <a:picLocks noChangeAspect="1"/>
+          </p:cNvPicPr>
+          <p:nvPr/>
+        </p:nvPicPr>
+        <p:blipFill>
+          <a:blip r:embed="rId3"/>
+          <a:stretch>
+            <a:fillRect/>
+          </a:stretch>
+        </p:blipFill>
+        <p:spPr>
+          <a:xfrm>
+            <a:off x="6784520" y="2218182"/>
+            <a:ext cx="4627519" cy="2714752"/>
+          </a:xfrm>
+          <a:prstGeom prst="rect">
+            <a:avLst/>
+          </a:prstGeom>
+        </p:spPr>
+      </p:pic>
+      <p:sp>
+        <p:nvSpPr>
+          <p:cNvPr id="8" name="TextBox 7"/>
+          <p:cNvSpPr txBox="1"/>
+          <p:nvPr/>
+        </p:nvSpPr>
+        <p:spPr>
+          <a:xfrm>
+            <a:off x="6400800" y="4951222"/>
+            <a:ext cx="5394960" cy="394208"/>
+          </a:xfrm>
+          <a:prstGeom prst="rect">
+            <a:avLst/>
+          </a:prstGeom>
+          <a:noFill/>
+        </p:spPr>
+        <p:txBody>
+          <a:bodyPr wrap="square">
+            <a:spAutoFit/>
+          </a:bodyPr>
+          <a:lstStyle/>
+          <a:p>
+            <a:pPr algn="ctr">
+              <a:spcAft>
+                <a:spcPts val="0"/>
+              </a:spcAft>
+            </a:pPr>
+            <a:r>
+              <a:rPr sz="1000" b="0">
+                <a:solidFill>
+                  <a:srgbClr val="6E6E6E"/>
+                </a:solidFill>
+                <a:latin typeface="Arial"/>
+              </a:rPr>
+              <a:t>The simulator at t = 70 s: uncorrected 1.0×10⁵ nm vs 6.8 nm corrected; accumulating WFE and Strehl vs time below.</a:t>
+            </a:r>
+          </a:p>
+        </p:txBody>
+      </p:sp>
+      <p:sp>
+        <p:nvSpPr>
+          <p:cNvPr id="9" name="TextBox 8"/>
+          <p:cNvSpPr txBox="1"/>
+          <p:nvPr/>
+        </p:nvSpPr>
+        <p:spPr>
+          <a:xfrm>
+            <a:off x="6400800" y="5382006"/>
+            <a:ext cx="5394960" cy="274320"/>
+          </a:xfrm>
+          <a:prstGeom prst="rect">
+            <a:avLst/>
+          </a:prstGeom>
+          <a:noFill/>
+        </p:spPr>
+        <p:txBody>
+          <a:bodyPr wrap="square">
+            <a:spAutoFit/>
+          </a:bodyPr>
+          <a:lstStyle/>
+          <a:p>
+            <a:pPr>
+              <a:spcAft>
+                <a:spcPts val="600"/>
+              </a:spcAft>
+            </a:pPr>
+            <a:r>
+              <a:rPr sz="1050" b="0">
+                <a:solidFill>
+                  <a:srgbClr val="6E6E6E"/>
+                </a:solidFill>
+                <a:latin typeface="Arial"/>
+              </a:rPr>
+              <a:t>Record: templates/80_end_to_end/e2e, comparison + simulator stages (s6/s7).</a:t>
             </a:r>
           </a:p>
         </p:txBody>

</xml_diff>

<commit_message>
deck: drift slide re-cut around CF5b (JWST-class series on the dug state); ladder/stations/drift order
Edit-deck sync HELD (Impress lock -- Dave reviewing); sync follows on close.

Co-Authored-By: Claude Fable 5 <noreply@anthropic.com>
</commit_message>
<xml_diff>
--- a/demo_session/deck_keysight.pptx
+++ b/demo_session/deck_keysight.pptx
@@ -11315,7 +11315,7 @@
                 </a:solidFill>
                 <a:latin typeface="Arial"/>
               </a:rPr>
-              <a:t>A randomly disturbed observatory, simulated</a:t>
+              <a:t>Digging the dark hole: the overnight restart ladder</a:t>
             </a:r>
           </a:p>
           <a:p>
@@ -11331,7 +11331,7 @@
                 </a:solidFill>
                 <a:latin typeface="Arial"/>
               </a:rPr>
-              <a:t>The closed loop holds dark-zone contrast at 2.5×10⁻⁷ where the uncontrolled series drifts to 1.7×10⁻⁶</a:t>
+              <a:t>1.2×10⁻⁶ → 1.1×10⁻⁹ — three decades from restart scheduling alone; no new hardware, no new physics</a:t>
             </a:r>
           </a:p>
         </p:txBody>
@@ -11414,7 +11414,7 @@
                 </a:solidFill>
                 <a:latin typeface="Arial"/>
               </a:rPr>
-              <a:t>•  Random segment drift is injected; the rigid-body loop senses through the designed metrology, estimates and corrects, while EFC re-solves the dark zone per scored frame — all on one model.</a:t>
+              <a:t>•  The recipe: EFC to a floor, relinearize about the dug state, restart at that floor — rinse and repeat.  Ten digging rounds, ~4 h unattended, on the d = 1.10 m two-DM variant — the spacing study's best linear substrate; three stall rounds then prove the plateau.</a:t>
             </a:r>
           </a:p>
           <a:p>
@@ -11430,7 +11430,7 @@
                 </a:solidFill>
                 <a:latin typeface="Arial"/>
               </a:rPr>
-              <a:t>•  The disturbance interface is the point: the same channels are built to ingest dynamical- and thermal-model time histories — simulating performance in the space environment.  Work in progress.</a:t>
+              <a:t>•  The controller was the bottleneck, measured: a single linearization stalls at 9.0×10⁻⁷; every restart bought another step down.  DM strokes end at 33 nm rms, well inside the 50 nm budget.</a:t>
             </a:r>
           </a:p>
           <a:p>
@@ -11446,14 +11446,14 @@
                 </a:solidFill>
                 <a:latin typeface="Arial"/>
               </a:rPr>
-              <a:t>•  Honest gap, attributed: the hold level is the loop mechanization's floor (sensor noise through the gain, damped EFC), not the model's limit — the next slide digs the static dark hole three decades deeper, overnight.</a:t>
+              <a:t>•  The remaining 1.5 decades are priced: re-measured at every dug state, the linear-achievable floor holds at 2–4×10⁻¹¹ — HWO-class 5×10⁻¹¹ is within this substrate's reach.  The plateau at 1.1×10⁻⁹ is the monotone Tikhonov step rule: the measured case for FALCO-grade step control on this same model.</a:t>
             </a:r>
           </a:p>
         </p:txBody>
       </p:sp>
       <p:pic>
         <p:nvPicPr>
-          <p:cNvPr id="5" name="Picture 4" descr="r4_series_3nm.png"/>
+          <p:cNvPr id="5" name="Picture 4" descr="fig_cf3d_ladder.png"/>
           <p:cNvPicPr>
             <a:picLocks noChangeAspect="1"/>
           </p:cNvPicPr>
@@ -11467,8 +11467,8 @@
         </p:blipFill>
         <p:spPr>
           <a:xfrm>
-            <a:off x="6923477" y="1298448"/>
-            <a:ext cx="4349605" cy="4177792"/>
+            <a:off x="6400800" y="1298448"/>
+            <a:ext cx="5394960" cy="3637305"/>
           </a:xfrm>
           <a:prstGeom prst="rect">
             <a:avLst/>
@@ -11483,7 +11483,7 @@
         </p:nvSpPr>
         <p:spPr>
           <a:xfrm>
-            <a:off x="6400800" y="5494528"/>
+            <a:off x="6400800" y="4954041"/>
             <a:ext cx="5394960" cy="394208"/>
           </a:xfrm>
           <a:prstGeom prst="rect">
@@ -11509,7 +11509,7 @@
                 </a:solidFill>
                 <a:latin typeface="Arial"/>
               </a:rPr>
-              <a:t>Four hundred seconds under drift: segment rigid-body state, wavefront at the coronagraph exit pupil, and science-plane contrast — open loop against closed.</a:t>
+              <a:t>The ladder: measured dark-zone floor by restart round, with the linear-achievable substrate re-measured at every dug state.</a:t>
             </a:r>
           </a:p>
         </p:txBody>
@@ -11522,7 +11522,7 @@
         </p:nvSpPr>
         <p:spPr>
           <a:xfrm>
-            <a:off x="6400800" y="5925312"/>
+            <a:off x="6400800" y="5384825"/>
             <a:ext cx="5394960" cy="274320"/>
           </a:xfrm>
           <a:prstGeom prst="rect">
@@ -11548,7 +11548,7 @@
                 </a:solidFill>
                 <a:latin typeface="Arial"/>
               </a:rPr>
-              <a:t>Record: templates/80_end_to_end/e2e6m_r2, time-series stage.</a:t>
+              <a:t>Record: templates/80_end_to_end/e2e6m_r2, CF3d stage — checkpointed and resumable; every round is a finished floor.</a:t>
             </a:r>
           </a:p>
         </p:txBody>
@@ -11605,7 +11605,7 @@
                 </a:solidFill>
                 <a:latin typeface="Arial"/>
               </a:rPr>
-              <a:t>Digging the dark hole: the overnight restart ladder</a:t>
+              <a:t>Inside the dig, station by station</a:t>
             </a:r>
           </a:p>
           <a:p>
@@ -11621,7 +11621,7 @@
                 </a:solidFill>
                 <a:latin typeface="Arial"/>
               </a:rPr>
-              <a:t>1.2×10⁻⁶ → 1.1×10⁻⁹ — three decades from restart scheduling alone; no new hardware, no new physics</a:t>
+              <a:t>Intensity at seven internal planes — the DM commands visibly do the gap work</a:t>
             </a:r>
           </a:p>
         </p:txBody>
@@ -11670,80 +11670,9 @@
           </a:p>
         </p:txBody>
       </p:sp>
-      <p:sp>
-        <p:nvSpPr>
-          <p:cNvPr id="4" name="TextBox 3"/>
-          <p:cNvSpPr txBox="1"/>
-          <p:nvPr/>
-        </p:nvSpPr>
-        <p:spPr>
-          <a:xfrm>
-            <a:off x="411480" y="1298448"/>
-            <a:ext cx="5806440" cy="274320"/>
-          </a:xfrm>
-          <a:prstGeom prst="rect">
-            <a:avLst/>
-          </a:prstGeom>
-          <a:noFill/>
-        </p:spPr>
-        <p:txBody>
-          <a:bodyPr wrap="square">
-            <a:spAutoFit/>
-          </a:bodyPr>
-          <a:lstStyle/>
-          <a:p>
-            <a:pPr>
-              <a:spcAft>
-                <a:spcPts val="600"/>
-              </a:spcAft>
-            </a:pPr>
-            <a:r>
-              <a:rPr sz="1200" b="0">
-                <a:solidFill>
-                  <a:srgbClr val="282828"/>
-                </a:solidFill>
-                <a:latin typeface="Arial"/>
-              </a:rPr>
-              <a:t>•  The recipe: EFC to a floor, relinearize about the dug state, restart at that floor — rinse and repeat.  Ten digging rounds, ~4 h unattended, on the d = 1.10 m two-DM variant — the spacing study's best linear substrate; three stall rounds then prove the plateau.</a:t>
-            </a:r>
-          </a:p>
-          <a:p>
-            <a:pPr>
-              <a:spcAft>
-                <a:spcPts val="600"/>
-              </a:spcAft>
-            </a:pPr>
-            <a:r>
-              <a:rPr sz="1200" b="0">
-                <a:solidFill>
-                  <a:srgbClr val="282828"/>
-                </a:solidFill>
-                <a:latin typeface="Arial"/>
-              </a:rPr>
-              <a:t>•  The controller was the bottleneck, measured: a single linearization stalls at 9.0×10⁻⁷; every restart bought another step down.  DM strokes end at 33 nm rms, well inside the 50 nm budget.</a:t>
-            </a:r>
-          </a:p>
-          <a:p>
-            <a:pPr>
-              <a:spcAft>
-                <a:spcPts val="600"/>
-              </a:spcAft>
-            </a:pPr>
-            <a:r>
-              <a:rPr sz="1200" b="0">
-                <a:solidFill>
-                  <a:srgbClr val="282828"/>
-                </a:solidFill>
-                <a:latin typeface="Arial"/>
-              </a:rPr>
-              <a:t>•  The remaining 1.5 decades are priced: re-measured at every dug state, the linear-achievable floor holds at 2–4×10⁻¹¹ — HWO-class 5×10⁻¹¹ is within this substrate's reach.  The plateau at 1.1×10⁻⁹ is the monotone Tikhonov step rule: the measured case for FALCO-grade step control on this same model.</a:t>
-            </a:r>
-          </a:p>
-        </p:txBody>
-      </p:sp>
       <p:pic>
         <p:nvPicPr>
-          <p:cNvPr id="5" name="Picture 4" descr="fig_cf3d_ladder.png"/>
+          <p:cNvPr id="4" name="Picture 3" descr="fig_cf3d_stations_wide.png"/>
           <p:cNvPicPr>
             <a:picLocks noChangeAspect="1"/>
           </p:cNvPicPr>
@@ -11757,8 +11686,8 @@
         </p:blipFill>
         <p:spPr>
           <a:xfrm>
-            <a:off x="6400800" y="1298448"/>
-            <a:ext cx="5394960" cy="3637305"/>
+            <a:off x="1544429" y="1298448"/>
+            <a:ext cx="9102837" cy="2257552"/>
           </a:xfrm>
           <a:prstGeom prst="rect">
             <a:avLst/>
@@ -11767,14 +11696,14 @@
       </p:pic>
       <p:sp>
         <p:nvSpPr>
-          <p:cNvPr id="6" name="TextBox 5"/>
+          <p:cNvPr id="5" name="TextBox 4"/>
           <p:cNvSpPr txBox="1"/>
           <p:nvPr/>
         </p:nvSpPr>
         <p:spPr>
           <a:xfrm>
-            <a:off x="6400800" y="4954041"/>
-            <a:ext cx="5394960" cy="394208"/>
+            <a:off x="411480" y="3574288"/>
+            <a:ext cx="11368735" cy="394208"/>
           </a:xfrm>
           <a:prstGeom prst="rect">
             <a:avLst/>
@@ -11799,21 +11728,21 @@
                 </a:solidFill>
                 <a:latin typeface="Arial"/>
               </a:rPr>
-              <a:t>The ladder: measured dark-zone floor by restart round, with the linear-achievable substrate re-measured at every dug state.</a:t>
-            </a:r>
-          </a:p>
-        </p:txBody>
-      </p:sp>
-      <p:sp>
-        <p:nvSpPr>
-          <p:cNvPr id="7" name="TextBox 6"/>
+              <a:t>Seven planes, DMs flat (top row) against the dug state (bottom): pupil, apodizer, focal plane before and after the occulter, Lyot plane before and after the stop, science-plane contrast.  The dug row ends in the full 3–15 λ/D annular dark hole at the 10⁻⁹ floor; the in-walk dark-zone means reproduce the scored record exactly.</a:t>
+            </a:r>
+          </a:p>
+        </p:txBody>
+      </p:sp>
+      <p:sp>
+        <p:nvSpPr>
+          <p:cNvPr id="6" name="TextBox 5"/>
           <p:cNvSpPr txBox="1"/>
           <p:nvPr/>
         </p:nvSpPr>
         <p:spPr>
           <a:xfrm>
-            <a:off x="6400800" y="5384825"/>
-            <a:ext cx="5394960" cy="274320"/>
+            <a:off x="411480" y="4005072"/>
+            <a:ext cx="11368735" cy="274320"/>
           </a:xfrm>
           <a:prstGeom prst="rect">
             <a:avLst/>
@@ -11832,13 +11761,92 @@
               </a:spcAft>
             </a:pPr>
             <a:r>
+              <a:rPr sz="1500" b="0">
+                <a:solidFill>
+                  <a:srgbClr val="282828"/>
+                </a:solidFill>
+                <a:latin typeface="Arial"/>
+              </a:rPr>
+              <a:t>•  DM1's command map imprints the hex-gap lattice — the controller is doing the gap-and-edge work the apodizer was bought for, actuator by actuator, at 33 nm rms; a no-apodizer A/B to price the throughput trade is the scoped follow-on.</a:t>
+            </a:r>
+          </a:p>
+          <a:p>
+            <a:pPr>
+              <a:spcAft>
+                <a:spcPts val="600"/>
+              </a:spcAft>
+            </a:pPr>
+            <a:r>
+              <a:rPr sz="1500" b="0">
+                <a:solidFill>
+                  <a:srgbClr val="282828"/>
+                </a:solidFill>
+                <a:latin typeface="Arial"/>
+              </a:rPr>
+              <a:t>•  The 0.90 Lyot stop removes only ~0.1% of the post-occulter energy — this train's rejected light is interior gap structure, not edge rings, so the Lyot radius is not where the suppression happens.</a:t>
+            </a:r>
+          </a:p>
+        </p:txBody>
+      </p:sp>
+      <p:pic>
+        <p:nvPicPr>
+          <p:cNvPr id="7" name="Picture 6" descr="fig_cf3d_dm_state.png"/>
+          <p:cNvPicPr>
+            <a:picLocks noChangeAspect="1"/>
+          </p:cNvPicPr>
+          <p:nvPr/>
+        </p:nvPicPr>
+        <p:blipFill>
+          <a:blip r:embed="rId3"/>
+          <a:stretch>
+            <a:fillRect/>
+          </a:stretch>
+        </p:blipFill>
+        <p:spPr>
+          <a:xfrm>
+            <a:off x="4763617" y="5312664"/>
+            <a:ext cx="2664460" cy="1188720"/>
+          </a:xfrm>
+          <a:prstGeom prst="rect">
+            <a:avLst/>
+          </a:prstGeom>
+        </p:spPr>
+      </p:pic>
+      <p:sp>
+        <p:nvSpPr>
+          <p:cNvPr id="8" name="TextBox 7"/>
+          <p:cNvSpPr txBox="1"/>
+          <p:nvPr/>
+        </p:nvSpPr>
+        <p:spPr>
+          <a:xfrm>
+            <a:off x="411480" y="6501384"/>
+            <a:ext cx="11368735" cy="274320"/>
+          </a:xfrm>
+          <a:prstGeom prst="rect">
+            <a:avLst/>
+          </a:prstGeom>
+          <a:noFill/>
+        </p:spPr>
+        <p:txBody>
+          <a:bodyPr wrap="square">
+            <a:spAutoFit/>
+          </a:bodyPr>
+          <a:lstStyle/>
+          <a:p>
+            <a:pPr>
+              <a:spcAft>
+                <a:spcPts val="600"/>
+              </a:spcAft>
+            </a:pPr>
+            <a:r>
               <a:rPr sz="1050" b="0">
                 <a:solidFill>
                   <a:srgbClr val="6E6E6E"/>
                 </a:solidFill>
                 <a:latin typeface="Arial"/>
               </a:rPr>
-              <a:t>Record: templates/80_end_to_end/e2e6m_r2, CF3d stage — checkpointed and resumable; every round is a finished floor.</a:t>
+              <a:t>The CTB documentation model — intensity at key planes, compact-vs-full — applied to the observatory train: same station layout, the two columns now DMs-flat vs dug.</a:t>
             </a:r>
           </a:p>
         </p:txBody>
@@ -11895,7 +11903,7 @@
                 </a:solidFill>
                 <a:latin typeface="Arial"/>
               </a:rPr>
-              <a:t>Inside the dig, station by station</a:t>
+              <a:t>A randomly disturbed observatory, simulated</a:t>
             </a:r>
           </a:p>
           <a:p>
@@ -11911,7 +11919,7 @@
                 </a:solidFill>
                 <a:latin typeface="Arial"/>
               </a:rPr>
-              <a:t>Intensity at seven internal planes — the DM commands visibly do the gap work</a:t>
+              <a:t>JWST-class drift on the dug dark hole: open loop decays 4.5 decades in a day — the loop holds 2×10⁻⁹</a:t>
             </a:r>
           </a:p>
         </p:txBody>
@@ -11960,9 +11968,96 @@
           </a:p>
         </p:txBody>
       </p:sp>
+      <p:sp>
+        <p:nvSpPr>
+          <p:cNvPr id="4" name="TextBox 3"/>
+          <p:cNvSpPr txBox="1"/>
+          <p:nvPr/>
+        </p:nvSpPr>
+        <p:spPr>
+          <a:xfrm>
+            <a:off x="411480" y="1298448"/>
+            <a:ext cx="5806440" cy="274320"/>
+          </a:xfrm>
+          <a:prstGeom prst="rect">
+            <a:avLst/>
+          </a:prstGeom>
+          <a:noFill/>
+        </p:spPr>
+        <p:txBody>
+          <a:bodyPr wrap="square">
+            <a:spAutoFit/>
+          </a:bodyPr>
+          <a:lstStyle/>
+          <a:p>
+            <a:pPr>
+              <a:spcAft>
+                <a:spcPts val="600"/>
+              </a:spcAft>
+            </a:pPr>
+            <a:r>
+              <a:rPr sz="1200" b="0">
+                <a:solidFill>
+                  <a:srgbClr val="282828"/>
+                </a:solidFill>
+                <a:latin typeface="Arial"/>
+              </a:rPr>
+              <a:t>•  The series starts at the new solution — frame one reproduces the dug floor (1.134 vs 1.133×10⁻⁹, a built-in gate) — and runs a JWST-experience disturbance: a 10 nm/hr correlated drift ramp plus a 0.5 nm-per-step walk, 24 hours at 30-minute frames.</a:t>
+            </a:r>
+          </a:p>
+          <a:p>
+            <a:pPr>
+              <a:spcAft>
+                <a:spcPts val="600"/>
+              </a:spcAft>
+            </a:pPr>
+            <a:r>
+              <a:rPr sz="1200" b="0">
+                <a:solidFill>
+                  <a:srgbClr val="282828"/>
+                </a:solidFill>
+                <a:latin typeface="Arial"/>
+              </a:rPr>
+              <a:t>•  Open loop, DMs frozen at the dug state: 1.1×10⁻⁹ → 3.9×10⁻⁵.  The first decade is lost to the first nanometre of drift — at 10⁻⁹, continuous control is not optional.</a:t>
+            </a:r>
+          </a:p>
+          <a:p>
+            <a:pPr>
+              <a:spcAft>
+                <a:spcPts val="600"/>
+              </a:spcAft>
+            </a:pPr>
+            <a:r>
+              <a:rPr sz="1200" b="0">
+                <a:solidFill>
+                  <a:srgbClr val="282828"/>
+                </a:solidFill>
+                <a:latin typeface="Arial"/>
+              </a:rPr>
+              <a:t>•  Closed loop: the rigid-body loop senses through the designed metrology and holds the segment state at 1.2 nm against 23 nm of accumulated drift; a guarded EFC hold — one damped step per hour about the dug-state Jacobian, 25 steps taken, none reverted — keeps the dark zone at ~2×10⁻⁹ for the full day.</a:t>
+            </a:r>
+          </a:p>
+          <a:p>
+            <a:pPr>
+              <a:spcAft>
+                <a:spcPts val="600"/>
+              </a:spcAft>
+            </a:pPr>
+            <a:r>
+              <a:rPr sz="1200" b="0">
+                <a:solidFill>
+                  <a:srgbClr val="282828"/>
+                </a:solidFill>
+                <a:latin typeface="Arial"/>
+              </a:rPr>
+              <a:t>•  The disturbance interface is the point: the same channels ingest dynamical- and thermal-model time histories — simulating performance in the space environment.</a:t>
+            </a:r>
+          </a:p>
+        </p:txBody>
+      </p:sp>
       <p:pic>
         <p:nvPicPr>
-          <p:cNvPr id="4" name="Picture 3" descr="fig_cf3d_stations_wide.png"/>
+          <p:cNvPr id="5" name="Picture 4" descr="fig_cf5b_jwst.png"/>
           <p:cNvPicPr>
             <a:picLocks noChangeAspect="1"/>
           </p:cNvPicPr>
@@ -11976,8 +12071,8 @@
         </p:blipFill>
         <p:spPr>
           <a:xfrm>
-            <a:off x="1544429" y="1298448"/>
-            <a:ext cx="9102837" cy="2257552"/>
+            <a:off x="7029688" y="1298448"/>
+            <a:ext cx="4137183" cy="4012692"/>
           </a:xfrm>
           <a:prstGeom prst="rect">
             <a:avLst/>
@@ -11986,14 +12081,14 @@
       </p:pic>
       <p:sp>
         <p:nvSpPr>
-          <p:cNvPr id="5" name="TextBox 4"/>
+          <p:cNvPr id="6" name="TextBox 5"/>
           <p:cNvSpPr txBox="1"/>
           <p:nvPr/>
         </p:nvSpPr>
         <p:spPr>
           <a:xfrm>
-            <a:off x="411480" y="3574288"/>
-            <a:ext cx="11368735" cy="394208"/>
+            <a:off x="6400800" y="5329428"/>
+            <a:ext cx="5394960" cy="559307"/>
           </a:xfrm>
           <a:prstGeom prst="rect">
             <a:avLst/>
@@ -12018,21 +12113,21 @@
                 </a:solidFill>
                 <a:latin typeface="Arial"/>
               </a:rPr>
-              <a:t>Seven planes, DMs flat (top row) against the dug state (bottom): pupil, apodizer, focal plane before and after the occulter, Lyot plane before and after the stop, science-plane contrast.  The dug row ends in the full 3–15 λ/D annular dark hole at the 10⁻⁹ floor; the in-walk dark-zone means reproduce the scored record exactly.</a:t>
-            </a:r>
-          </a:p>
-        </p:txBody>
-      </p:sp>
-      <p:sp>
-        <p:nvSpPr>
-          <p:cNvPr id="6" name="TextBox 5"/>
+              <a:t>Twenty-four hours under JWST-class drift, both passes starting from the dug dark hole: segment rigid-body state, exit-pupil wavefront, and science-plane contrast — open loop against closed.</a:t>
+            </a:r>
+          </a:p>
+        </p:txBody>
+      </p:sp>
+      <p:sp>
+        <p:nvSpPr>
+          <p:cNvPr id="7" name="TextBox 6"/>
           <p:cNvSpPr txBox="1"/>
           <p:nvPr/>
         </p:nvSpPr>
         <p:spPr>
           <a:xfrm>
-            <a:off x="411480" y="4005072"/>
-            <a:ext cx="11368735" cy="274320"/>
+            <a:off x="6400800" y="5925312"/>
+            <a:ext cx="5394960" cy="274320"/>
           </a:xfrm>
           <a:prstGeom prst="rect">
             <a:avLst/>
@@ -12051,92 +12146,13 @@
               </a:spcAft>
             </a:pPr>
             <a:r>
-              <a:rPr sz="1500" b="0">
-                <a:solidFill>
-                  <a:srgbClr val="282828"/>
-                </a:solidFill>
-                <a:latin typeface="Arial"/>
-              </a:rPr>
-              <a:t>•  DM1's command map imprints the hex-gap lattice — the controller is doing the gap-and-edge work the apodizer was bought for, actuator by actuator, at 33 nm rms; a no-apodizer A/B to price the throughput trade is the scoped follow-on.</a:t>
-            </a:r>
-          </a:p>
-          <a:p>
-            <a:pPr>
-              <a:spcAft>
-                <a:spcPts val="600"/>
-              </a:spcAft>
-            </a:pPr>
-            <a:r>
-              <a:rPr sz="1500" b="0">
-                <a:solidFill>
-                  <a:srgbClr val="282828"/>
-                </a:solidFill>
-                <a:latin typeface="Arial"/>
-              </a:rPr>
-              <a:t>•  The 0.90 Lyot stop removes only ~0.1% of the post-occulter energy — this train's rejected light is interior gap structure, not edge rings, so the Lyot radius is not where the suppression happens.</a:t>
-            </a:r>
-          </a:p>
-        </p:txBody>
-      </p:sp>
-      <p:pic>
-        <p:nvPicPr>
-          <p:cNvPr id="7" name="Picture 6" descr="fig_cf3d_dm_state.png"/>
-          <p:cNvPicPr>
-            <a:picLocks noChangeAspect="1"/>
-          </p:cNvPicPr>
-          <p:nvPr/>
-        </p:nvPicPr>
-        <p:blipFill>
-          <a:blip r:embed="rId3"/>
-          <a:stretch>
-            <a:fillRect/>
-          </a:stretch>
-        </p:blipFill>
-        <p:spPr>
-          <a:xfrm>
-            <a:off x="4763617" y="5312664"/>
-            <a:ext cx="2664460" cy="1188720"/>
-          </a:xfrm>
-          <a:prstGeom prst="rect">
-            <a:avLst/>
-          </a:prstGeom>
-        </p:spPr>
-      </p:pic>
-      <p:sp>
-        <p:nvSpPr>
-          <p:cNvPr id="8" name="TextBox 7"/>
-          <p:cNvSpPr txBox="1"/>
-          <p:nvPr/>
-        </p:nvSpPr>
-        <p:spPr>
-          <a:xfrm>
-            <a:off x="411480" y="6501384"/>
-            <a:ext cx="11368735" cy="274320"/>
-          </a:xfrm>
-          <a:prstGeom prst="rect">
-            <a:avLst/>
-          </a:prstGeom>
-          <a:noFill/>
-        </p:spPr>
-        <p:txBody>
-          <a:bodyPr wrap="square">
-            <a:spAutoFit/>
-          </a:bodyPr>
-          <a:lstStyle/>
-          <a:p>
-            <a:pPr>
-              <a:spcAft>
-                <a:spcPts val="600"/>
-              </a:spcAft>
-            </a:pPr>
-            <a:r>
               <a:rPr sz="1050" b="0">
                 <a:solidFill>
                   <a:srgbClr val="6E6E6E"/>
                 </a:solidFill>
                 <a:latin typeface="Arial"/>
               </a:rPr>
-              <a:t>The CTB documentation model — intensity at key planes, compact-vs-full — applied to the observatory train: same station layout, the two columns now DMs-flat vs dug.</a:t>
+              <a:t>Record: templates/80_end_to_end/e2e6m_r2, CF5b stage — d=1.10 deck, G = the ladder's dug-state Jacobian.</a:t>
             </a:r>
           </a:p>
         </p:txBody>

</xml_diff>

<commit_message>
deck: slide-5 reproduction row aligned to the record-sourced detail slides (CCMac's citation hunt)
C1 0.83-1.11x (unsourced) -> 0.991-1.003x (slide-10 re-trace range);
C3 0.99-1.10x -> 0.8-1.25x (slide 6's committed claim incl. the 0.86x
final step).  Edit-deck sync HELD (Impress lock).

Co-Authored-By: Claude Fable 5 <noreply@anthropic.com>
</commit_message>
<xml_diff>
--- a/demo_session/deck_keysight.pptx
+++ b/demo_session/deck_keysight.pptx
@@ -17566,7 +17566,7 @@
                           </a:solidFill>
                           <a:latin typeface="Arial"/>
                         </a:rPr>
-                        <a:t>0.83–1.11×</a:t>
+                        <a:t>0.991–1.003×</a:t>
                       </a:r>
                     </a:p>
                   </a:txBody>
@@ -17610,7 +17610,7 @@
                           </a:solidFill>
                           <a:latin typeface="Arial"/>
                         </a:rPr>
-                        <a:t>0.99–1.10× (all five steps)</a:t>
+                        <a:t>0.8–1.25× (all five steps)</a:t>
                       </a:r>
                     </a:p>
                   </a:txBody>

</xml_diff>

<commit_message>
deck: slide 32 reworked per Dave -- design questions first (basins, merit scaling), conventions concretized as a macro/API ask, coronagraph merged and last
Co-Authored-By: Claude Fable 5 <noreply@anthropic.com>
</commit_message>
<xml_diff>
--- a/demo_session/deck_keysight.pptx
+++ b/demo_session/deck_keysight.pptx
@@ -13094,7 +13094,7 @@
                 </a:solidFill>
                 <a:latin typeface="Arial"/>
               </a:rPr>
-              <a:t>•  To the coronagraph builders: our EFC restart ladder walled at 1.1×10⁻⁹ while the measured linear substrate priced 3.5×10⁻¹¹ — the binding element was the monotone Tikhonov step rule, not the optics.  What buys your last decade and a half — β-bump schedules, per-mode regularization, constrained strokes — and at 10⁻¹⁰-class floors, what breaks first: the linear model, the strokes, or the estimate?</a:t>
+              <a:t>•  On the afocal family: the interface-pupil condition consumes the last two mirror powers — we priced it at 2.7× of wavefront — and field curvature owns 60–99.7% of every design's wavefront variance.  Is that pupil requirement held this hard in shipped practice, and is a strongly curved opposite-sign corrector in the compressed beam near the exit a move you have seen work?</a:t>
             </a:r>
           </a:p>
           <a:p>
@@ -13110,7 +13110,7 @@
                 </a:solidFill>
                 <a:latin typeface="Arial"/>
               </a:rPr>
-              <a:t>•  Also yours: last night we measured that the apodizer's real purchase is stroke economy — the same 10⁻¹¹-class substrate costs ~33 nm rms of DM stroke apodized and microns bare, at 8× the throughput.  Do amplitude-shaping solutions at micron-class strokes survive contact with real DMs?</a:t>
+              <a:t>•  On basins: our solvers never left the basin they were seeded in — a cold start lost to a warm one by 8500×, and rigid bodies offered ±15° of freedom used 0.9° (the off-axis family had to be seeded, not perturbed into).  When does your practice reach for a genuinely new starting geometry rather than a better step — and do designers trust automated global search to make that call?</a:t>
             </a:r>
           </a:p>
           <a:p>
@@ -13126,7 +13126,7 @@
                 </a:solidFill>
                 <a:latin typeface="Arial"/>
               </a:rPr>
-              <a:t>•  To the designers: in the 30× afocal study, the interface-pupil condition consumes the last two mirror powers — we priced it at 2.7× of wavefront at the delivered standoff — and field curvature owns 60–99.7% of every design's wavefront variance.  Is that pupil requirement held this hard in shipped practice, and is a strongly curved opposite-sign corrector in the compressed beam near the exit a move you have seen work?</a:t>
+              <a:t>•  On merit functions: a requirement sitting 120× from feasible owns the sum of squares and the other terms cast no vote — we ended in log-domain residuals, and constraint walls applied to iterates, never to reports.  What is your practice for scaling one merit across requirement classes that live decades apart?</a:t>
             </a:r>
           </a:p>
           <a:p>
@@ -13142,7 +13142,23 @@
                 </a:solidFill>
                 <a:latin typeface="Arial"/>
               </a:rPr>
-              <a:t>•  To everyone: the largest defect class I produced in months of this work was conventions — the sign of a radius, which reference sphere a number is quoted against.  What would it take for the industry to ship its conventions as data?</a:t>
+              <a:t>•  On conventions: the largest error class I produced in months of this work was conventions — the sign of a radius, which reference sphere a number is quoted against.  Today those answers live in manuals.  Could the macro/API layer serve them as data — let a program, or an AI, ask the design which convention a number is in, instead of inferring it?</a:t>
+            </a:r>
+          </a:p>
+          <a:p>
+            <a:pPr>
+              <a:spcAft>
+                <a:spcPts val="600"/>
+              </a:spcAft>
+            </a:pPr>
+            <a:r>
+              <a:rPr sz="1500" b="0">
+                <a:solidFill>
+                  <a:srgbClr val="282828"/>
+                </a:solidFill>
+                <a:latin typeface="Arial"/>
+              </a:rPr>
+              <a:t>•  For anyone who has run a testbed: our EFC restart ladder walled at 1.1×10⁻⁹ against a measured 3.5×10⁻¹¹ substrate — the step rule was the binder, not the optics — and the apodizer's real purchase measured as stroke economy: the same substrate costs 33 nm of DM stroke apodized and microns bare, at 8× the throughput.  What buys the last decade in your experience, and do micron-stroke amplitude solutions survive real hardware?</a:t>
             </a:r>
           </a:p>
         </p:txBody>
@@ -13155,7 +13171,7 @@
         </p:nvSpPr>
         <p:spPr>
           <a:xfrm>
-            <a:off x="411480" y="5115306"/>
+            <a:off x="411480" y="6493763"/>
             <a:ext cx="11368735" cy="274320"/>
           </a:xfrm>
           <a:prstGeom prst="rect">

</xml_diff>